<commit_message>
refine pacman ppt slides
</commit_message>
<xml_diff>
--- a/ppt_3pages/pacman_rl_3slides.pptx
+++ b/ppt_3pages/pacman_rl_3slides.pptx
@@ -2619,13 +2619,52 @@
       </p:sp>
       <p:sp>
         <p:nvSpPr>
-          <p:cNvPr id="7" name="Shape 4"/>
-          <p:cNvSpPr/>
-          <p:nvPr/>
-        </p:nvSpPr>
-        <p:spPr>
-          <a:xfrm>
-            <a:off x="640080" y="2240280"/>
+          <p:cNvPr id="7" name="Text 4"/>
+          <p:cNvSpPr/>
+          <p:nvPr/>
+        </p:nvSpPr>
+        <p:spPr>
+          <a:xfrm>
+            <a:off x="640080" y="1993392"/>
+            <a:ext cx="3200400" cy="201168"/>
+          </a:xfrm>
+          <a:prstGeom prst="rect">
+            <a:avLst/>
+          </a:prstGeom>
+          <a:noFill/>
+          <a:ln/>
+        </p:spPr>
+        <p:txBody>
+          <a:bodyPr wrap="square" lIns="0" tIns="0" rIns="0" bIns="0" rtlCol="0" anchor="ctr"/>
+          <a:lstStyle/>
+          <a:p>
+            <a:pPr indent="0" marL="0">
+              <a:buNone/>
+            </a:pPr>
+            <a:r>
+              <a:rPr lang="en-US" sz="1200" b="1" dirty="0">
+                <a:solidFill>
+                  <a:srgbClr val="D8E2EE"/>
+                </a:solidFill>
+                <a:latin typeface="Arial" pitchFamily="34" charset="0"/>
+                <a:ea typeface="Arial" pitchFamily="34" charset="-122"/>
+                <a:cs typeface="Arial" pitchFamily="34" charset="-120"/>
+              </a:rPr>
+              <a:t>Reward and Penalty Design</a:t>
+            </a:r>
+            <a:endParaRPr lang="en-US" sz="1200" dirty="0"/>
+          </a:p>
+        </p:txBody>
+      </p:sp>
+      <p:sp>
+        <p:nvSpPr>
+          <p:cNvPr id="8" name="Shape 5"/>
+          <p:cNvSpPr/>
+          <p:nvPr/>
+        </p:nvSpPr>
+        <p:spPr>
+          <a:xfrm>
+            <a:off x="640080" y="2322576"/>
             <a:ext cx="1737360" cy="658368"/>
           </a:xfrm>
           <a:prstGeom prst="roundRect">
@@ -2648,13 +2687,13 @@
       </p:sp>
       <p:sp>
         <p:nvSpPr>
-          <p:cNvPr id="8" name="Text 5"/>
-          <p:cNvSpPr/>
-          <p:nvPr/>
-        </p:nvSpPr>
-        <p:spPr>
-          <a:xfrm>
-            <a:off x="777240" y="2350008"/>
+          <p:cNvPr id="9" name="Text 6"/>
+          <p:cNvSpPr/>
+          <p:nvPr/>
+        </p:nvSpPr>
+        <p:spPr>
+          <a:xfrm>
+            <a:off x="777240" y="2432304"/>
             <a:ext cx="1463040" cy="182880"/>
           </a:xfrm>
           <a:prstGeom prst="rect">
@@ -2687,13 +2726,13 @@
       </p:sp>
       <p:sp>
         <p:nvSpPr>
-          <p:cNvPr id="9" name="Text 6"/>
-          <p:cNvSpPr/>
-          <p:nvPr/>
-        </p:nvSpPr>
-        <p:spPr>
-          <a:xfrm>
-            <a:off x="777240" y="2587752"/>
+          <p:cNvPr id="10" name="Text 7"/>
+          <p:cNvSpPr/>
+          <p:nvPr/>
+        </p:nvSpPr>
+        <p:spPr>
+          <a:xfrm>
+            <a:off x="777240" y="2670048"/>
             <a:ext cx="1463040" cy="219456"/>
           </a:xfrm>
           <a:prstGeom prst="rect">
@@ -2726,13 +2765,13 @@
       </p:sp>
       <p:sp>
         <p:nvSpPr>
-          <p:cNvPr id="10" name="Shape 7"/>
-          <p:cNvSpPr/>
-          <p:nvPr/>
-        </p:nvSpPr>
-        <p:spPr>
-          <a:xfrm>
-            <a:off x="2478024" y="2240280"/>
+          <p:cNvPr id="11" name="Shape 8"/>
+          <p:cNvSpPr/>
+          <p:nvPr/>
+        </p:nvSpPr>
+        <p:spPr>
+          <a:xfrm>
+            <a:off x="2478024" y="2322576"/>
             <a:ext cx="1737360" cy="658368"/>
           </a:xfrm>
           <a:prstGeom prst="roundRect">
@@ -2755,13 +2794,13 @@
       </p:sp>
       <p:sp>
         <p:nvSpPr>
-          <p:cNvPr id="11" name="Text 8"/>
-          <p:cNvSpPr/>
-          <p:nvPr/>
-        </p:nvSpPr>
-        <p:spPr>
-          <a:xfrm>
-            <a:off x="2615184" y="2350008"/>
+          <p:cNvPr id="12" name="Text 9"/>
+          <p:cNvSpPr/>
+          <p:nvPr/>
+        </p:nvSpPr>
+        <p:spPr>
+          <a:xfrm>
+            <a:off x="2615184" y="2432304"/>
             <a:ext cx="1463040" cy="182880"/>
           </a:xfrm>
           <a:prstGeom prst="rect">
@@ -2794,13 +2833,13 @@
       </p:sp>
       <p:sp>
         <p:nvSpPr>
-          <p:cNvPr id="12" name="Text 9"/>
-          <p:cNvSpPr/>
-          <p:nvPr/>
-        </p:nvSpPr>
-        <p:spPr>
-          <a:xfrm>
-            <a:off x="2615184" y="2587752"/>
+          <p:cNvPr id="13" name="Text 10"/>
+          <p:cNvSpPr/>
+          <p:nvPr/>
+        </p:nvSpPr>
+        <p:spPr>
+          <a:xfrm>
+            <a:off x="2615184" y="2670048"/>
             <a:ext cx="1463040" cy="219456"/>
           </a:xfrm>
           <a:prstGeom prst="rect">
@@ -2833,13 +2872,13 @@
       </p:sp>
       <p:sp>
         <p:nvSpPr>
-          <p:cNvPr id="13" name="Shape 10"/>
-          <p:cNvSpPr/>
-          <p:nvPr/>
-        </p:nvSpPr>
-        <p:spPr>
-          <a:xfrm>
-            <a:off x="4315968" y="2240280"/>
+          <p:cNvPr id="14" name="Shape 11"/>
+          <p:cNvSpPr/>
+          <p:nvPr/>
+        </p:nvSpPr>
+        <p:spPr>
+          <a:xfrm>
+            <a:off x="4315968" y="2322576"/>
             <a:ext cx="1737360" cy="658368"/>
           </a:xfrm>
           <a:prstGeom prst="roundRect">
@@ -2862,13 +2901,13 @@
       </p:sp>
       <p:sp>
         <p:nvSpPr>
-          <p:cNvPr id="14" name="Text 11"/>
-          <p:cNvSpPr/>
-          <p:nvPr/>
-        </p:nvSpPr>
-        <p:spPr>
-          <a:xfrm>
-            <a:off x="4453128" y="2350008"/>
+          <p:cNvPr id="15" name="Text 12"/>
+          <p:cNvSpPr/>
+          <p:nvPr/>
+        </p:nvSpPr>
+        <p:spPr>
+          <a:xfrm>
+            <a:off x="4453128" y="2432304"/>
             <a:ext cx="1463040" cy="182880"/>
           </a:xfrm>
           <a:prstGeom prst="rect">
@@ -2901,13 +2940,13 @@
       </p:sp>
       <p:sp>
         <p:nvSpPr>
-          <p:cNvPr id="15" name="Text 12"/>
-          <p:cNvSpPr/>
-          <p:nvPr/>
-        </p:nvSpPr>
-        <p:spPr>
-          <a:xfrm>
-            <a:off x="4453128" y="2587752"/>
+          <p:cNvPr id="16" name="Text 13"/>
+          <p:cNvSpPr/>
+          <p:nvPr/>
+        </p:nvSpPr>
+        <p:spPr>
+          <a:xfrm>
+            <a:off x="4453128" y="2670048"/>
             <a:ext cx="1463040" cy="219456"/>
           </a:xfrm>
           <a:prstGeom prst="rect">
@@ -2940,13 +2979,13 @@
       </p:sp>
       <p:sp>
         <p:nvSpPr>
-          <p:cNvPr id="16" name="Shape 13"/>
-          <p:cNvSpPr/>
-          <p:nvPr/>
-        </p:nvSpPr>
-        <p:spPr>
-          <a:xfrm>
-            <a:off x="6153912" y="2240280"/>
+          <p:cNvPr id="17" name="Shape 14"/>
+          <p:cNvSpPr/>
+          <p:nvPr/>
+        </p:nvSpPr>
+        <p:spPr>
+          <a:xfrm>
+            <a:off x="6153912" y="2322576"/>
             <a:ext cx="1737360" cy="658368"/>
           </a:xfrm>
           <a:prstGeom prst="roundRect">
@@ -2969,13 +3008,13 @@
       </p:sp>
       <p:sp>
         <p:nvSpPr>
-          <p:cNvPr id="17" name="Text 14"/>
-          <p:cNvSpPr/>
-          <p:nvPr/>
-        </p:nvSpPr>
-        <p:spPr>
-          <a:xfrm>
-            <a:off x="6291072" y="2350008"/>
+          <p:cNvPr id="18" name="Text 15"/>
+          <p:cNvSpPr/>
+          <p:nvPr/>
+        </p:nvSpPr>
+        <p:spPr>
+          <a:xfrm>
+            <a:off x="6291072" y="2432304"/>
             <a:ext cx="1463040" cy="182880"/>
           </a:xfrm>
           <a:prstGeom prst="rect">
@@ -3008,13 +3047,13 @@
       </p:sp>
       <p:sp>
         <p:nvSpPr>
-          <p:cNvPr id="18" name="Text 15"/>
-          <p:cNvSpPr/>
-          <p:nvPr/>
-        </p:nvSpPr>
-        <p:spPr>
-          <a:xfrm>
-            <a:off x="6291072" y="2587752"/>
+          <p:cNvPr id="19" name="Text 16"/>
+          <p:cNvSpPr/>
+          <p:nvPr/>
+        </p:nvSpPr>
+        <p:spPr>
+          <a:xfrm>
+            <a:off x="6291072" y="2670048"/>
             <a:ext cx="1463040" cy="219456"/>
           </a:xfrm>
           <a:prstGeom prst="rect">
@@ -3047,13 +3086,13 @@
       </p:sp>
       <p:sp>
         <p:nvSpPr>
-          <p:cNvPr id="19" name="Shape 16"/>
-          <p:cNvSpPr/>
-          <p:nvPr/>
-        </p:nvSpPr>
-        <p:spPr>
-          <a:xfrm>
-            <a:off x="7991856" y="2240280"/>
+          <p:cNvPr id="20" name="Shape 17"/>
+          <p:cNvSpPr/>
+          <p:nvPr/>
+        </p:nvSpPr>
+        <p:spPr>
+          <a:xfrm>
+            <a:off x="7991856" y="2322576"/>
             <a:ext cx="1737360" cy="658368"/>
           </a:xfrm>
           <a:prstGeom prst="roundRect">
@@ -3076,13 +3115,13 @@
       </p:sp>
       <p:sp>
         <p:nvSpPr>
-          <p:cNvPr id="20" name="Text 17"/>
-          <p:cNvSpPr/>
-          <p:nvPr/>
-        </p:nvSpPr>
-        <p:spPr>
-          <a:xfrm>
-            <a:off x="8129016" y="2350008"/>
+          <p:cNvPr id="21" name="Text 18"/>
+          <p:cNvSpPr/>
+          <p:nvPr/>
+        </p:nvSpPr>
+        <p:spPr>
+          <a:xfrm>
+            <a:off x="8129016" y="2432304"/>
             <a:ext cx="1463040" cy="182880"/>
           </a:xfrm>
           <a:prstGeom prst="rect">
@@ -3115,13 +3154,13 @@
       </p:sp>
       <p:sp>
         <p:nvSpPr>
-          <p:cNvPr id="21" name="Text 18"/>
-          <p:cNvSpPr/>
-          <p:nvPr/>
-        </p:nvSpPr>
-        <p:spPr>
-          <a:xfrm>
-            <a:off x="8129016" y="2587752"/>
+          <p:cNvPr id="22" name="Text 19"/>
+          <p:cNvSpPr/>
+          <p:nvPr/>
+        </p:nvSpPr>
+        <p:spPr>
+          <a:xfrm>
+            <a:off x="8129016" y="2670048"/>
             <a:ext cx="1463040" cy="219456"/>
           </a:xfrm>
           <a:prstGeom prst="rect">
@@ -3154,13 +3193,13 @@
       </p:sp>
       <p:sp>
         <p:nvSpPr>
-          <p:cNvPr id="22" name="Shape 19"/>
-          <p:cNvSpPr/>
-          <p:nvPr/>
-        </p:nvSpPr>
-        <p:spPr>
-          <a:xfrm>
-            <a:off x="9829800" y="2240280"/>
+          <p:cNvPr id="23" name="Shape 20"/>
+          <p:cNvSpPr/>
+          <p:nvPr/>
+        </p:nvSpPr>
+        <p:spPr>
+          <a:xfrm>
+            <a:off x="9829800" y="2322576"/>
             <a:ext cx="1737360" cy="658368"/>
           </a:xfrm>
           <a:prstGeom prst="roundRect">
@@ -3183,13 +3222,13 @@
       </p:sp>
       <p:sp>
         <p:nvSpPr>
-          <p:cNvPr id="23" name="Text 20"/>
-          <p:cNvSpPr/>
-          <p:nvPr/>
-        </p:nvSpPr>
-        <p:spPr>
-          <a:xfrm>
-            <a:off x="9966960" y="2350008"/>
+          <p:cNvPr id="24" name="Text 21"/>
+          <p:cNvSpPr/>
+          <p:nvPr/>
+        </p:nvSpPr>
+        <p:spPr>
+          <a:xfrm>
+            <a:off x="9966960" y="2432304"/>
             <a:ext cx="1463040" cy="182880"/>
           </a:xfrm>
           <a:prstGeom prst="rect">
@@ -3222,13 +3261,13 @@
       </p:sp>
       <p:sp>
         <p:nvSpPr>
-          <p:cNvPr id="24" name="Text 21"/>
-          <p:cNvSpPr/>
-          <p:nvPr/>
-        </p:nvSpPr>
-        <p:spPr>
-          <a:xfrm>
-            <a:off x="9966960" y="2587752"/>
+          <p:cNvPr id="25" name="Text 22"/>
+          <p:cNvSpPr/>
+          <p:nvPr/>
+        </p:nvSpPr>
+        <p:spPr>
+          <a:xfrm>
+            <a:off x="9966960" y="2670048"/>
             <a:ext cx="1463040" cy="219456"/>
           </a:xfrm>
           <a:prstGeom prst="rect">
@@ -3261,13 +3300,13 @@
       </p:sp>
       <p:sp>
         <p:nvSpPr>
-          <p:cNvPr id="25" name="Shape 22"/>
-          <p:cNvSpPr/>
-          <p:nvPr/>
-        </p:nvSpPr>
-        <p:spPr>
-          <a:xfrm>
-            <a:off x="640080" y="3154680"/>
+          <p:cNvPr id="26" name="Shape 23"/>
+          <p:cNvSpPr/>
+          <p:nvPr/>
+        </p:nvSpPr>
+        <p:spPr>
+          <a:xfrm>
+            <a:off x="640080" y="3255264"/>
             <a:ext cx="3456432" cy="2267712"/>
           </a:xfrm>
           <a:prstGeom prst="roundRect">
@@ -3290,13 +3329,13 @@
       </p:sp>
       <p:sp>
         <p:nvSpPr>
-          <p:cNvPr id="26" name="Text 23"/>
-          <p:cNvSpPr/>
-          <p:nvPr/>
-        </p:nvSpPr>
-        <p:spPr>
-          <a:xfrm>
-            <a:off x="868680" y="3355848"/>
+          <p:cNvPr id="27" name="Text 24"/>
+          <p:cNvSpPr/>
+          <p:nvPr/>
+        </p:nvSpPr>
+        <p:spPr>
+          <a:xfrm>
+            <a:off x="868680" y="3456432"/>
             <a:ext cx="2999232" cy="274320"/>
           </a:xfrm>
           <a:prstGeom prst="rect">
@@ -3329,13 +3368,13 @@
       </p:sp>
       <p:sp>
         <p:nvSpPr>
-          <p:cNvPr id="27" name="Shape 24"/>
-          <p:cNvSpPr/>
-          <p:nvPr/>
-        </p:nvSpPr>
-        <p:spPr>
-          <a:xfrm>
-            <a:off x="868680" y="3721608"/>
+          <p:cNvPr id="28" name="Shape 25"/>
+          <p:cNvSpPr/>
+          <p:nvPr/>
+        </p:nvSpPr>
+        <p:spPr>
+          <a:xfrm>
+            <a:off x="868680" y="3822192"/>
             <a:ext cx="2999232" cy="0"/>
           </a:xfrm>
           <a:prstGeom prst="line">
@@ -3354,13 +3393,13 @@
       </p:sp>
       <p:sp>
         <p:nvSpPr>
-          <p:cNvPr id="28" name="Text 25"/>
-          <p:cNvSpPr/>
-          <p:nvPr/>
-        </p:nvSpPr>
-        <p:spPr>
-          <a:xfrm>
-            <a:off x="868680" y="3904488"/>
+          <p:cNvPr id="29" name="Text 26"/>
+          <p:cNvSpPr/>
+          <p:nvPr/>
+        </p:nvSpPr>
+        <p:spPr>
+          <a:xfrm>
+            <a:off x="868680" y="4005072"/>
             <a:ext cx="2999232" cy="1335024"/>
           </a:xfrm>
           <a:prstGeom prst="rect">
@@ -3444,13 +3483,13 @@
       </p:sp>
       <p:sp>
         <p:nvSpPr>
-          <p:cNvPr id="29" name="Shape 26"/>
-          <p:cNvSpPr/>
-          <p:nvPr/>
-        </p:nvSpPr>
-        <p:spPr>
-          <a:xfrm>
-            <a:off x="4370832" y="3154680"/>
+          <p:cNvPr id="30" name="Shape 27"/>
+          <p:cNvSpPr/>
+          <p:nvPr/>
+        </p:nvSpPr>
+        <p:spPr>
+          <a:xfrm>
+            <a:off x="4370832" y="3255264"/>
             <a:ext cx="3456432" cy="2267712"/>
           </a:xfrm>
           <a:prstGeom prst="roundRect">
@@ -3473,13 +3512,13 @@
       </p:sp>
       <p:sp>
         <p:nvSpPr>
-          <p:cNvPr id="30" name="Text 27"/>
-          <p:cNvSpPr/>
-          <p:nvPr/>
-        </p:nvSpPr>
-        <p:spPr>
-          <a:xfrm>
-            <a:off x="4599432" y="3355848"/>
+          <p:cNvPr id="31" name="Text 28"/>
+          <p:cNvSpPr/>
+          <p:nvPr/>
+        </p:nvSpPr>
+        <p:spPr>
+          <a:xfrm>
+            <a:off x="4599432" y="3456432"/>
             <a:ext cx="2999232" cy="274320"/>
           </a:xfrm>
           <a:prstGeom prst="rect">
@@ -3512,13 +3551,13 @@
       </p:sp>
       <p:sp>
         <p:nvSpPr>
-          <p:cNvPr id="31" name="Shape 28"/>
-          <p:cNvSpPr/>
-          <p:nvPr/>
-        </p:nvSpPr>
-        <p:spPr>
-          <a:xfrm>
-            <a:off x="4599432" y="3721608"/>
+          <p:cNvPr id="32" name="Shape 29"/>
+          <p:cNvSpPr/>
+          <p:nvPr/>
+        </p:nvSpPr>
+        <p:spPr>
+          <a:xfrm>
+            <a:off x="4599432" y="3822192"/>
             <a:ext cx="2999232" cy="0"/>
           </a:xfrm>
           <a:prstGeom prst="line">
@@ -3537,13 +3576,13 @@
       </p:sp>
       <p:sp>
         <p:nvSpPr>
-          <p:cNvPr id="32" name="Text 29"/>
-          <p:cNvSpPr/>
-          <p:nvPr/>
-        </p:nvSpPr>
-        <p:spPr>
-          <a:xfrm>
-            <a:off x="4599432" y="3904488"/>
+          <p:cNvPr id="33" name="Text 30"/>
+          <p:cNvSpPr/>
+          <p:nvPr/>
+        </p:nvSpPr>
+        <p:spPr>
+          <a:xfrm>
+            <a:off x="4599432" y="4005072"/>
             <a:ext cx="2999232" cy="1335024"/>
           </a:xfrm>
           <a:prstGeom prst="rect">
@@ -3627,13 +3666,13 @@
       </p:sp>
       <p:sp>
         <p:nvSpPr>
-          <p:cNvPr id="33" name="Shape 30"/>
-          <p:cNvSpPr/>
-          <p:nvPr/>
-        </p:nvSpPr>
-        <p:spPr>
-          <a:xfrm>
-            <a:off x="8110728" y="3154680"/>
+          <p:cNvPr id="34" name="Shape 31"/>
+          <p:cNvSpPr/>
+          <p:nvPr/>
+        </p:nvSpPr>
+        <p:spPr>
+          <a:xfrm>
+            <a:off x="8110728" y="3255264"/>
             <a:ext cx="3456432" cy="2267712"/>
           </a:xfrm>
           <a:prstGeom prst="roundRect">
@@ -3656,13 +3695,13 @@
       </p:sp>
       <p:sp>
         <p:nvSpPr>
-          <p:cNvPr id="34" name="Text 31"/>
-          <p:cNvSpPr/>
-          <p:nvPr/>
-        </p:nvSpPr>
-        <p:spPr>
-          <a:xfrm>
-            <a:off x="8339328" y="3355848"/>
+          <p:cNvPr id="35" name="Text 32"/>
+          <p:cNvSpPr/>
+          <p:nvPr/>
+        </p:nvSpPr>
+        <p:spPr>
+          <a:xfrm>
+            <a:off x="8339328" y="3456432"/>
             <a:ext cx="2999232" cy="274320"/>
           </a:xfrm>
           <a:prstGeom prst="rect">
@@ -3695,13 +3734,13 @@
       </p:sp>
       <p:sp>
         <p:nvSpPr>
-          <p:cNvPr id="35" name="Shape 32"/>
-          <p:cNvSpPr/>
-          <p:nvPr/>
-        </p:nvSpPr>
-        <p:spPr>
-          <a:xfrm>
-            <a:off x="8339328" y="3721608"/>
+          <p:cNvPr id="36" name="Shape 33"/>
+          <p:cNvSpPr/>
+          <p:nvPr/>
+        </p:nvSpPr>
+        <p:spPr>
+          <a:xfrm>
+            <a:off x="8339328" y="3822192"/>
             <a:ext cx="2999232" cy="0"/>
           </a:xfrm>
           <a:prstGeom prst="line">
@@ -3720,13 +3759,13 @@
       </p:sp>
       <p:sp>
         <p:nvSpPr>
-          <p:cNvPr id="36" name="Text 33"/>
-          <p:cNvSpPr/>
-          <p:nvPr/>
-        </p:nvSpPr>
-        <p:spPr>
-          <a:xfrm>
-            <a:off x="8339328" y="3904488"/>
+          <p:cNvPr id="37" name="Text 34"/>
+          <p:cNvSpPr/>
+          <p:nvPr/>
+        </p:nvSpPr>
+        <p:spPr>
+          <a:xfrm>
+            <a:off x="8339328" y="4005072"/>
             <a:ext cx="2999232" cy="1335024"/>
           </a:xfrm>
           <a:prstGeom prst="rect">
@@ -3840,9 +3879,62 @@
           <a:chExt cx="0" cy="0"/>
         </a:xfrm>
       </p:grpSpPr>
-      <p:sp>
-        <p:nvSpPr>
-          <p:cNvPr id="2" name="Text 0"/>
+      <p:pic>
+        <p:nvPicPr>
+          <p:cNvPr id="2" name="Image 0" descr="/Users/fengruiding/Desktop/cs520/project/ppt_3pages/pacman_neon_bg.png">    </p:cNvPr>
+          <p:cNvPicPr>
+            <a:picLocks noChangeAspect="1"/>
+          </p:cNvPicPr>
+          <p:nvPr/>
+        </p:nvPicPr>
+        <p:blipFill>
+          <a:blip r:embed="rId1"/>
+          <a:stretch>
+            <a:fillRect/>
+          </a:stretch>
+        </p:blipFill>
+        <p:spPr>
+          <a:xfrm>
+            <a:off x="0" y="0"/>
+            <a:ext cx="12191695" cy="6858000"/>
+          </a:xfrm>
+          <a:prstGeom prst="rect">
+            <a:avLst/>
+          </a:prstGeom>
+        </p:spPr>
+      </p:pic>
+      <p:sp>
+        <p:nvSpPr>
+          <p:cNvPr id="3" name="Shape 0"/>
+          <p:cNvSpPr/>
+          <p:nvPr/>
+        </p:nvSpPr>
+        <p:spPr>
+          <a:xfrm>
+            <a:off x="0" y="0"/>
+            <a:ext cx="12191695" cy="6858000"/>
+          </a:xfrm>
+          <a:prstGeom prst="rect">
+            <a:avLst/>
+          </a:prstGeom>
+          <a:solidFill>
+            <a:srgbClr val="000000">
+              <a:alpha val="45000"/>
+            </a:srgbClr>
+          </a:solidFill>
+          <a:ln w="12700">
+            <a:solidFill>
+              <a:srgbClr val="000000">
+                <a:alpha val="0"/>
+              </a:srgbClr>
+            </a:solidFill>
+            <a:prstDash val="solid"/>
+          </a:ln>
+        </p:spPr>
+      </p:sp>
+      <p:sp>
+        <p:nvSpPr>
+          <p:cNvPr id="4" name="Text 1"/>
           <p:cNvSpPr/>
           <p:nvPr/>
         </p:nvSpPr>
@@ -3873,7 +3965,7 @@
                 <a:ea typeface="Arial" pitchFamily="34" charset="-122"/>
                 <a:cs typeface="Arial" pitchFamily="34" charset="-120"/>
               </a:rPr>
-              <a:t>Discussion Placeholder</a:t>
+              <a:t>Optimization</a:t>
             </a:r>
             <a:endParaRPr lang="en-US" sz="2400" dirty="0"/>
           </a:p>
@@ -3881,7 +3973,7 @@
       </p:sp>
       <p:sp>
         <p:nvSpPr>
-          <p:cNvPr id="3" name="Shape 1"/>
+          <p:cNvPr id="5" name="Shape 2"/>
           <p:cNvSpPr/>
           <p:nvPr/>
         </p:nvSpPr>
@@ -3906,22 +3998,24 @@
       </p:sp>
       <p:sp>
         <p:nvSpPr>
-          <p:cNvPr id="4" name="Shape 2"/>
-          <p:cNvSpPr/>
-          <p:nvPr/>
-        </p:nvSpPr>
-        <p:spPr>
-          <a:xfrm>
-            <a:off x="960120" y="2011680"/>
-            <a:ext cx="10241280" cy="3291840"/>
+          <p:cNvPr id="6" name="Shape 3"/>
+          <p:cNvSpPr/>
+          <p:nvPr/>
+        </p:nvSpPr>
+        <p:spPr>
+          <a:xfrm>
+            <a:off x="640080" y="1554480"/>
+            <a:ext cx="10927080" cy="512064"/>
           </a:xfrm>
           <a:prstGeom prst="roundRect">
             <a:avLst>
-              <a:gd name="adj" fmla="val 2778"/>
+              <a:gd name="adj" fmla="val 14286"/>
             </a:avLst>
           </a:prstGeom>
           <a:solidFill>
-            <a:srgbClr val="FFF9E8"/>
+            <a:srgbClr val="1A2030">
+              <a:alpha val="80000"/>
+            </a:srgbClr>
           </a:solidFill>
           <a:ln w="12700">
             <a:solidFill>
@@ -3933,14 +4027,14 @@
       </p:sp>
       <p:sp>
         <p:nvSpPr>
-          <p:cNvPr id="5" name="Text 3"/>
-          <p:cNvSpPr/>
-          <p:nvPr/>
-        </p:nvSpPr>
-        <p:spPr>
-          <a:xfrm>
-            <a:off x="3154680" y="2788920"/>
-            <a:ext cx="5852160" cy="502920"/>
+          <p:cNvPr id="7" name="Text 4"/>
+          <p:cNvSpPr/>
+          <p:nvPr/>
+        </p:nvSpPr>
+        <p:spPr>
+          <a:xfrm>
+            <a:off x="896112" y="1719072"/>
+            <a:ext cx="10415016" cy="292608"/>
           </a:xfrm>
           <a:prstGeom prst="rect">
             <a:avLst/>
@@ -3952,34 +4046,34 @@
           <a:bodyPr wrap="square" lIns="0" tIns="0" rIns="0" bIns="0" rtlCol="0" anchor="ctr"/>
           <a:lstStyle/>
           <a:p>
-            <a:pPr algn="ctr" indent="0" marL="0">
-              <a:buNone/>
-            </a:pPr>
-            <a:r>
-              <a:rPr lang="en-US" sz="2600" b="1" dirty="0">
-                <a:solidFill>
-                  <a:srgbClr val="1C2430"/>
-                </a:solidFill>
-                <a:latin typeface="Arial" pitchFamily="34" charset="0"/>
-                <a:ea typeface="Arial" pitchFamily="34" charset="-122"/>
-                <a:cs typeface="Arial" pitchFamily="34" charset="-120"/>
-              </a:rPr>
-              <a:t>Content to be added later</a:t>
-            </a:r>
-            <a:endParaRPr lang="en-US" sz="2600" dirty="0"/>
-          </a:p>
-        </p:txBody>
-      </p:sp>
-      <p:sp>
-        <p:nvSpPr>
-          <p:cNvPr id="6" name="Text 4"/>
-          <p:cNvSpPr/>
-          <p:nvPr/>
-        </p:nvSpPr>
-        <p:spPr>
-          <a:xfrm>
-            <a:off x="2971800" y="3493008"/>
-            <a:ext cx="6217920" cy="320040"/>
+            <a:pPr indent="0" marL="0">
+              <a:buNone/>
+            </a:pPr>
+            <a:r>
+              <a:rPr lang="en-US" sz="1800" b="1" dirty="0">
+                <a:solidFill>
+                  <a:srgbClr val="FFFFFF"/>
+                </a:solidFill>
+                <a:latin typeface="Arial" pitchFamily="34" charset="0"/>
+                <a:ea typeface="Arial" pitchFamily="34" charset="-122"/>
+                <a:cs typeface="Arial" pitchFamily="34" charset="-120"/>
+              </a:rPr>
+              <a:t>Goal: clear the level without losing a single life.</a:t>
+            </a:r>
+            <a:endParaRPr lang="en-US" sz="1800" dirty="0"/>
+          </a:p>
+        </p:txBody>
+      </p:sp>
+      <p:sp>
+        <p:nvSpPr>
+          <p:cNvPr id="8" name="Text 5"/>
+          <p:cNvSpPr/>
+          <p:nvPr/>
+        </p:nvSpPr>
+        <p:spPr>
+          <a:xfrm>
+            <a:off x="640080" y="2267712"/>
+            <a:ext cx="4754880" cy="274320"/>
           </a:xfrm>
           <a:prstGeom prst="rect">
             <a:avLst/>
@@ -3991,21 +4085,1081 @@
           <a:bodyPr wrap="square" lIns="0" tIns="0" rIns="0" bIns="0" rtlCol="0" anchor="ctr"/>
           <a:lstStyle/>
           <a:p>
-            <a:pPr algn="ctr" indent="0" marL="0">
-              <a:buNone/>
-            </a:pPr>
-            <a:r>
-              <a:rPr lang="en-US" sz="1600" dirty="0">
-                <a:solidFill>
-                  <a:srgbClr val="5F6B7A"/>
-                </a:solidFill>
-                <a:latin typeface="Arial" pitchFamily="34" charset="0"/>
-                <a:ea typeface="Arial" pitchFamily="34" charset="-122"/>
-                <a:cs typeface="Arial" pitchFamily="34" charset="-120"/>
-              </a:rPr>
-              <a:t>Reserved for the final discussion point.</a:t>
-            </a:r>
-            <a:endParaRPr lang="en-US" sz="1600" dirty="0"/>
+            <a:pPr indent="0" marL="0">
+              <a:buNone/>
+            </a:pPr>
+            <a:r>
+              <a:rPr lang="en-US" sz="1400" b="1" dirty="0">
+                <a:solidFill>
+                  <a:srgbClr val="FFFFFF"/>
+                </a:solidFill>
+                <a:latin typeface="Arial" pitchFamily="34" charset="0"/>
+                <a:ea typeface="Arial" pitchFamily="34" charset="-122"/>
+                <a:cs typeface="Arial" pitchFamily="34" charset="-120"/>
+              </a:rPr>
+              <a:t>Death Handling Mechanisms</a:t>
+            </a:r>
+            <a:endParaRPr lang="en-US" sz="1400" dirty="0"/>
+          </a:p>
+        </p:txBody>
+      </p:sp>
+      <p:sp>
+        <p:nvSpPr>
+          <p:cNvPr id="9" name="Shape 6"/>
+          <p:cNvSpPr/>
+          <p:nvPr/>
+        </p:nvSpPr>
+        <p:spPr>
+          <a:xfrm>
+            <a:off x="640080" y="2560320"/>
+            <a:ext cx="2331720" cy="0"/>
+          </a:xfrm>
+          <a:prstGeom prst="line">
+            <a:avLst/>
+          </a:prstGeom>
+          <a:noFill/>
+          <a:ln w="12700">
+            <a:solidFill>
+              <a:srgbClr val="F4B400">
+                <a:alpha val="82000"/>
+              </a:srgbClr>
+            </a:solidFill>
+            <a:prstDash val="solid"/>
+          </a:ln>
+        </p:spPr>
+      </p:sp>
+      <p:sp>
+        <p:nvSpPr>
+          <p:cNvPr id="10" name="Shape 7"/>
+          <p:cNvSpPr/>
+          <p:nvPr/>
+        </p:nvSpPr>
+        <p:spPr>
+          <a:xfrm>
+            <a:off x="640080" y="2743200"/>
+            <a:ext cx="3429000" cy="2286000"/>
+          </a:xfrm>
+          <a:prstGeom prst="roundRect">
+            <a:avLst>
+              <a:gd name="adj" fmla="val 3200"/>
+            </a:avLst>
+          </a:prstGeom>
+          <a:solidFill>
+            <a:srgbClr val="1A2030">
+              <a:alpha val="80000"/>
+            </a:srgbClr>
+          </a:solidFill>
+          <a:ln w="12700">
+            <a:solidFill>
+              <a:srgbClr val="1E88E5"/>
+            </a:solidFill>
+            <a:prstDash val="solid"/>
+          </a:ln>
+        </p:spPr>
+      </p:sp>
+      <p:sp>
+        <p:nvSpPr>
+          <p:cNvPr id="11" name="Text 8"/>
+          <p:cNvSpPr/>
+          <p:nvPr/>
+        </p:nvSpPr>
+        <p:spPr>
+          <a:xfrm>
+            <a:off x="868680" y="2944368"/>
+            <a:ext cx="2971800" cy="274320"/>
+          </a:xfrm>
+          <a:prstGeom prst="rect">
+            <a:avLst/>
+          </a:prstGeom>
+          <a:noFill/>
+          <a:ln/>
+        </p:spPr>
+        <p:txBody>
+          <a:bodyPr wrap="square" lIns="0" tIns="0" rIns="0" bIns="0" rtlCol="0" anchor="ctr"/>
+          <a:lstStyle/>
+          <a:p>
+            <a:pPr indent="0" marL="0">
+              <a:buNone/>
+            </a:pPr>
+            <a:r>
+              <a:rPr lang="en-US" sz="1800" b="1" dirty="0">
+                <a:solidFill>
+                  <a:srgbClr val="FFFFFF"/>
+                </a:solidFill>
+                <a:latin typeface="Arial" pitchFamily="34" charset="0"/>
+                <a:ea typeface="Arial" pitchFamily="34" charset="-122"/>
+                <a:cs typeface="Arial" pitchFamily="34" charset="-120"/>
+              </a:rPr>
+              <a:t>Model 1</a:t>
+            </a:r>
+            <a:endParaRPr lang="en-US" sz="1800" dirty="0"/>
+          </a:p>
+        </p:txBody>
+      </p:sp>
+      <p:sp>
+        <p:nvSpPr>
+          <p:cNvPr id="12" name="Shape 9"/>
+          <p:cNvSpPr/>
+          <p:nvPr/>
+        </p:nvSpPr>
+        <p:spPr>
+          <a:xfrm>
+            <a:off x="868680" y="3310128"/>
+            <a:ext cx="2971800" cy="0"/>
+          </a:xfrm>
+          <a:prstGeom prst="line">
+            <a:avLst/>
+          </a:prstGeom>
+          <a:noFill/>
+          <a:ln w="12700">
+            <a:solidFill>
+              <a:srgbClr val="1E88E5">
+                <a:alpha val="82000"/>
+              </a:srgbClr>
+            </a:solidFill>
+            <a:prstDash val="solid"/>
+          </a:ln>
+        </p:spPr>
+      </p:sp>
+      <p:sp>
+        <p:nvSpPr>
+          <p:cNvPr id="13" name="Text 10"/>
+          <p:cNvSpPr/>
+          <p:nvPr/>
+        </p:nvSpPr>
+        <p:spPr>
+          <a:xfrm>
+            <a:off x="868680" y="3493008"/>
+            <a:ext cx="2971800" cy="1353312"/>
+          </a:xfrm>
+          <a:prstGeom prst="rect">
+            <a:avLst/>
+          </a:prstGeom>
+          <a:noFill/>
+          <a:ln/>
+        </p:spPr>
+        <p:txBody>
+          <a:bodyPr wrap="square" lIns="0" tIns="0" rIns="0" bIns="0" rtlCol="0" anchor="t"/>
+          <a:lstStyle/>
+          <a:p>
+            <a:pPr indent="0" marL="0">
+              <a:buNone/>
+            </a:pPr>
+            <a:r>
+              <a:rPr lang="en-US" sz="1350" dirty="0">
+                <a:solidFill>
+                  <a:srgbClr val="FFFFFF"/>
+                </a:solidFill>
+                <a:latin typeface="Arial" pitchFamily="34" charset="0"/>
+                <a:ea typeface="Arial" pitchFamily="34" charset="-122"/>
+                <a:cs typeface="Arial" pitchFamily="34" charset="-120"/>
+              </a:rPr>
+              <a:t>• Pac-Man has 3 lives.</a:t>
+            </a:r>
+            <a:endParaRPr lang="en-US" sz="1350" dirty="0"/>
+          </a:p>
+          <a:p>
+            <a:pPr indent="0" marL="0">
+              <a:buNone/>
+            </a:pPr>
+            <a:r>
+              <a:rPr lang="en-US" sz="1350" dirty="0">
+                <a:solidFill>
+                  <a:srgbClr val="FFFFFF"/>
+                </a:solidFill>
+                <a:latin typeface="Arial" pitchFamily="34" charset="0"/>
+                <a:ea typeface="Arial" pitchFamily="34" charset="-122"/>
+                <a:cs typeface="Arial" pitchFamily="34" charset="-120"/>
+              </a:rPr>
+              <a:t>• Rewards keep accumulating across lives.</a:t>
+            </a:r>
+            <a:endParaRPr lang="en-US" sz="1350" dirty="0"/>
+          </a:p>
+          <a:p>
+            <a:pPr indent="0" marL="0">
+              <a:buNone/>
+            </a:pPr>
+            <a:r>
+              <a:rPr lang="en-US" sz="1350" dirty="0">
+                <a:solidFill>
+                  <a:srgbClr val="FFFFFF"/>
+                </a:solidFill>
+                <a:latin typeface="Arial" pitchFamily="34" charset="0"/>
+                <a:ea typeface="Arial" pitchFamily="34" charset="-122"/>
+                <a:cs typeface="Arial" pitchFamily="34" charset="-120"/>
+              </a:rPr>
+              <a:t>• Dying does not reset the score.</a:t>
+            </a:r>
+            <a:endParaRPr lang="en-US" sz="1350" dirty="0"/>
+          </a:p>
+        </p:txBody>
+      </p:sp>
+      <p:sp>
+        <p:nvSpPr>
+          <p:cNvPr id="14" name="Shape 11"/>
+          <p:cNvSpPr/>
+          <p:nvPr/>
+        </p:nvSpPr>
+        <p:spPr>
+          <a:xfrm>
+            <a:off x="4379976" y="2743200"/>
+            <a:ext cx="3429000" cy="2286000"/>
+          </a:xfrm>
+          <a:prstGeom prst="roundRect">
+            <a:avLst>
+              <a:gd name="adj" fmla="val 3200"/>
+            </a:avLst>
+          </a:prstGeom>
+          <a:solidFill>
+            <a:srgbClr val="1A2030">
+              <a:alpha val="80000"/>
+            </a:srgbClr>
+          </a:solidFill>
+          <a:ln w="12700">
+            <a:solidFill>
+              <a:srgbClr val="16A085"/>
+            </a:solidFill>
+            <a:prstDash val="solid"/>
+          </a:ln>
+        </p:spPr>
+      </p:sp>
+      <p:sp>
+        <p:nvSpPr>
+          <p:cNvPr id="15" name="Text 12"/>
+          <p:cNvSpPr/>
+          <p:nvPr/>
+        </p:nvSpPr>
+        <p:spPr>
+          <a:xfrm>
+            <a:off x="4608576" y="2944368"/>
+            <a:ext cx="2971800" cy="274320"/>
+          </a:xfrm>
+          <a:prstGeom prst="rect">
+            <a:avLst/>
+          </a:prstGeom>
+          <a:noFill/>
+          <a:ln/>
+        </p:spPr>
+        <p:txBody>
+          <a:bodyPr wrap="square" lIns="0" tIns="0" rIns="0" bIns="0" rtlCol="0" anchor="ctr"/>
+          <a:lstStyle/>
+          <a:p>
+            <a:pPr indent="0" marL="0">
+              <a:buNone/>
+            </a:pPr>
+            <a:r>
+              <a:rPr lang="en-US" sz="1800" b="1" dirty="0">
+                <a:solidFill>
+                  <a:srgbClr val="FFFFFF"/>
+                </a:solidFill>
+                <a:latin typeface="Arial" pitchFamily="34" charset="0"/>
+                <a:ea typeface="Arial" pitchFamily="34" charset="-122"/>
+                <a:cs typeface="Arial" pitchFamily="34" charset="-120"/>
+              </a:rPr>
+              <a:t>Model 2</a:t>
+            </a:r>
+            <a:endParaRPr lang="en-US" sz="1800" dirty="0"/>
+          </a:p>
+        </p:txBody>
+      </p:sp>
+      <p:sp>
+        <p:nvSpPr>
+          <p:cNvPr id="16" name="Shape 13"/>
+          <p:cNvSpPr/>
+          <p:nvPr/>
+        </p:nvSpPr>
+        <p:spPr>
+          <a:xfrm>
+            <a:off x="4608576" y="3310128"/>
+            <a:ext cx="2971800" cy="0"/>
+          </a:xfrm>
+          <a:prstGeom prst="line">
+            <a:avLst/>
+          </a:prstGeom>
+          <a:noFill/>
+          <a:ln w="12700">
+            <a:solidFill>
+              <a:srgbClr val="16A085">
+                <a:alpha val="82000"/>
+              </a:srgbClr>
+            </a:solidFill>
+            <a:prstDash val="solid"/>
+          </a:ln>
+        </p:spPr>
+      </p:sp>
+      <p:sp>
+        <p:nvSpPr>
+          <p:cNvPr id="17" name="Text 14"/>
+          <p:cNvSpPr/>
+          <p:nvPr/>
+        </p:nvSpPr>
+        <p:spPr>
+          <a:xfrm>
+            <a:off x="4608576" y="3493008"/>
+            <a:ext cx="2971800" cy="1353312"/>
+          </a:xfrm>
+          <a:prstGeom prst="rect">
+            <a:avLst/>
+          </a:prstGeom>
+          <a:noFill/>
+          <a:ln/>
+        </p:spPr>
+        <p:txBody>
+          <a:bodyPr wrap="square" lIns="0" tIns="0" rIns="0" bIns="0" rtlCol="0" anchor="t"/>
+          <a:lstStyle/>
+          <a:p>
+            <a:pPr indent="0" marL="0">
+              <a:buNone/>
+            </a:pPr>
+            <a:r>
+              <a:rPr lang="en-US" sz="1350" dirty="0">
+                <a:solidFill>
+                  <a:srgbClr val="FFFFFF"/>
+                </a:solidFill>
+                <a:latin typeface="Arial" pitchFamily="34" charset="0"/>
+                <a:ea typeface="Arial" pitchFamily="34" charset="-122"/>
+                <a:cs typeface="Arial" pitchFamily="34" charset="-120"/>
+              </a:rPr>
+              <a:t>• Pac-Man has 3 lives.</a:t>
+            </a:r>
+            <a:endParaRPr lang="en-US" sz="1350" dirty="0"/>
+          </a:p>
+          <a:p>
+            <a:pPr indent="0" marL="0">
+              <a:buNone/>
+            </a:pPr>
+            <a:r>
+              <a:rPr lang="en-US" sz="1350" dirty="0">
+                <a:solidFill>
+                  <a:srgbClr val="FFFFFF"/>
+                </a:solidFill>
+                <a:latin typeface="Arial" pitchFamily="34" charset="0"/>
+                <a:ea typeface="Arial" pitchFamily="34" charset="-122"/>
+                <a:cs typeface="Arial" pitchFamily="34" charset="-120"/>
+              </a:rPr>
+              <a:t>• If Pac-Man dies, the score resets to 0.</a:t>
+            </a:r>
+            <a:endParaRPr lang="en-US" sz="1350" dirty="0"/>
+          </a:p>
+          <a:p>
+            <a:pPr indent="0" marL="0">
+              <a:buNone/>
+            </a:pPr>
+            <a:r>
+              <a:rPr lang="en-US" sz="1350" dirty="0">
+                <a:solidFill>
+                  <a:srgbClr val="FFFFFF"/>
+                </a:solidFill>
+                <a:latin typeface="Arial" pitchFamily="34" charset="0"/>
+                <a:ea typeface="Arial" pitchFamily="34" charset="-122"/>
+                <a:cs typeface="Arial" pitchFamily="34" charset="-120"/>
+              </a:rPr>
+              <a:t>• This creates a much stronger penalty for death.</a:t>
+            </a:r>
+            <a:endParaRPr lang="en-US" sz="1350" dirty="0"/>
+          </a:p>
+        </p:txBody>
+      </p:sp>
+      <p:sp>
+        <p:nvSpPr>
+          <p:cNvPr id="18" name="Shape 15"/>
+          <p:cNvSpPr/>
+          <p:nvPr/>
+        </p:nvSpPr>
+        <p:spPr>
+          <a:xfrm>
+            <a:off x="8119872" y="2743200"/>
+            <a:ext cx="3429000" cy="2286000"/>
+          </a:xfrm>
+          <a:prstGeom prst="roundRect">
+            <a:avLst>
+              <a:gd name="adj" fmla="val 3200"/>
+            </a:avLst>
+          </a:prstGeom>
+          <a:solidFill>
+            <a:srgbClr val="1A2030">
+              <a:alpha val="80000"/>
+            </a:srgbClr>
+          </a:solidFill>
+          <a:ln w="12700">
+            <a:solidFill>
+              <a:srgbClr val="D93025"/>
+            </a:solidFill>
+            <a:prstDash val="solid"/>
+          </a:ln>
+        </p:spPr>
+      </p:sp>
+      <p:sp>
+        <p:nvSpPr>
+          <p:cNvPr id="19" name="Text 16"/>
+          <p:cNvSpPr/>
+          <p:nvPr/>
+        </p:nvSpPr>
+        <p:spPr>
+          <a:xfrm>
+            <a:off x="8348472" y="2944368"/>
+            <a:ext cx="2971800" cy="274320"/>
+          </a:xfrm>
+          <a:prstGeom prst="rect">
+            <a:avLst/>
+          </a:prstGeom>
+          <a:noFill/>
+          <a:ln/>
+        </p:spPr>
+        <p:txBody>
+          <a:bodyPr wrap="square" lIns="0" tIns="0" rIns="0" bIns="0" rtlCol="0" anchor="ctr"/>
+          <a:lstStyle/>
+          <a:p>
+            <a:pPr indent="0" marL="0">
+              <a:buNone/>
+            </a:pPr>
+            <a:r>
+              <a:rPr lang="en-US" sz="1800" b="1" dirty="0">
+                <a:solidFill>
+                  <a:srgbClr val="FFFFFF"/>
+                </a:solidFill>
+                <a:latin typeface="Arial" pitchFamily="34" charset="0"/>
+                <a:ea typeface="Arial" pitchFamily="34" charset="-122"/>
+                <a:cs typeface="Arial" pitchFamily="34" charset="-120"/>
+              </a:rPr>
+              <a:t>Model 3</a:t>
+            </a:r>
+            <a:endParaRPr lang="en-US" sz="1800" dirty="0"/>
+          </a:p>
+        </p:txBody>
+      </p:sp>
+      <p:sp>
+        <p:nvSpPr>
+          <p:cNvPr id="20" name="Shape 17"/>
+          <p:cNvSpPr/>
+          <p:nvPr/>
+        </p:nvSpPr>
+        <p:spPr>
+          <a:xfrm>
+            <a:off x="8348472" y="3310128"/>
+            <a:ext cx="2971800" cy="0"/>
+          </a:xfrm>
+          <a:prstGeom prst="line">
+            <a:avLst/>
+          </a:prstGeom>
+          <a:noFill/>
+          <a:ln w="12700">
+            <a:solidFill>
+              <a:srgbClr val="D93025">
+                <a:alpha val="82000"/>
+              </a:srgbClr>
+            </a:solidFill>
+            <a:prstDash val="solid"/>
+          </a:ln>
+        </p:spPr>
+      </p:sp>
+      <p:sp>
+        <p:nvSpPr>
+          <p:cNvPr id="21" name="Text 18"/>
+          <p:cNvSpPr/>
+          <p:nvPr/>
+        </p:nvSpPr>
+        <p:spPr>
+          <a:xfrm>
+            <a:off x="8348472" y="3493008"/>
+            <a:ext cx="2971800" cy="1353312"/>
+          </a:xfrm>
+          <a:prstGeom prst="rect">
+            <a:avLst/>
+          </a:prstGeom>
+          <a:noFill/>
+          <a:ln/>
+        </p:spPr>
+        <p:txBody>
+          <a:bodyPr wrap="square" lIns="0" tIns="0" rIns="0" bIns="0" rtlCol="0" anchor="t"/>
+          <a:lstStyle/>
+          <a:p>
+            <a:pPr indent="0" marL="0">
+              <a:buNone/>
+            </a:pPr>
+            <a:r>
+              <a:rPr lang="en-US" sz="1350" dirty="0">
+                <a:solidFill>
+                  <a:srgbClr val="FFFFFF"/>
+                </a:solidFill>
+                <a:latin typeface="Arial" pitchFamily="34" charset="0"/>
+                <a:ea typeface="Arial" pitchFamily="34" charset="-122"/>
+                <a:cs typeface="Arial" pitchFamily="34" charset="-120"/>
+              </a:rPr>
+              <a:t>• Pac-Man has 3 lives.</a:t>
+            </a:r>
+            <a:endParaRPr lang="en-US" sz="1350" dirty="0"/>
+          </a:p>
+          <a:p>
+            <a:pPr indent="0" marL="0">
+              <a:buNone/>
+            </a:pPr>
+            <a:r>
+              <a:rPr lang="en-US" sz="1350" dirty="0">
+                <a:solidFill>
+                  <a:srgbClr val="FFFFFF"/>
+                </a:solidFill>
+                <a:latin typeface="Arial" pitchFamily="34" charset="0"/>
+                <a:ea typeface="Arial" pitchFamily="34" charset="-122"/>
+                <a:cs typeface="Arial" pitchFamily="34" charset="-120"/>
+              </a:rPr>
+              <a:t>• If Pac-Man dies, the next life starts from a score below 0.</a:t>
+            </a:r>
+            <a:endParaRPr lang="en-US" sz="1350" dirty="0"/>
+          </a:p>
+          <a:p>
+            <a:pPr indent="0" marL="0">
+              <a:buNone/>
+            </a:pPr>
+            <a:r>
+              <a:rPr lang="en-US" sz="1350" dirty="0">
+                <a:solidFill>
+                  <a:srgbClr val="FFFFFF"/>
+                </a:solidFill>
+                <a:latin typeface="Arial" pitchFamily="34" charset="0"/>
+                <a:ea typeface="Arial" pitchFamily="34" charset="-122"/>
+                <a:cs typeface="Arial" pitchFamily="34" charset="-120"/>
+              </a:rPr>
+              <a:t>• This is the harshest death penalty among the three models.</a:t>
+            </a:r>
+            <a:endParaRPr lang="en-US" sz="1350" dirty="0"/>
+          </a:p>
+        </p:txBody>
+      </p:sp>
+      <p:sp>
+        <p:nvSpPr>
+          <p:cNvPr id="22" name="Text 19"/>
+          <p:cNvSpPr/>
+          <p:nvPr/>
+        </p:nvSpPr>
+        <p:spPr>
+          <a:xfrm>
+            <a:off x="640080" y="5138928"/>
+            <a:ext cx="6949440" cy="201168"/>
+          </a:xfrm>
+          <a:prstGeom prst="rect">
+            <a:avLst/>
+          </a:prstGeom>
+          <a:noFill/>
+          <a:ln/>
+        </p:spPr>
+        <p:txBody>
+          <a:bodyPr wrap="square" lIns="0" tIns="0" rIns="0" bIns="0" rtlCol="0" anchor="ctr"/>
+          <a:lstStyle/>
+          <a:p>
+            <a:pPr indent="0" marL="0">
+              <a:buNone/>
+            </a:pPr>
+            <a:r>
+              <a:rPr lang="en-US" sz="1100" b="1" dirty="0">
+                <a:solidFill>
+                  <a:srgbClr val="D8E2EE"/>
+                </a:solidFill>
+                <a:latin typeface="Arial" pitchFamily="34" charset="0"/>
+                <a:ea typeface="Arial" pitchFamily="34" charset="-122"/>
+                <a:cs typeface="Arial" pitchFamily="34" charset="-120"/>
+              </a:rPr>
+              <a:t>Example Start Values (if each death happens after reaching 1200 points)</a:t>
+            </a:r>
+            <a:endParaRPr lang="en-US" sz="1100" dirty="0"/>
+          </a:p>
+        </p:txBody>
+      </p:sp>
+      <p:sp>
+        <p:nvSpPr>
+          <p:cNvPr id="23" name="Shape 20"/>
+          <p:cNvSpPr/>
+          <p:nvPr/>
+        </p:nvSpPr>
+        <p:spPr>
+          <a:xfrm>
+            <a:off x="640080" y="5376672"/>
+            <a:ext cx="3429000" cy="1024128"/>
+          </a:xfrm>
+          <a:prstGeom prst="roundRect">
+            <a:avLst>
+              <a:gd name="adj" fmla="val 7143"/>
+            </a:avLst>
+          </a:prstGeom>
+          <a:solidFill>
+            <a:srgbClr val="1A2030">
+              <a:alpha val="80000"/>
+            </a:srgbClr>
+          </a:solidFill>
+          <a:ln w="12700">
+            <a:solidFill>
+              <a:srgbClr val="1E88E5"/>
+            </a:solidFill>
+            <a:prstDash val="solid"/>
+          </a:ln>
+        </p:spPr>
+      </p:sp>
+      <p:sp>
+        <p:nvSpPr>
+          <p:cNvPr id="24" name="Text 21"/>
+          <p:cNvSpPr/>
+          <p:nvPr/>
+        </p:nvSpPr>
+        <p:spPr>
+          <a:xfrm>
+            <a:off x="868680" y="5513832"/>
+            <a:ext cx="2697480" cy="201168"/>
+          </a:xfrm>
+          <a:prstGeom prst="rect">
+            <a:avLst/>
+          </a:prstGeom>
+          <a:noFill/>
+          <a:ln/>
+        </p:spPr>
+        <p:txBody>
+          <a:bodyPr wrap="square" lIns="0" tIns="0" rIns="0" bIns="0" rtlCol="0" anchor="ctr"/>
+          <a:lstStyle/>
+          <a:p>
+            <a:pPr indent="0" marL="0">
+              <a:buNone/>
+            </a:pPr>
+            <a:r>
+              <a:rPr lang="en-US" sz="1150" b="1" dirty="0">
+                <a:solidFill>
+                  <a:srgbClr val="FFFFFF"/>
+                </a:solidFill>
+                <a:latin typeface="Arial" pitchFamily="34" charset="0"/>
+                <a:ea typeface="Arial" pitchFamily="34" charset="-122"/>
+                <a:cs typeface="Arial" pitchFamily="34" charset="-120"/>
+              </a:rPr>
+              <a:t>Model 1 Start Value</a:t>
+            </a:r>
+            <a:endParaRPr lang="en-US" sz="1150" dirty="0"/>
+          </a:p>
+        </p:txBody>
+      </p:sp>
+      <p:sp>
+        <p:nvSpPr>
+          <p:cNvPr id="25" name="Shape 22"/>
+          <p:cNvSpPr/>
+          <p:nvPr/>
+        </p:nvSpPr>
+        <p:spPr>
+          <a:xfrm>
+            <a:off x="868680" y="5742432"/>
+            <a:ext cx="2880360" cy="0"/>
+          </a:xfrm>
+          <a:prstGeom prst="line">
+            <a:avLst/>
+          </a:prstGeom>
+          <a:noFill/>
+          <a:ln w="12700">
+            <a:solidFill>
+              <a:srgbClr val="1E88E5">
+                <a:alpha val="82000"/>
+              </a:srgbClr>
+            </a:solidFill>
+            <a:prstDash val="solid"/>
+          </a:ln>
+        </p:spPr>
+      </p:sp>
+      <p:sp>
+        <p:nvSpPr>
+          <p:cNvPr id="26" name="Text 23"/>
+          <p:cNvSpPr/>
+          <p:nvPr/>
+        </p:nvSpPr>
+        <p:spPr>
+          <a:xfrm>
+            <a:off x="868680" y="5888736"/>
+            <a:ext cx="2834640" cy="384048"/>
+          </a:xfrm>
+          <a:prstGeom prst="rect">
+            <a:avLst/>
+          </a:prstGeom>
+          <a:noFill/>
+          <a:ln/>
+        </p:spPr>
+        <p:txBody>
+          <a:bodyPr wrap="square" lIns="0" tIns="0" rIns="0" bIns="0" rtlCol="0" anchor="ctr"/>
+          <a:lstStyle/>
+          <a:p>
+            <a:pPr indent="0" marL="0">
+              <a:buNone/>
+            </a:pPr>
+            <a:r>
+              <a:rPr lang="en-US" sz="1050" dirty="0">
+                <a:solidFill>
+                  <a:srgbClr val="FFFFFF"/>
+                </a:solidFill>
+                <a:latin typeface="Arial" pitchFamily="34" charset="0"/>
+                <a:ea typeface="Arial" pitchFamily="34" charset="-122"/>
+                <a:cs typeface="Arial" pitchFamily="34" charset="-120"/>
+              </a:rPr>
+              <a:t>Life 1: 0</a:t>
+            </a:r>
+            <a:endParaRPr lang="en-US" sz="1050" dirty="0"/>
+          </a:p>
+          <a:p>
+            <a:pPr indent="0" marL="0">
+              <a:buNone/>
+            </a:pPr>
+            <a:r>
+              <a:rPr lang="en-US" sz="1050" dirty="0">
+                <a:solidFill>
+                  <a:srgbClr val="FFFFFF"/>
+                </a:solidFill>
+                <a:latin typeface="Arial" pitchFamily="34" charset="0"/>
+                <a:ea typeface="Arial" pitchFamily="34" charset="-122"/>
+                <a:cs typeface="Arial" pitchFamily="34" charset="-120"/>
+              </a:rPr>
+              <a:t>Life 2: 1200</a:t>
+            </a:r>
+            <a:endParaRPr lang="en-US" sz="1050" dirty="0"/>
+          </a:p>
+          <a:p>
+            <a:pPr indent="0" marL="0">
+              <a:buNone/>
+            </a:pPr>
+            <a:r>
+              <a:rPr lang="en-US" sz="1050" dirty="0">
+                <a:solidFill>
+                  <a:srgbClr val="FFFFFF"/>
+                </a:solidFill>
+                <a:latin typeface="Arial" pitchFamily="34" charset="0"/>
+                <a:ea typeface="Arial" pitchFamily="34" charset="-122"/>
+                <a:cs typeface="Arial" pitchFamily="34" charset="-120"/>
+              </a:rPr>
+              <a:t>Life 3: 2400</a:t>
+            </a:r>
+            <a:endParaRPr lang="en-US" sz="1050" dirty="0"/>
+          </a:p>
+        </p:txBody>
+      </p:sp>
+      <p:sp>
+        <p:nvSpPr>
+          <p:cNvPr id="27" name="Shape 24"/>
+          <p:cNvSpPr/>
+          <p:nvPr/>
+        </p:nvSpPr>
+        <p:spPr>
+          <a:xfrm>
+            <a:off x="4379976" y="5376672"/>
+            <a:ext cx="3429000" cy="1024128"/>
+          </a:xfrm>
+          <a:prstGeom prst="roundRect">
+            <a:avLst>
+              <a:gd name="adj" fmla="val 7143"/>
+            </a:avLst>
+          </a:prstGeom>
+          <a:solidFill>
+            <a:srgbClr val="1A2030">
+              <a:alpha val="80000"/>
+            </a:srgbClr>
+          </a:solidFill>
+          <a:ln w="12700">
+            <a:solidFill>
+              <a:srgbClr val="16A085"/>
+            </a:solidFill>
+            <a:prstDash val="solid"/>
+          </a:ln>
+        </p:spPr>
+      </p:sp>
+      <p:sp>
+        <p:nvSpPr>
+          <p:cNvPr id="28" name="Text 25"/>
+          <p:cNvSpPr/>
+          <p:nvPr/>
+        </p:nvSpPr>
+        <p:spPr>
+          <a:xfrm>
+            <a:off x="4608576" y="5513832"/>
+            <a:ext cx="2697480" cy="201168"/>
+          </a:xfrm>
+          <a:prstGeom prst="rect">
+            <a:avLst/>
+          </a:prstGeom>
+          <a:noFill/>
+          <a:ln/>
+        </p:spPr>
+        <p:txBody>
+          <a:bodyPr wrap="square" lIns="0" tIns="0" rIns="0" bIns="0" rtlCol="0" anchor="ctr"/>
+          <a:lstStyle/>
+          <a:p>
+            <a:pPr indent="0" marL="0">
+              <a:buNone/>
+            </a:pPr>
+            <a:r>
+              <a:rPr lang="en-US" sz="1150" b="1" dirty="0">
+                <a:solidFill>
+                  <a:srgbClr val="FFFFFF"/>
+                </a:solidFill>
+                <a:latin typeface="Arial" pitchFamily="34" charset="0"/>
+                <a:ea typeface="Arial" pitchFamily="34" charset="-122"/>
+                <a:cs typeface="Arial" pitchFamily="34" charset="-120"/>
+              </a:rPr>
+              <a:t>Model 2 Start Value</a:t>
+            </a:r>
+            <a:endParaRPr lang="en-US" sz="1150" dirty="0"/>
+          </a:p>
+        </p:txBody>
+      </p:sp>
+      <p:sp>
+        <p:nvSpPr>
+          <p:cNvPr id="29" name="Shape 26"/>
+          <p:cNvSpPr/>
+          <p:nvPr/>
+        </p:nvSpPr>
+        <p:spPr>
+          <a:xfrm>
+            <a:off x="4608576" y="5742432"/>
+            <a:ext cx="2880360" cy="0"/>
+          </a:xfrm>
+          <a:prstGeom prst="line">
+            <a:avLst/>
+          </a:prstGeom>
+          <a:noFill/>
+          <a:ln w="12700">
+            <a:solidFill>
+              <a:srgbClr val="16A085">
+                <a:alpha val="82000"/>
+              </a:srgbClr>
+            </a:solidFill>
+            <a:prstDash val="solid"/>
+          </a:ln>
+        </p:spPr>
+      </p:sp>
+      <p:sp>
+        <p:nvSpPr>
+          <p:cNvPr id="30" name="Text 27"/>
+          <p:cNvSpPr/>
+          <p:nvPr/>
+        </p:nvSpPr>
+        <p:spPr>
+          <a:xfrm>
+            <a:off x="4608576" y="5888736"/>
+            <a:ext cx="2834640" cy="384048"/>
+          </a:xfrm>
+          <a:prstGeom prst="rect">
+            <a:avLst/>
+          </a:prstGeom>
+          <a:noFill/>
+          <a:ln/>
+        </p:spPr>
+        <p:txBody>
+          <a:bodyPr wrap="square" lIns="0" tIns="0" rIns="0" bIns="0" rtlCol="0" anchor="ctr"/>
+          <a:lstStyle/>
+          <a:p>
+            <a:pPr indent="0" marL="0">
+              <a:buNone/>
+            </a:pPr>
+            <a:r>
+              <a:rPr lang="en-US" sz="1050" dirty="0">
+                <a:solidFill>
+                  <a:srgbClr val="FFFFFF"/>
+                </a:solidFill>
+                <a:latin typeface="Arial" pitchFamily="34" charset="0"/>
+                <a:ea typeface="Arial" pitchFamily="34" charset="-122"/>
+                <a:cs typeface="Arial" pitchFamily="34" charset="-120"/>
+              </a:rPr>
+              <a:t>Life 1: 0</a:t>
+            </a:r>
+            <a:endParaRPr lang="en-US" sz="1050" dirty="0"/>
+          </a:p>
+          <a:p>
+            <a:pPr indent="0" marL="0">
+              <a:buNone/>
+            </a:pPr>
+            <a:r>
+              <a:rPr lang="en-US" sz="1050" dirty="0">
+                <a:solidFill>
+                  <a:srgbClr val="FFFFFF"/>
+                </a:solidFill>
+                <a:latin typeface="Arial" pitchFamily="34" charset="0"/>
+                <a:ea typeface="Arial" pitchFamily="34" charset="-122"/>
+                <a:cs typeface="Arial" pitchFamily="34" charset="-120"/>
+              </a:rPr>
+              <a:t>Life 2: 0</a:t>
+            </a:r>
+            <a:endParaRPr lang="en-US" sz="1050" dirty="0"/>
+          </a:p>
+          <a:p>
+            <a:pPr indent="0" marL="0">
+              <a:buNone/>
+            </a:pPr>
+            <a:r>
+              <a:rPr lang="en-US" sz="1050" dirty="0">
+                <a:solidFill>
+                  <a:srgbClr val="FFFFFF"/>
+                </a:solidFill>
+                <a:latin typeface="Arial" pitchFamily="34" charset="0"/>
+                <a:ea typeface="Arial" pitchFamily="34" charset="-122"/>
+                <a:cs typeface="Arial" pitchFamily="34" charset="-120"/>
+              </a:rPr>
+              <a:t>Life 3: 0</a:t>
+            </a:r>
+            <a:endParaRPr lang="en-US" sz="1050" dirty="0"/>
+          </a:p>
+        </p:txBody>
+      </p:sp>
+      <p:sp>
+        <p:nvSpPr>
+          <p:cNvPr id="31" name="Shape 28"/>
+          <p:cNvSpPr/>
+          <p:nvPr/>
+        </p:nvSpPr>
+        <p:spPr>
+          <a:xfrm>
+            <a:off x="8119872" y="5376672"/>
+            <a:ext cx="3429000" cy="1024128"/>
+          </a:xfrm>
+          <a:prstGeom prst="roundRect">
+            <a:avLst>
+              <a:gd name="adj" fmla="val 7143"/>
+            </a:avLst>
+          </a:prstGeom>
+          <a:solidFill>
+            <a:srgbClr val="1A2030">
+              <a:alpha val="80000"/>
+            </a:srgbClr>
+          </a:solidFill>
+          <a:ln w="12700">
+            <a:solidFill>
+              <a:srgbClr val="D93025"/>
+            </a:solidFill>
+            <a:prstDash val="solid"/>
+          </a:ln>
+        </p:spPr>
+      </p:sp>
+      <p:sp>
+        <p:nvSpPr>
+          <p:cNvPr id="32" name="Text 29"/>
+          <p:cNvSpPr/>
+          <p:nvPr/>
+        </p:nvSpPr>
+        <p:spPr>
+          <a:xfrm>
+            <a:off x="8348472" y="5513832"/>
+            <a:ext cx="2697480" cy="201168"/>
+          </a:xfrm>
+          <a:prstGeom prst="rect">
+            <a:avLst/>
+          </a:prstGeom>
+          <a:noFill/>
+          <a:ln/>
+        </p:spPr>
+        <p:txBody>
+          <a:bodyPr wrap="square" lIns="0" tIns="0" rIns="0" bIns="0" rtlCol="0" anchor="ctr"/>
+          <a:lstStyle/>
+          <a:p>
+            <a:pPr indent="0" marL="0">
+              <a:buNone/>
+            </a:pPr>
+            <a:r>
+              <a:rPr lang="en-US" sz="1150" b="1" dirty="0">
+                <a:solidFill>
+                  <a:srgbClr val="FFFFFF"/>
+                </a:solidFill>
+                <a:latin typeface="Arial" pitchFamily="34" charset="0"/>
+                <a:ea typeface="Arial" pitchFamily="34" charset="-122"/>
+                <a:cs typeface="Arial" pitchFamily="34" charset="-120"/>
+              </a:rPr>
+              <a:t>Model 3 Start Value</a:t>
+            </a:r>
+            <a:endParaRPr lang="en-US" sz="1150" dirty="0"/>
+          </a:p>
+        </p:txBody>
+      </p:sp>
+      <p:sp>
+        <p:nvSpPr>
+          <p:cNvPr id="33" name="Shape 30"/>
+          <p:cNvSpPr/>
+          <p:nvPr/>
+        </p:nvSpPr>
+        <p:spPr>
+          <a:xfrm>
+            <a:off x="8348472" y="5742432"/>
+            <a:ext cx="2880360" cy="0"/>
+          </a:xfrm>
+          <a:prstGeom prst="line">
+            <a:avLst/>
+          </a:prstGeom>
+          <a:noFill/>
+          <a:ln w="12700">
+            <a:solidFill>
+              <a:srgbClr val="D93025">
+                <a:alpha val="82000"/>
+              </a:srgbClr>
+            </a:solidFill>
+            <a:prstDash val="solid"/>
+          </a:ln>
+        </p:spPr>
+      </p:sp>
+      <p:sp>
+        <p:nvSpPr>
+          <p:cNvPr id="34" name="Text 31"/>
+          <p:cNvSpPr/>
+          <p:nvPr/>
+        </p:nvSpPr>
+        <p:spPr>
+          <a:xfrm>
+            <a:off x="8348472" y="5888736"/>
+            <a:ext cx="2834640" cy="384048"/>
+          </a:xfrm>
+          <a:prstGeom prst="rect">
+            <a:avLst/>
+          </a:prstGeom>
+          <a:noFill/>
+          <a:ln/>
+        </p:spPr>
+        <p:txBody>
+          <a:bodyPr wrap="square" lIns="0" tIns="0" rIns="0" bIns="0" rtlCol="0" anchor="ctr"/>
+          <a:lstStyle/>
+          <a:p>
+            <a:pPr indent="0" marL="0">
+              <a:buNone/>
+            </a:pPr>
+            <a:r>
+              <a:rPr lang="en-US" sz="1050" dirty="0">
+                <a:solidFill>
+                  <a:srgbClr val="FFFFFF"/>
+                </a:solidFill>
+                <a:latin typeface="Arial" pitchFamily="34" charset="0"/>
+                <a:ea typeface="Arial" pitchFamily="34" charset="-122"/>
+                <a:cs typeface="Arial" pitchFamily="34" charset="-120"/>
+              </a:rPr>
+              <a:t>Life 1: 0</a:t>
+            </a:r>
+            <a:endParaRPr lang="en-US" sz="1050" dirty="0"/>
+          </a:p>
+          <a:p>
+            <a:pPr indent="0" marL="0">
+              <a:buNone/>
+            </a:pPr>
+            <a:r>
+              <a:rPr lang="en-US" sz="1050" dirty="0">
+                <a:solidFill>
+                  <a:srgbClr val="FFFFFF"/>
+                </a:solidFill>
+                <a:latin typeface="Arial" pitchFamily="34" charset="0"/>
+                <a:ea typeface="Arial" pitchFamily="34" charset="-122"/>
+                <a:cs typeface="Arial" pitchFamily="34" charset="-120"/>
+              </a:rPr>
+              <a:t>Life 2: -360</a:t>
+            </a:r>
+            <a:endParaRPr lang="en-US" sz="1050" dirty="0"/>
+          </a:p>
+          <a:p>
+            <a:pPr indent="0" marL="0">
+              <a:buNone/>
+            </a:pPr>
+            <a:r>
+              <a:rPr lang="en-US" sz="1050" dirty="0">
+                <a:solidFill>
+                  <a:srgbClr val="FFFFFF"/>
+                </a:solidFill>
+                <a:latin typeface="Arial" pitchFamily="34" charset="0"/>
+                <a:ea typeface="Arial" pitchFamily="34" charset="-122"/>
+                <a:cs typeface="Arial" pitchFamily="34" charset="-120"/>
+              </a:rPr>
+              <a:t>Life 3: -720</a:t>
+            </a:r>
+            <a:endParaRPr lang="en-US" sz="1050" dirty="0"/>
           </a:p>
         </p:txBody>
       </p:sp>

</xml_diff>

<commit_message>
reorganize ppt assets and update slides
</commit_message>
<xml_diff>
--- a/ppt_3pages/pacman_rl_3slides.pptx
+++ b/ppt_3pages/pacman_rl_3slides.pptx
@@ -1055,7 +1055,7 @@
       </p:grpSpPr>
       <p:pic>
         <p:nvPicPr>
-          <p:cNvPr id="2" name="Image 0" descr="/Users/fengruiding/Desktop/cs520/project/ppt_3pages/pacman_neon_bg.png">    </p:cNvPr>
+          <p:cNvPr id="2" name="Image 0" descr="/Users/fengruiding/Desktop/cs520/project/ppt_3pages/images/pacman_neon_bg.png">    </p:cNvPr>
           <p:cNvPicPr>
             <a:picLocks noChangeAspect="1"/>
           </p:cNvPicPr>
@@ -1793,7 +1793,7 @@
       </p:sp>
       <p:pic>
         <p:nvPicPr>
-          <p:cNvPr id="26" name="Image 4" descr="/Users/fengruiding/Desktop/cs520/project/ppt_3pages/ui_ghost_blue.png">    </p:cNvPr>
+          <p:cNvPr id="26" name="Image 4" descr="/Users/fengruiding/Desktop/cs520/project/ppt_3pages/images/ui_ghost_blue.png">    </p:cNvPr>
           <p:cNvPicPr>
             <a:picLocks noChangeAspect="1"/>
           </p:cNvPicPr>
@@ -1924,7 +1924,7 @@
       </p:sp>
       <p:pic>
         <p:nvPicPr>
-          <p:cNvPr id="30" name="Image 5" descr="/Users/fengruiding/Desktop/cs520/project/ppt_3pages/ui_fruit_cherries.png">    </p:cNvPr>
+          <p:cNvPr id="30" name="Image 5" descr="/Users/fengruiding/Desktop/cs520/project/ppt_3pages/images/ui_fruit_cherries.png">    </p:cNvPr>
           <p:cNvPicPr>
             <a:picLocks noChangeAspect="1"/>
           </p:cNvPicPr>
@@ -2453,7 +2453,7 @@
       </p:grpSpPr>
       <p:pic>
         <p:nvPicPr>
-          <p:cNvPr id="2" name="Image 0" descr="/Users/fengruiding/Desktop/cs520/project/ppt_3pages/pacman_neon_bg.png">    </p:cNvPr>
+          <p:cNvPr id="2" name="Image 0" descr="/Users/fengruiding/Desktop/cs520/project/ppt_3pages/images/pacman_neon_bg.png">    </p:cNvPr>
           <p:cNvPicPr>
             <a:picLocks noChangeAspect="1"/>
           </p:cNvPicPr>
@@ -2508,7 +2508,7 @@
                 <a:ea typeface="Arial" pitchFamily="34" charset="-122"/>
                 <a:cs typeface="Arial" pitchFamily="34" charset="-120"/>
               </a:rPr>
-              <a:t>Reward and Penalty Design</a:t>
+              <a:t>Q-Learning Update Rule</a:t>
             </a:r>
             <a:endParaRPr lang="en-US" sz="2400" dirty="0"/>
           </a:p>
@@ -2626,7 +2626,7 @@
         <p:spPr>
           <a:xfrm>
             <a:off x="640080" y="1993392"/>
-            <a:ext cx="3200400" cy="201168"/>
+            <a:ext cx="6583680" cy="201168"/>
           </a:xfrm>
           <a:prstGeom prst="rect">
             <a:avLst/>
@@ -2650,7 +2650,7 @@
                 <a:ea typeface="Arial" pitchFamily="34" charset="-122"/>
                 <a:cs typeface="Arial" pitchFamily="34" charset="-120"/>
               </a:rPr>
-              <a:t>Reward and Penalty Design</a:t>
+              <a:t>How the formula updates action values from reward and future return</a:t>
             </a:r>
             <a:endParaRPr lang="en-US" sz="1200" dirty="0"/>
           </a:p>
@@ -3881,7 +3881,7 @@
       </p:grpSpPr>
       <p:pic>
         <p:nvPicPr>
-          <p:cNvPr id="2" name="Image 0" descr="/Users/fengruiding/Desktop/cs520/project/ppt_3pages/pacman_neon_bg.png">    </p:cNvPr>
+          <p:cNvPr id="2" name="Image 0" descr="/Users/fengruiding/Desktop/cs520/project/ppt_3pages/images/pacman_neon_bg.png">    </p:cNvPr>
           <p:cNvPicPr>
             <a:picLocks noChangeAspect="1"/>
           </p:cNvPicPr>

</xml_diff>

<commit_message>
refine project overview slide
</commit_message>
<xml_diff>
--- a/ppt_3pages/pacman_rl_3slides.pptx
+++ b/ppt_3pages/pacman_rl_3slides.pptx
@@ -8,9 +8,10 @@
     <p:sldId id="256" r:id="rId2"/>
     <p:sldId id="257" r:id="rId3"/>
     <p:sldId id="258" r:id="rId4"/>
+    <p:sldId id="259" r:id="rId5"/>
   </p:sldIdLst>
   <p:notesMasterIdLst>
-    <p:notesMasterId r:id="rId5"/>
+    <p:notesMasterId r:id="rId6"/>
   </p:notesMasterIdLst>
   <p:sldSz cx="12192000" cy="6858000"/>
   <p:notesSz cx="6858000" cy="12192000"/>
@@ -704,6 +705,94 @@
             <a:fld id="{F7021451-1387-4CA6-816F-3879F97B5CBC}" type="slidenum">
               <a:rPr lang="en-US"/>
               <a:t>3</a:t>
+            </a:fld>
+            <a:endParaRPr lang="en-US"/>
+          </a:p>
+        </p:txBody>
+      </p:sp>
+    </p:spTree>
+    <p:extLst>
+      <p:ext uri="{BB962C8B-B14F-4D97-AF65-F5344CB8AC3E}">
+        <p14:creationId xmlns:p14="http://schemas.microsoft.com/office/powerpoint/2010/main" val="1024086991"/>
+      </p:ext>
+    </p:extLst>
+  </p:cSld>
+  <p:clrMapOvr>
+    <a:masterClrMapping/>
+  </p:clrMapOvr>
+</p:notes>
+</file>
+
+<file path=ppt/notesSlides/notesSlide4.xml><?xml version="1.0" encoding="utf-8"?>
+<p:notes xmlns:a="http://schemas.openxmlformats.org/drawingml/2006/main" xmlns:r="http://schemas.openxmlformats.org/officeDocument/2006/relationships" xmlns:p="http://schemas.openxmlformats.org/presentationml/2006/main">
+  <p:cSld>
+    <p:spTree>
+      <p:nvGrpSpPr>
+        <p:cNvPr id="1" name=""/>
+        <p:cNvGrpSpPr/>
+        <p:nvPr/>
+      </p:nvGrpSpPr>
+      <p:grpSpPr>
+        <a:xfrm>
+          <a:off x="0" y="0"/>
+          <a:ext cx="0" cy="0"/>
+          <a:chOff x="0" y="0"/>
+          <a:chExt cx="0" cy="0"/>
+        </a:xfrm>
+      </p:grpSpPr>
+      <p:sp>
+        <p:nvSpPr>
+          <p:cNvPr id="2" name="Slide Image Placeholder 1"/>
+          <p:cNvSpPr>
+            <a:spLocks noGrp="1" noRot="1" noChangeAspect="1"/>
+          </p:cNvSpPr>
+          <p:nvPr>
+            <p:ph type="sldImg"/>
+          </p:nvPr>
+        </p:nvSpPr>
+        <p:spPr/>
+      </p:sp>
+      <p:sp>
+        <p:nvSpPr>
+          <p:cNvPr id="3" name="Notes Placeholder 2"/>
+          <p:cNvSpPr>
+            <a:spLocks noGrp="1"/>
+          </p:cNvSpPr>
+          <p:nvPr>
+            <p:ph type="body" idx="1"/>
+          </p:nvPr>
+        </p:nvSpPr>
+        <p:spPr/>
+        <p:txBody>
+          <a:bodyPr/>
+          <a:lstStyle/>
+          <a:p>
+            <a:r>
+              <a:rPr lang="en-US" dirty="0"/>
+              <a:t/>
+            </a:r>
+            <a:endParaRPr lang="en-US" dirty="0"/>
+          </a:p>
+        </p:txBody>
+      </p:sp>
+      <p:sp>
+        <p:nvSpPr>
+          <p:cNvPr id="4" name="Slide Number Placeholder 3"/>
+          <p:cNvSpPr>
+            <a:spLocks noGrp="1"/>
+          </p:cNvSpPr>
+          <p:nvPr>
+            <p:ph type="sldNum" sz="quarter" idx="10"/>
+          </p:nvPr>
+        </p:nvSpPr>
+        <p:spPr/>
+        <p:txBody>
+          <a:bodyPr/>
+          <a:lstStyle/>
+          <a:p>
+            <a:fld id="{F7021451-1387-4CA6-816F-3879F97B5CBC}" type="slidenum">
+              <a:rPr lang="en-US"/>
+              <a:t>4</a:t>
             </a:fld>
             <a:endParaRPr lang="en-US"/>
           </a:p>
@@ -1079,7 +1168,36 @@
       </p:pic>
       <p:sp>
         <p:nvSpPr>
-          <p:cNvPr id="3" name="Text 0"/>
+          <p:cNvPr id="3" name="Shape 0"/>
+          <p:cNvSpPr/>
+          <p:nvPr/>
+        </p:nvSpPr>
+        <p:spPr>
+          <a:xfrm>
+            <a:off x="0" y="0"/>
+            <a:ext cx="12191695" cy="6858000"/>
+          </a:xfrm>
+          <a:prstGeom prst="rect">
+            <a:avLst/>
+          </a:prstGeom>
+          <a:solidFill>
+            <a:srgbClr val="000000">
+              <a:alpha val="42000"/>
+            </a:srgbClr>
+          </a:solidFill>
+          <a:ln w="12700">
+            <a:solidFill>
+              <a:srgbClr val="000000">
+                <a:alpha val="0"/>
+              </a:srgbClr>
+            </a:solidFill>
+            <a:prstDash val="solid"/>
+          </a:ln>
+        </p:spPr>
+      </p:sp>
+      <p:sp>
+        <p:nvSpPr>
+          <p:cNvPr id="4" name="Text 1"/>
           <p:cNvSpPr/>
           <p:nvPr/>
         </p:nvSpPr>
@@ -1110,7 +1228,7 @@
                 <a:ea typeface="Arial" pitchFamily="34" charset="-122"/>
                 <a:cs typeface="Arial" pitchFamily="34" charset="-120"/>
               </a:rPr>
-              <a:t>Game Rules and Scoring</a:t>
+              <a:t>Project Overview</a:t>
             </a:r>
             <a:endParaRPr lang="en-US" sz="2400" dirty="0"/>
           </a:p>
@@ -1118,7 +1236,7 @@
       </p:sp>
       <p:sp>
         <p:nvSpPr>
-          <p:cNvPr id="4" name="Shape 1"/>
+          <p:cNvPr id="5" name="Shape 2"/>
           <p:cNvSpPr/>
           <p:nvPr/>
         </p:nvSpPr>
@@ -1133,7 +1251,7 @@
           <a:noFill/>
           <a:ln w="12700">
             <a:solidFill>
-              <a:srgbClr val="1E88E5">
+              <a:srgbClr val="F4B400">
                 <a:alpha val="72000"/>
               </a:srgbClr>
             </a:solidFill>
@@ -1143,18 +1261,18 @@
       </p:sp>
       <p:sp>
         <p:nvSpPr>
-          <p:cNvPr id="5" name="Shape 2"/>
-          <p:cNvSpPr/>
-          <p:nvPr/>
-        </p:nvSpPr>
-        <p:spPr>
-          <a:xfrm>
-            <a:off x="640080" y="1828800"/>
-            <a:ext cx="1783080" cy="932688"/>
+          <p:cNvPr id="6" name="Shape 3"/>
+          <p:cNvSpPr/>
+          <p:nvPr/>
+        </p:nvSpPr>
+        <p:spPr>
+          <a:xfrm>
+            <a:off x="640080" y="1444752"/>
+            <a:ext cx="10927080" cy="658368"/>
           </a:xfrm>
           <a:prstGeom prst="roundRect">
             <a:avLst>
-              <a:gd name="adj" fmla="val 7843"/>
+              <a:gd name="adj" fmla="val 11111"/>
             </a:avLst>
           </a:prstGeom>
           <a:solidFill>
@@ -1164,7 +1282,7 @@
           </a:solidFill>
           <a:ln w="12700">
             <a:solidFill>
-              <a:srgbClr val="D93025"/>
+              <a:srgbClr val="F4B400"/>
             </a:solidFill>
             <a:prstDash val="solid"/>
           </a:ln>
@@ -1172,14 +1290,14 @@
       </p:sp>
       <p:sp>
         <p:nvSpPr>
-          <p:cNvPr id="6" name="Text 3"/>
-          <p:cNvSpPr/>
-          <p:nvPr/>
-        </p:nvSpPr>
-        <p:spPr>
-          <a:xfrm>
-            <a:off x="822960" y="1975104"/>
-            <a:ext cx="1417320" cy="201168"/>
+          <p:cNvPr id="7" name="Text 4"/>
+          <p:cNvSpPr/>
+          <p:nvPr/>
+        </p:nvSpPr>
+        <p:spPr>
+          <a:xfrm>
+            <a:off x="896112" y="1609344"/>
+            <a:ext cx="10415016" cy="438912"/>
           </a:xfrm>
           <a:prstGeom prst="rect">
             <a:avLst/>
@@ -1195,7 +1313,46 @@
               <a:buNone/>
             </a:pPr>
             <a:r>
-              <a:rPr lang="en-US" sz="1000" b="1" dirty="0">
+              <a:rPr lang="en-US" sz="1900" b="1" dirty="0">
+                <a:solidFill>
+                  <a:srgbClr val="FFFFFF"/>
+                </a:solidFill>
+                <a:latin typeface="Arial" pitchFamily="34" charset="0"/>
+                <a:ea typeface="Arial" pitchFamily="34" charset="-122"/>
+                <a:cs typeface="Arial" pitchFamily="34" charset="-120"/>
+              </a:rPr>
+              <a:t>Decision-Theoretic Navigation Under Uncertainty in Dynamic Grids</a:t>
+            </a:r>
+            <a:endParaRPr lang="en-US" sz="1900" dirty="0"/>
+          </a:p>
+        </p:txBody>
+      </p:sp>
+      <p:sp>
+        <p:nvSpPr>
+          <p:cNvPr id="8" name="Text 5"/>
+          <p:cNvSpPr/>
+          <p:nvPr/>
+        </p:nvSpPr>
+        <p:spPr>
+          <a:xfrm>
+            <a:off x="640080" y="2359152"/>
+            <a:ext cx="2011680" cy="219456"/>
+          </a:xfrm>
+          <a:prstGeom prst="rect">
+            <a:avLst/>
+          </a:prstGeom>
+          <a:noFill/>
+          <a:ln/>
+        </p:spPr>
+        <p:txBody>
+          <a:bodyPr wrap="square" lIns="0" tIns="0" rIns="0" bIns="0" rtlCol="0" anchor="ctr"/>
+          <a:lstStyle/>
+          <a:p>
+            <a:pPr indent="0" marL="0">
+              <a:buNone/>
+            </a:pPr>
+            <a:r>
+              <a:rPr lang="en-US" sz="1200" b="1" dirty="0">
                 <a:solidFill>
                   <a:srgbClr val="D8E2EE"/>
                 </a:solidFill>
@@ -1203,137 +1360,26 @@
                 <a:ea typeface="Arial" pitchFamily="34" charset="-122"/>
                 <a:cs typeface="Arial" pitchFamily="34" charset="-120"/>
               </a:rPr>
-              <a:t>LIVES</a:t>
-            </a:r>
-            <a:endParaRPr lang="en-US" sz="1000" dirty="0"/>
-          </a:p>
-        </p:txBody>
-      </p:sp>
-      <p:pic>
-        <p:nvPicPr>
-          <p:cNvPr id="7" name="Image 1" descr="/Users/fengruiding/Desktop/cs520/project/pacman/public/icon/favicon.png">    </p:cNvPr>
-          <p:cNvPicPr>
-            <a:picLocks noChangeAspect="1"/>
-          </p:cNvPicPr>
-          <p:nvPr/>
-        </p:nvPicPr>
-        <p:blipFill>
-          <a:blip r:embed="rId2"/>
-          <a:stretch>
-            <a:fillRect/>
-          </a:stretch>
-        </p:blipFill>
-        <p:spPr>
-          <a:xfrm>
-            <a:off x="1088136" y="2194560"/>
-            <a:ext cx="246888" cy="246888"/>
-          </a:xfrm>
-          <a:prstGeom prst="rect">
-            <a:avLst/>
-          </a:prstGeom>
-        </p:spPr>
-      </p:pic>
-      <p:pic>
-        <p:nvPicPr>
-          <p:cNvPr id="8" name="Image 2" descr="/Users/fengruiding/Desktop/cs520/project/pacman/public/icon/favicon.png">    </p:cNvPr>
-          <p:cNvPicPr>
-            <a:picLocks noChangeAspect="1"/>
-          </p:cNvPicPr>
-          <p:nvPr/>
-        </p:nvPicPr>
-        <p:blipFill>
-          <a:blip r:embed="rId3"/>
-          <a:stretch>
-            <a:fillRect/>
-          </a:stretch>
-        </p:blipFill>
-        <p:spPr>
-          <a:xfrm>
-            <a:off x="1408176" y="2194560"/>
-            <a:ext cx="246888" cy="246888"/>
-          </a:xfrm>
-          <a:prstGeom prst="rect">
-            <a:avLst/>
-          </a:prstGeom>
-        </p:spPr>
-      </p:pic>
-      <p:pic>
-        <p:nvPicPr>
-          <p:cNvPr id="9" name="Image 3" descr="/Users/fengruiding/Desktop/cs520/project/pacman/public/icon/favicon.png">    </p:cNvPr>
-          <p:cNvPicPr>
-            <a:picLocks noChangeAspect="1"/>
-          </p:cNvPicPr>
-          <p:nvPr/>
-        </p:nvPicPr>
-        <p:blipFill>
-          <a:blip r:embed="rId4"/>
-          <a:stretch>
-            <a:fillRect/>
-          </a:stretch>
-        </p:blipFill>
-        <p:spPr>
-          <a:xfrm>
-            <a:off x="1728216" y="2194560"/>
-            <a:ext cx="246888" cy="246888"/>
-          </a:xfrm>
-          <a:prstGeom prst="rect">
-            <a:avLst/>
-          </a:prstGeom>
-        </p:spPr>
-      </p:pic>
-      <p:sp>
-        <p:nvSpPr>
-          <p:cNvPr id="10" name="Text 4"/>
-          <p:cNvSpPr/>
-          <p:nvPr/>
-        </p:nvSpPr>
-        <p:spPr>
-          <a:xfrm>
-            <a:off x="804672" y="2496312"/>
-            <a:ext cx="1453896" cy="182880"/>
-          </a:xfrm>
-          <a:prstGeom prst="rect">
-            <a:avLst/>
-          </a:prstGeom>
-          <a:noFill/>
-          <a:ln/>
-        </p:spPr>
-        <p:txBody>
-          <a:bodyPr wrap="square" lIns="0" tIns="0" rIns="0" bIns="0" rtlCol="0" anchor="ctr"/>
-          <a:lstStyle/>
-          <a:p>
-            <a:pPr algn="ctr" indent="0" marL="0">
-              <a:buNone/>
-            </a:pPr>
-            <a:r>
-              <a:rPr lang="en-US" sz="1100" b="1" dirty="0">
-                <a:solidFill>
-                  <a:srgbClr val="FFFFFF"/>
-                </a:solidFill>
-                <a:latin typeface="Arial" pitchFamily="34" charset="0"/>
-                <a:ea typeface="Arial" pitchFamily="34" charset="-122"/>
-                <a:cs typeface="Arial" pitchFamily="34" charset="-120"/>
-              </a:rPr>
-              <a:t>3 lives</a:t>
-            </a:r>
-            <a:endParaRPr lang="en-US" sz="1100" dirty="0"/>
-          </a:p>
-        </p:txBody>
-      </p:sp>
-      <p:sp>
-        <p:nvSpPr>
-          <p:cNvPr id="11" name="Shape 5"/>
-          <p:cNvSpPr/>
-          <p:nvPr/>
-        </p:nvSpPr>
-        <p:spPr>
-          <a:xfrm>
-            <a:off x="2606040" y="1828800"/>
-            <a:ext cx="1783080" cy="932688"/>
+              <a:t>Participants</a:t>
+            </a:r>
+            <a:endParaRPr lang="en-US" sz="1200" dirty="0"/>
+          </a:p>
+        </p:txBody>
+      </p:sp>
+      <p:sp>
+        <p:nvSpPr>
+          <p:cNvPr id="9" name="Shape 6"/>
+          <p:cNvSpPr/>
+          <p:nvPr/>
+        </p:nvSpPr>
+        <p:spPr>
+          <a:xfrm>
+            <a:off x="640080" y="2633472"/>
+            <a:ext cx="2926080" cy="841248"/>
           </a:xfrm>
           <a:prstGeom prst="roundRect">
             <a:avLst>
-              <a:gd name="adj" fmla="val 7843"/>
+              <a:gd name="adj" fmla="val 8696"/>
             </a:avLst>
           </a:prstGeom>
           <a:solidFill>
@@ -1351,14 +1397,14 @@
       </p:sp>
       <p:sp>
         <p:nvSpPr>
-          <p:cNvPr id="12" name="Text 6"/>
-          <p:cNvSpPr/>
-          <p:nvPr/>
-        </p:nvSpPr>
-        <p:spPr>
-          <a:xfrm>
-            <a:off x="2788920" y="1975104"/>
-            <a:ext cx="1417320" cy="182880"/>
+          <p:cNvPr id="10" name="Text 7"/>
+          <p:cNvSpPr/>
+          <p:nvPr/>
+        </p:nvSpPr>
+        <p:spPr>
+          <a:xfrm>
+            <a:off x="804672" y="2907792"/>
+            <a:ext cx="2596896" cy="219456"/>
           </a:xfrm>
           <a:prstGeom prst="rect">
             <a:avLst/>
@@ -1370,239 +1416,38 @@
           <a:bodyPr wrap="square" lIns="0" tIns="0" rIns="0" bIns="0" rtlCol="0" anchor="ctr"/>
           <a:lstStyle/>
           <a:p>
-            <a:pPr indent="0" marL="0">
-              <a:buNone/>
-            </a:pPr>
-            <a:r>
-              <a:rPr lang="en-US" sz="1000" b="1" dirty="0">
-                <a:solidFill>
-                  <a:srgbClr val="D8E2EE"/>
-                </a:solidFill>
-                <a:latin typeface="Arial" pitchFamily="34" charset="0"/>
-                <a:ea typeface="Arial" pitchFamily="34" charset="-122"/>
-                <a:cs typeface="Arial" pitchFamily="34" charset="-120"/>
-              </a:rPr>
-              <a:t>PELLET</a:t>
-            </a:r>
-            <a:endParaRPr lang="en-US" sz="1000" dirty="0"/>
-          </a:p>
-        </p:txBody>
-      </p:sp>
-      <p:sp>
-        <p:nvSpPr>
-          <p:cNvPr id="13" name="Shape 7"/>
-          <p:cNvSpPr/>
-          <p:nvPr/>
-        </p:nvSpPr>
-        <p:spPr>
-          <a:xfrm>
-            <a:off x="2962656" y="2258568"/>
-            <a:ext cx="64008" cy="64008"/>
-          </a:xfrm>
-          <a:prstGeom prst="ellipse">
-            <a:avLst/>
-          </a:prstGeom>
-          <a:solidFill>
-            <a:srgbClr val="F7C5C0"/>
-          </a:solidFill>
-          <a:ln w="12700">
-            <a:solidFill>
-              <a:srgbClr val="F7C5C0">
-                <a:alpha val="0"/>
-              </a:srgbClr>
-            </a:solidFill>
-            <a:prstDash val="solid"/>
-          </a:ln>
-        </p:spPr>
-      </p:sp>
-      <p:sp>
-        <p:nvSpPr>
-          <p:cNvPr id="14" name="Shape 8"/>
-          <p:cNvSpPr/>
-          <p:nvPr/>
-        </p:nvSpPr>
-        <p:spPr>
-          <a:xfrm>
-            <a:off x="3163824" y="2258568"/>
-            <a:ext cx="64008" cy="64008"/>
-          </a:xfrm>
-          <a:prstGeom prst="ellipse">
-            <a:avLst/>
-          </a:prstGeom>
-          <a:solidFill>
-            <a:srgbClr val="F7C5C0"/>
-          </a:solidFill>
-          <a:ln w="12700">
-            <a:solidFill>
-              <a:srgbClr val="F7C5C0">
-                <a:alpha val="0"/>
-              </a:srgbClr>
-            </a:solidFill>
-            <a:prstDash val="solid"/>
-          </a:ln>
-        </p:spPr>
-      </p:sp>
-      <p:sp>
-        <p:nvSpPr>
-          <p:cNvPr id="15" name="Shape 9"/>
-          <p:cNvSpPr/>
-          <p:nvPr/>
-        </p:nvSpPr>
-        <p:spPr>
-          <a:xfrm>
-            <a:off x="3364992" y="2258568"/>
-            <a:ext cx="64008" cy="64008"/>
-          </a:xfrm>
-          <a:prstGeom prst="ellipse">
-            <a:avLst/>
-          </a:prstGeom>
-          <a:solidFill>
-            <a:srgbClr val="F7C5C0"/>
-          </a:solidFill>
-          <a:ln w="12700">
-            <a:solidFill>
-              <a:srgbClr val="F7C5C0">
-                <a:alpha val="0"/>
-              </a:srgbClr>
-            </a:solidFill>
-            <a:prstDash val="solid"/>
-          </a:ln>
-        </p:spPr>
-      </p:sp>
-      <p:sp>
-        <p:nvSpPr>
-          <p:cNvPr id="16" name="Shape 10"/>
-          <p:cNvSpPr/>
-          <p:nvPr/>
-        </p:nvSpPr>
-        <p:spPr>
-          <a:xfrm>
-            <a:off x="3566160" y="2258568"/>
-            <a:ext cx="64008" cy="64008"/>
-          </a:xfrm>
-          <a:prstGeom prst="ellipse">
-            <a:avLst/>
-          </a:prstGeom>
-          <a:solidFill>
-            <a:srgbClr val="F7C5C0"/>
-          </a:solidFill>
-          <a:ln w="12700">
-            <a:solidFill>
-              <a:srgbClr val="F7C5C0">
-                <a:alpha val="0"/>
-              </a:srgbClr>
-            </a:solidFill>
-            <a:prstDash val="solid"/>
-          </a:ln>
-        </p:spPr>
-      </p:sp>
-      <p:sp>
-        <p:nvSpPr>
-          <p:cNvPr id="17" name="Shape 11"/>
-          <p:cNvSpPr/>
-          <p:nvPr/>
-        </p:nvSpPr>
-        <p:spPr>
-          <a:xfrm>
-            <a:off x="3767328" y="2258568"/>
-            <a:ext cx="64008" cy="64008"/>
-          </a:xfrm>
-          <a:prstGeom prst="ellipse">
-            <a:avLst/>
-          </a:prstGeom>
-          <a:solidFill>
-            <a:srgbClr val="F7C5C0"/>
-          </a:solidFill>
-          <a:ln w="12700">
-            <a:solidFill>
-              <a:srgbClr val="F7C5C0">
-                <a:alpha val="0"/>
-              </a:srgbClr>
-            </a:solidFill>
-            <a:prstDash val="solid"/>
-          </a:ln>
-        </p:spPr>
-      </p:sp>
-      <p:sp>
-        <p:nvSpPr>
-          <p:cNvPr id="18" name="Shape 12"/>
-          <p:cNvSpPr/>
-          <p:nvPr/>
-        </p:nvSpPr>
-        <p:spPr>
-          <a:xfrm>
-            <a:off x="3968496" y="2258568"/>
-            <a:ext cx="64008" cy="64008"/>
-          </a:xfrm>
-          <a:prstGeom prst="ellipse">
-            <a:avLst/>
-          </a:prstGeom>
-          <a:solidFill>
-            <a:srgbClr val="F7C5C0"/>
-          </a:solidFill>
-          <a:ln w="12700">
-            <a:solidFill>
-              <a:srgbClr val="F7C5C0">
-                <a:alpha val="0"/>
-              </a:srgbClr>
-            </a:solidFill>
-            <a:prstDash val="solid"/>
-          </a:ln>
-        </p:spPr>
-      </p:sp>
-      <p:sp>
-        <p:nvSpPr>
-          <p:cNvPr id="19" name="Text 13"/>
-          <p:cNvSpPr/>
-          <p:nvPr/>
-        </p:nvSpPr>
-        <p:spPr>
-          <a:xfrm>
-            <a:off x="2770632" y="2459736"/>
-            <a:ext cx="1453896" cy="182880"/>
-          </a:xfrm>
-          <a:prstGeom prst="rect">
-            <a:avLst/>
-          </a:prstGeom>
-          <a:noFill/>
-          <a:ln/>
-        </p:spPr>
-        <p:txBody>
-          <a:bodyPr wrap="square" lIns="0" tIns="0" rIns="0" bIns="0" rtlCol="0" anchor="ctr"/>
-          <a:lstStyle/>
-          <a:p>
             <a:pPr algn="ctr" indent="0" marL="0">
               <a:buNone/>
             </a:pPr>
             <a:r>
-              <a:rPr lang="en-US" sz="2100" b="1" dirty="0">
-                <a:solidFill>
-                  <a:srgbClr val="FFFFFF"/>
-                </a:solidFill>
-                <a:latin typeface="Arial" pitchFamily="34" charset="0"/>
-                <a:ea typeface="Arial" pitchFamily="34" charset="-122"/>
-                <a:cs typeface="Arial" pitchFamily="34" charset="-120"/>
-              </a:rPr>
-              <a:t>＋10</a:t>
-            </a:r>
-            <a:endParaRPr lang="en-US" sz="2100" dirty="0"/>
-          </a:p>
-        </p:txBody>
-      </p:sp>
-      <p:sp>
-        <p:nvSpPr>
-          <p:cNvPr id="20" name="Shape 14"/>
-          <p:cNvSpPr/>
-          <p:nvPr/>
-        </p:nvSpPr>
-        <p:spPr>
-          <a:xfrm>
-            <a:off x="4572000" y="1828800"/>
-            <a:ext cx="1965960" cy="932688"/>
+              <a:rPr lang="en-US" sz="1700" b="1" dirty="0">
+                <a:solidFill>
+                  <a:srgbClr val="FFFFFF"/>
+                </a:solidFill>
+                <a:latin typeface="Arial" pitchFamily="34" charset="0"/>
+                <a:ea typeface="Arial" pitchFamily="34" charset="-122"/>
+                <a:cs typeface="Arial" pitchFamily="34" charset="-120"/>
+              </a:rPr>
+              <a:t>Michael Liu</a:t>
+            </a:r>
+            <a:endParaRPr lang="en-US" sz="1700" dirty="0"/>
+          </a:p>
+        </p:txBody>
+      </p:sp>
+      <p:sp>
+        <p:nvSpPr>
+          <p:cNvPr id="11" name="Shape 8"/>
+          <p:cNvSpPr/>
+          <p:nvPr/>
+        </p:nvSpPr>
+        <p:spPr>
+          <a:xfrm>
+            <a:off x="4014216" y="2633472"/>
+            <a:ext cx="2926080" cy="841248"/>
           </a:xfrm>
           <a:prstGeom prst="roundRect">
             <a:avLst>
-              <a:gd name="adj" fmla="val 7843"/>
+              <a:gd name="adj" fmla="val 8696"/>
             </a:avLst>
           </a:prstGeom>
           <a:solidFill>
@@ -1620,14 +1465,14 @@
       </p:sp>
       <p:sp>
         <p:nvSpPr>
-          <p:cNvPr id="21" name="Text 15"/>
-          <p:cNvSpPr/>
-          <p:nvPr/>
-        </p:nvSpPr>
-        <p:spPr>
-          <a:xfrm>
-            <a:off x="4754880" y="1975104"/>
-            <a:ext cx="1600200" cy="182880"/>
+          <p:cNvPr id="12" name="Text 9"/>
+          <p:cNvSpPr/>
+          <p:nvPr/>
+        </p:nvSpPr>
+        <p:spPr>
+          <a:xfrm>
+            <a:off x="4178808" y="2907792"/>
+            <a:ext cx="2596896" cy="219456"/>
           </a:xfrm>
           <a:prstGeom prst="rect">
             <a:avLst/>
@@ -1639,104 +1484,38 @@
           <a:bodyPr wrap="square" lIns="0" tIns="0" rIns="0" bIns="0" rtlCol="0" anchor="ctr"/>
           <a:lstStyle/>
           <a:p>
-            <a:pPr indent="0" marL="0">
-              <a:buNone/>
-            </a:pPr>
-            <a:r>
-              <a:rPr lang="en-US" sz="1000" b="1" dirty="0">
-                <a:solidFill>
-                  <a:srgbClr val="D8E2EE"/>
-                </a:solidFill>
-                <a:latin typeface="Arial" pitchFamily="34" charset="0"/>
-                <a:ea typeface="Arial" pitchFamily="34" charset="-122"/>
-                <a:cs typeface="Arial" pitchFamily="34" charset="-120"/>
-              </a:rPr>
-              <a:t>ENERGIZER</a:t>
-            </a:r>
-            <a:endParaRPr lang="en-US" sz="1000" dirty="0"/>
-          </a:p>
-        </p:txBody>
-      </p:sp>
-      <p:sp>
-        <p:nvSpPr>
-          <p:cNvPr id="22" name="Shape 16"/>
-          <p:cNvSpPr/>
-          <p:nvPr/>
-        </p:nvSpPr>
-        <p:spPr>
-          <a:xfrm>
-            <a:off x="5454396" y="2185416"/>
-            <a:ext cx="201168" cy="201168"/>
-          </a:xfrm>
-          <a:prstGeom prst="ellipse">
-            <a:avLst/>
-          </a:prstGeom>
-          <a:solidFill>
-            <a:srgbClr val="F7C5C0"/>
-          </a:solidFill>
-          <a:ln w="12700">
-            <a:solidFill>
-              <a:srgbClr val="F7C5C0">
-                <a:alpha val="0"/>
-              </a:srgbClr>
-            </a:solidFill>
-            <a:prstDash val="solid"/>
-          </a:ln>
-        </p:spPr>
-      </p:sp>
-      <p:sp>
-        <p:nvSpPr>
-          <p:cNvPr id="23" name="Text 17"/>
-          <p:cNvSpPr/>
-          <p:nvPr/>
-        </p:nvSpPr>
-        <p:spPr>
-          <a:xfrm>
-            <a:off x="4736592" y="2459736"/>
-            <a:ext cx="1636776" cy="182880"/>
-          </a:xfrm>
-          <a:prstGeom prst="rect">
-            <a:avLst/>
-          </a:prstGeom>
-          <a:noFill/>
-          <a:ln/>
-        </p:spPr>
-        <p:txBody>
-          <a:bodyPr wrap="square" lIns="0" tIns="0" rIns="0" bIns="0" rtlCol="0" anchor="ctr"/>
-          <a:lstStyle/>
-          <a:p>
             <a:pPr algn="ctr" indent="0" marL="0">
               <a:buNone/>
             </a:pPr>
             <a:r>
-              <a:rPr lang="en-US" sz="2100" b="1" dirty="0">
-                <a:solidFill>
-                  <a:srgbClr val="FFFFFF"/>
-                </a:solidFill>
-                <a:latin typeface="Arial" pitchFamily="34" charset="0"/>
-                <a:ea typeface="Arial" pitchFamily="34" charset="-122"/>
-                <a:cs typeface="Arial" pitchFamily="34" charset="-120"/>
-              </a:rPr>
-              <a:t>＋50</a:t>
-            </a:r>
-            <a:endParaRPr lang="en-US" sz="2100" dirty="0"/>
-          </a:p>
-        </p:txBody>
-      </p:sp>
-      <p:sp>
-        <p:nvSpPr>
-          <p:cNvPr id="24" name="Shape 18"/>
-          <p:cNvSpPr/>
-          <p:nvPr/>
-        </p:nvSpPr>
-        <p:spPr>
-          <a:xfrm>
-            <a:off x="6720840" y="1828800"/>
-            <a:ext cx="2423160" cy="932688"/>
+              <a:rPr lang="en-US" sz="1700" b="1" dirty="0">
+                <a:solidFill>
+                  <a:srgbClr val="FFFFFF"/>
+                </a:solidFill>
+                <a:latin typeface="Arial" pitchFamily="34" charset="0"/>
+                <a:ea typeface="Arial" pitchFamily="34" charset="-122"/>
+                <a:cs typeface="Arial" pitchFamily="34" charset="-120"/>
+              </a:rPr>
+              <a:t>Ruiding Feng</a:t>
+            </a:r>
+            <a:endParaRPr lang="en-US" sz="1700" dirty="0"/>
+          </a:p>
+        </p:txBody>
+      </p:sp>
+      <p:sp>
+        <p:nvSpPr>
+          <p:cNvPr id="13" name="Shape 10"/>
+          <p:cNvSpPr/>
+          <p:nvPr/>
+        </p:nvSpPr>
+        <p:spPr>
+          <a:xfrm>
+            <a:off x="7388352" y="2633472"/>
+            <a:ext cx="2926080" cy="841248"/>
           </a:xfrm>
           <a:prstGeom prst="roundRect">
             <a:avLst>
-              <a:gd name="adj" fmla="val 7843"/>
+              <a:gd name="adj" fmla="val 8696"/>
             </a:avLst>
           </a:prstGeom>
           <a:solidFill>
@@ -1754,14 +1533,14 @@
       </p:sp>
       <p:sp>
         <p:nvSpPr>
-          <p:cNvPr id="25" name="Text 19"/>
-          <p:cNvSpPr/>
-          <p:nvPr/>
-        </p:nvSpPr>
-        <p:spPr>
-          <a:xfrm>
-            <a:off x="6903720" y="1975104"/>
-            <a:ext cx="2057400" cy="182880"/>
+          <p:cNvPr id="14" name="Text 11"/>
+          <p:cNvSpPr/>
+          <p:nvPr/>
+        </p:nvSpPr>
+        <p:spPr>
+          <a:xfrm>
+            <a:off x="7552944" y="2907792"/>
+            <a:ext cx="2596896" cy="219456"/>
           </a:xfrm>
           <a:prstGeom prst="rect">
             <a:avLst/>
@@ -1773,101 +1552,204 @@
           <a:bodyPr wrap="square" lIns="0" tIns="0" rIns="0" bIns="0" rtlCol="0" anchor="ctr"/>
           <a:lstStyle/>
           <a:p>
-            <a:pPr indent="0" marL="0">
-              <a:buNone/>
-            </a:pPr>
-            <a:r>
-              <a:rPr lang="en-US" sz="1000" b="1" dirty="0">
-                <a:solidFill>
-                  <a:srgbClr val="D8E2EE"/>
-                </a:solidFill>
-                <a:latin typeface="Arial" pitchFamily="34" charset="0"/>
-                <a:ea typeface="Arial" pitchFamily="34" charset="-122"/>
-                <a:cs typeface="Arial" pitchFamily="34" charset="-120"/>
-              </a:rPr>
-              <a:t>GHOST BONUS</a:t>
-            </a:r>
-            <a:endParaRPr lang="en-US" sz="1000" dirty="0"/>
-          </a:p>
-        </p:txBody>
-      </p:sp>
-      <p:pic>
-        <p:nvPicPr>
-          <p:cNvPr id="26" name="Image 4" descr="/Users/fengruiding/Desktop/cs520/project/ppt_3pages/images/ui_ghost_blue.png">    </p:cNvPr>
-          <p:cNvPicPr>
-            <a:picLocks noChangeAspect="1"/>
-          </p:cNvPicPr>
-          <p:nvPr/>
-        </p:nvPicPr>
-        <p:blipFill>
-          <a:blip r:embed="rId5"/>
-          <a:stretch>
-            <a:fillRect/>
-          </a:stretch>
-        </p:blipFill>
-        <p:spPr>
-          <a:xfrm>
-            <a:off x="7804404" y="2185416"/>
-            <a:ext cx="256032" cy="256032"/>
-          </a:xfrm>
-          <a:prstGeom prst="rect">
-            <a:avLst/>
-          </a:prstGeom>
-        </p:spPr>
-      </p:pic>
-      <p:sp>
-        <p:nvSpPr>
-          <p:cNvPr id="27" name="Text 20"/>
-          <p:cNvSpPr/>
-          <p:nvPr/>
-        </p:nvSpPr>
-        <p:spPr>
-          <a:xfrm>
-            <a:off x="6867144" y="2478024"/>
-            <a:ext cx="2130552" cy="146304"/>
-          </a:xfrm>
-          <a:prstGeom prst="rect">
-            <a:avLst/>
-          </a:prstGeom>
-          <a:noFill/>
-          <a:ln/>
-        </p:spPr>
-        <p:txBody>
-          <a:bodyPr wrap="square" lIns="0" tIns="0" rIns="0" bIns="0" rtlCol="0" anchor="ctr"/>
-          <a:lstStyle/>
-          <a:p>
             <a:pPr algn="ctr" indent="0" marL="0">
               <a:buNone/>
             </a:pPr>
             <a:r>
-              <a:rPr lang="en-US" sz="1000" b="1" dirty="0">
-                <a:solidFill>
-                  <a:srgbClr val="FFFFFF"/>
-                </a:solidFill>
-                <a:latin typeface="Arial" pitchFamily="34" charset="0"/>
-                <a:ea typeface="Arial" pitchFamily="34" charset="-122"/>
-                <a:cs typeface="Arial" pitchFamily="34" charset="-120"/>
-              </a:rPr>
-              <a:t>+200 / +400 / +800 / +1600</a:t>
-            </a:r>
-            <a:endParaRPr lang="en-US" sz="1000" dirty="0"/>
-          </a:p>
-        </p:txBody>
-      </p:sp>
-      <p:sp>
-        <p:nvSpPr>
-          <p:cNvPr id="28" name="Shape 21"/>
-          <p:cNvSpPr/>
-          <p:nvPr/>
-        </p:nvSpPr>
-        <p:spPr>
-          <a:xfrm>
-            <a:off x="9326880" y="1828800"/>
-            <a:ext cx="2240280" cy="932688"/>
+              <a:rPr lang="en-US" sz="1700" b="1" dirty="0">
+                <a:solidFill>
+                  <a:srgbClr val="FFFFFF"/>
+                </a:solidFill>
+                <a:latin typeface="Arial" pitchFamily="34" charset="0"/>
+                <a:ea typeface="Arial" pitchFamily="34" charset="-122"/>
+                <a:cs typeface="Arial" pitchFamily="34" charset="-120"/>
+              </a:rPr>
+              <a:t>Zhichun Xiao</a:t>
+            </a:r>
+            <a:endParaRPr lang="en-US" sz="1700" dirty="0"/>
+          </a:p>
+        </p:txBody>
+      </p:sp>
+      <p:sp>
+        <p:nvSpPr>
+          <p:cNvPr id="15" name="Shape 12"/>
+          <p:cNvSpPr/>
+          <p:nvPr/>
+        </p:nvSpPr>
+        <p:spPr>
+          <a:xfrm>
+            <a:off x="640080" y="3767328"/>
+            <a:ext cx="10927080" cy="1499616"/>
           </a:xfrm>
           <a:prstGeom prst="roundRect">
             <a:avLst>
-              <a:gd name="adj" fmla="val 7843"/>
+              <a:gd name="adj" fmla="val 4878"/>
+            </a:avLst>
+          </a:prstGeom>
+          <a:solidFill>
+            <a:srgbClr val="1A2030">
+              <a:alpha val="80000"/>
+            </a:srgbClr>
+          </a:solidFill>
+          <a:ln w="12700">
+            <a:solidFill>
+              <a:srgbClr val="16A085"/>
+            </a:solidFill>
+            <a:prstDash val="solid"/>
+          </a:ln>
+        </p:spPr>
+      </p:sp>
+      <p:sp>
+        <p:nvSpPr>
+          <p:cNvPr id="16" name="Text 13"/>
+          <p:cNvSpPr/>
+          <p:nvPr/>
+        </p:nvSpPr>
+        <p:spPr>
+          <a:xfrm>
+            <a:off x="868680" y="3968496"/>
+            <a:ext cx="10469880" cy="274320"/>
+          </a:xfrm>
+          <a:prstGeom prst="rect">
+            <a:avLst/>
+          </a:prstGeom>
+          <a:noFill/>
+          <a:ln/>
+        </p:spPr>
+        <p:txBody>
+          <a:bodyPr wrap="square" lIns="0" tIns="0" rIns="0" bIns="0" rtlCol="0" anchor="ctr"/>
+          <a:lstStyle/>
+          <a:p>
+            <a:pPr indent="0" marL="0">
+              <a:buNone/>
+            </a:pPr>
+            <a:r>
+              <a:rPr lang="en-US" sz="1800" b="1" dirty="0">
+                <a:solidFill>
+                  <a:srgbClr val="FFFFFF"/>
+                </a:solidFill>
+                <a:latin typeface="Arial" pitchFamily="34" charset="0"/>
+                <a:ea typeface="Arial" pitchFamily="34" charset="-122"/>
+                <a:cs typeface="Arial" pitchFamily="34" charset="-120"/>
+              </a:rPr>
+              <a:t>Major Objective</a:t>
+            </a:r>
+            <a:endParaRPr lang="en-US" sz="1800" dirty="0"/>
+          </a:p>
+        </p:txBody>
+      </p:sp>
+      <p:sp>
+        <p:nvSpPr>
+          <p:cNvPr id="17" name="Shape 14"/>
+          <p:cNvSpPr/>
+          <p:nvPr/>
+        </p:nvSpPr>
+        <p:spPr>
+          <a:xfrm>
+            <a:off x="868680" y="4334256"/>
+            <a:ext cx="10469880" cy="0"/>
+          </a:xfrm>
+          <a:prstGeom prst="line">
+            <a:avLst/>
+          </a:prstGeom>
+          <a:noFill/>
+          <a:ln w="12700">
+            <a:solidFill>
+              <a:srgbClr val="16A085">
+                <a:alpha val="82000"/>
+              </a:srgbClr>
+            </a:solidFill>
+            <a:prstDash val="solid"/>
+          </a:ln>
+        </p:spPr>
+      </p:sp>
+      <p:sp>
+        <p:nvSpPr>
+          <p:cNvPr id="18" name="Text 15"/>
+          <p:cNvSpPr/>
+          <p:nvPr/>
+        </p:nvSpPr>
+        <p:spPr>
+          <a:xfrm>
+            <a:off x="868680" y="4517136"/>
+            <a:ext cx="10469880" cy="566928"/>
+          </a:xfrm>
+          <a:prstGeom prst="rect">
+            <a:avLst/>
+          </a:prstGeom>
+          <a:noFill/>
+          <a:ln/>
+        </p:spPr>
+        <p:txBody>
+          <a:bodyPr wrap="square" lIns="0" tIns="0" rIns="0" bIns="0" rtlCol="0" anchor="t"/>
+          <a:lstStyle/>
+          <a:p>
+            <a:pPr indent="0" marL="0">
+              <a:buNone/>
+            </a:pPr>
+            <a:r>
+              <a:rPr lang="en-US" sz="1600" dirty="0">
+                <a:solidFill>
+                  <a:srgbClr val="FFFFFF"/>
+                </a:solidFill>
+                <a:latin typeface="Arial" pitchFamily="34" charset="0"/>
+                <a:ea typeface="Arial" pitchFamily="34" charset="-122"/>
+                <a:cs typeface="Arial" pitchFamily="34" charset="-120"/>
+              </a:rPr>
+              <a:t>• Study decision-making under uncertainty through a stochastic navigation problem.</a:t>
+            </a:r>
+            <a:endParaRPr lang="en-US" sz="1600" dirty="0"/>
+          </a:p>
+          <a:p>
+            <a:pPr indent="0" marL="0">
+              <a:buNone/>
+            </a:pPr>
+            <a:r>
+              <a:rPr lang="en-US" sz="1600" dirty="0">
+                <a:solidFill>
+                  <a:srgbClr val="FFFFFF"/>
+                </a:solidFill>
+                <a:latin typeface="Arial" pitchFamily="34" charset="0"/>
+                <a:ea typeface="Arial" pitchFamily="34" charset="-122"/>
+                <a:cs typeface="Arial" pitchFamily="34" charset="-120"/>
+              </a:rPr>
+              <a:t>• Use a Pac-Man-style environment to model pursuit, risk, and long-horizon planning.</a:t>
+            </a:r>
+            <a:endParaRPr lang="en-US" sz="1600" dirty="0"/>
+          </a:p>
+          <a:p>
+            <a:pPr indent="0" marL="0">
+              <a:buNone/>
+            </a:pPr>
+            <a:r>
+              <a:rPr lang="en-US" sz="1600" dirty="0">
+                <a:solidFill>
+                  <a:srgbClr val="FFFFFF"/>
+                </a:solidFill>
+                <a:latin typeface="Arial" pitchFamily="34" charset="0"/>
+                <a:ea typeface="Arial" pitchFamily="34" charset="-122"/>
+                <a:cs typeface="Arial" pitchFamily="34" charset="-120"/>
+              </a:rPr>
+              <a:t>• Learn a policy that maximizes score while aiming for a no-death level clear.</a:t>
+            </a:r>
+            <a:endParaRPr lang="en-US" sz="1600" dirty="0"/>
+          </a:p>
+        </p:txBody>
+      </p:sp>
+      <p:sp>
+        <p:nvSpPr>
+          <p:cNvPr id="19" name="Shape 16"/>
+          <p:cNvSpPr/>
+          <p:nvPr/>
+        </p:nvSpPr>
+        <p:spPr>
+          <a:xfrm>
+            <a:off x="640080" y="5522976"/>
+            <a:ext cx="10927080" cy="457200"/>
+          </a:xfrm>
+          <a:prstGeom prst="roundRect">
+            <a:avLst>
+              <a:gd name="adj" fmla="val 16000"/>
             </a:avLst>
           </a:prstGeom>
           <a:solidFill>
@@ -1885,14 +1767,14 @@
       </p:sp>
       <p:sp>
         <p:nvSpPr>
-          <p:cNvPr id="29" name="Text 22"/>
-          <p:cNvSpPr/>
-          <p:nvPr/>
-        </p:nvSpPr>
-        <p:spPr>
-          <a:xfrm>
-            <a:off x="9509760" y="1975104"/>
-            <a:ext cx="1874520" cy="182880"/>
+          <p:cNvPr id="20" name="Text 17"/>
+          <p:cNvSpPr/>
+          <p:nvPr/>
+        </p:nvSpPr>
+        <p:spPr>
+          <a:xfrm>
+            <a:off x="896112" y="5687568"/>
+            <a:ext cx="10415016" cy="237744"/>
           </a:xfrm>
           <a:prstGeom prst="rect">
             <a:avLst/>
@@ -1908,503 +1790,6 @@
               <a:buNone/>
             </a:pPr>
             <a:r>
-              <a:rPr lang="en-US" sz="1000" b="1" dirty="0">
-                <a:solidFill>
-                  <a:srgbClr val="D8E2EE"/>
-                </a:solidFill>
-                <a:latin typeface="Arial" pitchFamily="34" charset="0"/>
-                <a:ea typeface="Arial" pitchFamily="34" charset="-122"/>
-                <a:cs typeface="Arial" pitchFamily="34" charset="-120"/>
-              </a:rPr>
-              <a:t>FRUIT</a:t>
-            </a:r>
-            <a:endParaRPr lang="en-US" sz="1000" dirty="0"/>
-          </a:p>
-        </p:txBody>
-      </p:sp>
-      <p:pic>
-        <p:nvPicPr>
-          <p:cNvPr id="30" name="Image 5" descr="/Users/fengruiding/Desktop/cs520/project/ppt_3pages/images/ui_fruit_cherries.png">    </p:cNvPr>
-          <p:cNvPicPr>
-            <a:picLocks noChangeAspect="1"/>
-          </p:cNvPicPr>
-          <p:nvPr/>
-        </p:nvPicPr>
-        <p:blipFill>
-          <a:blip r:embed="rId6"/>
-          <a:stretch>
-            <a:fillRect/>
-          </a:stretch>
-        </p:blipFill>
-        <p:spPr>
-          <a:xfrm>
-            <a:off x="10254996" y="2157984"/>
-            <a:ext cx="347472" cy="283464"/>
-          </a:xfrm>
-          <a:prstGeom prst="rect">
-            <a:avLst/>
-          </a:prstGeom>
-        </p:spPr>
-      </p:pic>
-      <p:sp>
-        <p:nvSpPr>
-          <p:cNvPr id="31" name="Text 23"/>
-          <p:cNvSpPr/>
-          <p:nvPr/>
-        </p:nvSpPr>
-        <p:spPr>
-          <a:xfrm>
-            <a:off x="9491472" y="2487168"/>
-            <a:ext cx="1911096" cy="182880"/>
-          </a:xfrm>
-          <a:prstGeom prst="rect">
-            <a:avLst/>
-          </a:prstGeom>
-          <a:noFill/>
-          <a:ln/>
-        </p:spPr>
-        <p:txBody>
-          <a:bodyPr wrap="square" lIns="0" tIns="0" rIns="0" bIns="0" rtlCol="0" anchor="ctr"/>
-          <a:lstStyle/>
-          <a:p>
-            <a:pPr algn="ctr" indent="0" marL="0">
-              <a:buNone/>
-            </a:pPr>
-            <a:r>
-              <a:rPr lang="en-US" sz="1600" b="1" dirty="0">
-                <a:solidFill>
-                  <a:srgbClr val="FFFFFF"/>
-                </a:solidFill>
-                <a:latin typeface="Arial" pitchFamily="34" charset="0"/>
-                <a:ea typeface="Arial" pitchFamily="34" charset="-122"/>
-                <a:cs typeface="Arial" pitchFamily="34" charset="-120"/>
-              </a:rPr>
-              <a:t>BONUS</a:t>
-            </a:r>
-            <a:endParaRPr lang="en-US" sz="1600" dirty="0"/>
-          </a:p>
-        </p:txBody>
-      </p:sp>
-      <p:sp>
-        <p:nvSpPr>
-          <p:cNvPr id="32" name="Shape 24"/>
-          <p:cNvSpPr/>
-          <p:nvPr/>
-        </p:nvSpPr>
-        <p:spPr>
-          <a:xfrm>
-            <a:off x="640080" y="2944368"/>
-            <a:ext cx="5440680" cy="2834640"/>
-          </a:xfrm>
-          <a:prstGeom prst="roundRect">
-            <a:avLst>
-              <a:gd name="adj" fmla="val 2581"/>
-            </a:avLst>
-          </a:prstGeom>
-          <a:solidFill>
-            <a:srgbClr val="1A2030">
-              <a:alpha val="80000"/>
-            </a:srgbClr>
-          </a:solidFill>
-          <a:ln w="12700">
-            <a:solidFill>
-              <a:srgbClr val="1E88E5"/>
-            </a:solidFill>
-            <a:prstDash val="solid"/>
-          </a:ln>
-        </p:spPr>
-      </p:sp>
-      <p:sp>
-        <p:nvSpPr>
-          <p:cNvPr id="33" name="Text 25"/>
-          <p:cNvSpPr/>
-          <p:nvPr/>
-        </p:nvSpPr>
-        <p:spPr>
-          <a:xfrm>
-            <a:off x="868680" y="3145536"/>
-            <a:ext cx="4983480" cy="274320"/>
-          </a:xfrm>
-          <a:prstGeom prst="rect">
-            <a:avLst/>
-          </a:prstGeom>
-          <a:noFill/>
-          <a:ln/>
-        </p:spPr>
-        <p:txBody>
-          <a:bodyPr wrap="square" lIns="0" tIns="0" rIns="0" bIns="0" rtlCol="0" anchor="ctr"/>
-          <a:lstStyle/>
-          <a:p>
-            <a:pPr indent="0" marL="0">
-              <a:buNone/>
-            </a:pPr>
-            <a:r>
-              <a:rPr lang="en-US" sz="1800" b="1" dirty="0">
-                <a:solidFill>
-                  <a:srgbClr val="FFFFFF"/>
-                </a:solidFill>
-                <a:latin typeface="Arial" pitchFamily="34" charset="0"/>
-                <a:ea typeface="Arial" pitchFamily="34" charset="-122"/>
-                <a:cs typeface="Arial" pitchFamily="34" charset="-120"/>
-              </a:rPr>
-              <a:t>Rules</a:t>
-            </a:r>
-            <a:endParaRPr lang="en-US" sz="1800" dirty="0"/>
-          </a:p>
-        </p:txBody>
-      </p:sp>
-      <p:sp>
-        <p:nvSpPr>
-          <p:cNvPr id="34" name="Shape 26"/>
-          <p:cNvSpPr/>
-          <p:nvPr/>
-        </p:nvSpPr>
-        <p:spPr>
-          <a:xfrm>
-            <a:off x="868680" y="3511296"/>
-            <a:ext cx="4983480" cy="0"/>
-          </a:xfrm>
-          <a:prstGeom prst="line">
-            <a:avLst/>
-          </a:prstGeom>
-          <a:noFill/>
-          <a:ln w="12700">
-            <a:solidFill>
-              <a:srgbClr val="1E88E5">
-                <a:alpha val="82000"/>
-              </a:srgbClr>
-            </a:solidFill>
-            <a:prstDash val="solid"/>
-          </a:ln>
-        </p:spPr>
-      </p:sp>
-      <p:sp>
-        <p:nvSpPr>
-          <p:cNvPr id="35" name="Text 27"/>
-          <p:cNvSpPr/>
-          <p:nvPr/>
-        </p:nvSpPr>
-        <p:spPr>
-          <a:xfrm>
-            <a:off x="868680" y="3694176"/>
-            <a:ext cx="4983480" cy="1901952"/>
-          </a:xfrm>
-          <a:prstGeom prst="rect">
-            <a:avLst/>
-          </a:prstGeom>
-          <a:noFill/>
-          <a:ln/>
-        </p:spPr>
-        <p:txBody>
-          <a:bodyPr wrap="square" lIns="0" tIns="0" rIns="0" bIns="0" rtlCol="0" anchor="t"/>
-          <a:lstStyle/>
-          <a:p>
-            <a:pPr indent="0" marL="0">
-              <a:buNone/>
-            </a:pPr>
-            <a:r>
-              <a:rPr lang="en-US" sz="1600" dirty="0">
-                <a:solidFill>
-                  <a:srgbClr val="FFFFFF"/>
-                </a:solidFill>
-                <a:latin typeface="Arial" pitchFamily="34" charset="0"/>
-                <a:ea typeface="Arial" pitchFamily="34" charset="-122"/>
-                <a:cs typeface="Arial" pitchFamily="34" charset="-120"/>
-              </a:rPr>
-              <a:t>• The player controls Pac-Man and clears the maze by eating all pellets and energizers.</a:t>
-            </a:r>
-            <a:endParaRPr lang="en-US" sz="1600" dirty="0"/>
-          </a:p>
-          <a:p>
-            <a:pPr indent="0" marL="0">
-              <a:buNone/>
-            </a:pPr>
-            <a:r>
-              <a:rPr lang="en-US" sz="1600" dirty="0">
-                <a:solidFill>
-                  <a:srgbClr val="FFFFFF"/>
-                </a:solidFill>
-                <a:latin typeface="Arial" pitchFamily="34" charset="0"/>
-                <a:ea typeface="Arial" pitchFamily="34" charset="-122"/>
-                <a:cs typeface="Arial" pitchFamily="34" charset="-120"/>
-              </a:rPr>
-              <a:t>• Pac-Man starts the game with 3 lives.</a:t>
-            </a:r>
-            <a:endParaRPr lang="en-US" sz="1600" dirty="0"/>
-          </a:p>
-          <a:p>
-            <a:pPr indent="0" marL="0">
-              <a:buNone/>
-            </a:pPr>
-            <a:r>
-              <a:rPr lang="en-US" sz="1600" dirty="0">
-                <a:solidFill>
-                  <a:srgbClr val="FFFFFF"/>
-                </a:solidFill>
-                <a:latin typeface="Arial" pitchFamily="34" charset="0"/>
-                <a:ea typeface="Arial" pitchFamily="34" charset="-122"/>
-                <a:cs typeface="Arial" pitchFamily="34" charset="-120"/>
-              </a:rPr>
-              <a:t>• Colliding with a normal ghost costs 1 life.</a:t>
-            </a:r>
-            <a:endParaRPr lang="en-US" sz="1600" dirty="0"/>
-          </a:p>
-          <a:p>
-            <a:pPr indent="0" marL="0">
-              <a:buNone/>
-            </a:pPr>
-            <a:r>
-              <a:rPr lang="en-US" sz="1600" dirty="0">
-                <a:solidFill>
-                  <a:srgbClr val="FFFFFF"/>
-                </a:solidFill>
-                <a:latin typeface="Arial" pitchFamily="34" charset="0"/>
-                <a:ea typeface="Arial" pitchFamily="34" charset="-122"/>
-                <a:cs typeface="Arial" pitchFamily="34" charset="-120"/>
-              </a:rPr>
-              <a:t>• The game ends when all 3 lives are lost.</a:t>
-            </a:r>
-            <a:endParaRPr lang="en-US" sz="1600" dirty="0"/>
-          </a:p>
-        </p:txBody>
-      </p:sp>
-      <p:sp>
-        <p:nvSpPr>
-          <p:cNvPr id="36" name="Shape 28"/>
-          <p:cNvSpPr/>
-          <p:nvPr/>
-        </p:nvSpPr>
-        <p:spPr>
-          <a:xfrm>
-            <a:off x="6291072" y="2944368"/>
-            <a:ext cx="5276088" cy="2834640"/>
-          </a:xfrm>
-          <a:prstGeom prst="roundRect">
-            <a:avLst>
-              <a:gd name="adj" fmla="val 2581"/>
-            </a:avLst>
-          </a:prstGeom>
-          <a:solidFill>
-            <a:srgbClr val="1A2030">
-              <a:alpha val="80000"/>
-            </a:srgbClr>
-          </a:solidFill>
-          <a:ln w="12700">
-            <a:solidFill>
-              <a:srgbClr val="16A085"/>
-            </a:solidFill>
-            <a:prstDash val="solid"/>
-          </a:ln>
-        </p:spPr>
-      </p:sp>
-      <p:sp>
-        <p:nvSpPr>
-          <p:cNvPr id="37" name="Text 29"/>
-          <p:cNvSpPr/>
-          <p:nvPr/>
-        </p:nvSpPr>
-        <p:spPr>
-          <a:xfrm>
-            <a:off x="6519672" y="3145536"/>
-            <a:ext cx="4818888" cy="274320"/>
-          </a:xfrm>
-          <a:prstGeom prst="rect">
-            <a:avLst/>
-          </a:prstGeom>
-          <a:noFill/>
-          <a:ln/>
-        </p:spPr>
-        <p:txBody>
-          <a:bodyPr wrap="square" lIns="0" tIns="0" rIns="0" bIns="0" rtlCol="0" anchor="ctr"/>
-          <a:lstStyle/>
-          <a:p>
-            <a:pPr indent="0" marL="0">
-              <a:buNone/>
-            </a:pPr>
-            <a:r>
-              <a:rPr lang="en-US" sz="1800" b="1" dirty="0">
-                <a:solidFill>
-                  <a:srgbClr val="FFFFFF"/>
-                </a:solidFill>
-                <a:latin typeface="Arial" pitchFamily="34" charset="0"/>
-                <a:ea typeface="Arial" pitchFamily="34" charset="-122"/>
-                <a:cs typeface="Arial" pitchFamily="34" charset="-120"/>
-              </a:rPr>
-              <a:t>Scoring</a:t>
-            </a:r>
-            <a:endParaRPr lang="en-US" sz="1800" dirty="0"/>
-          </a:p>
-        </p:txBody>
-      </p:sp>
-      <p:sp>
-        <p:nvSpPr>
-          <p:cNvPr id="38" name="Shape 30"/>
-          <p:cNvSpPr/>
-          <p:nvPr/>
-        </p:nvSpPr>
-        <p:spPr>
-          <a:xfrm>
-            <a:off x="6519672" y="3511296"/>
-            <a:ext cx="4818888" cy="0"/>
-          </a:xfrm>
-          <a:prstGeom prst="line">
-            <a:avLst/>
-          </a:prstGeom>
-          <a:noFill/>
-          <a:ln w="12700">
-            <a:solidFill>
-              <a:srgbClr val="16A085">
-                <a:alpha val="82000"/>
-              </a:srgbClr>
-            </a:solidFill>
-            <a:prstDash val="solid"/>
-          </a:ln>
-        </p:spPr>
-      </p:sp>
-      <p:sp>
-        <p:nvSpPr>
-          <p:cNvPr id="39" name="Text 31"/>
-          <p:cNvSpPr/>
-          <p:nvPr/>
-        </p:nvSpPr>
-        <p:spPr>
-          <a:xfrm>
-            <a:off x="6519672" y="3694176"/>
-            <a:ext cx="4818888" cy="1901952"/>
-          </a:xfrm>
-          <a:prstGeom prst="rect">
-            <a:avLst/>
-          </a:prstGeom>
-          <a:noFill/>
-          <a:ln/>
-        </p:spPr>
-        <p:txBody>
-          <a:bodyPr wrap="square" lIns="0" tIns="0" rIns="0" bIns="0" rtlCol="0" anchor="t"/>
-          <a:lstStyle/>
-          <a:p>
-            <a:pPr indent="0" marL="0">
-              <a:buNone/>
-            </a:pPr>
-            <a:r>
-              <a:rPr lang="en-US" sz="1500" dirty="0">
-                <a:solidFill>
-                  <a:srgbClr val="FFFFFF"/>
-                </a:solidFill>
-                <a:latin typeface="Arial" pitchFamily="34" charset="0"/>
-                <a:ea typeface="Arial" pitchFamily="34" charset="-122"/>
-                <a:cs typeface="Arial" pitchFamily="34" charset="-120"/>
-              </a:rPr>
-              <a:t>• Eating a regular pellet gives +10 points.</a:t>
-            </a:r>
-            <a:endParaRPr lang="en-US" sz="1500" dirty="0"/>
-          </a:p>
-          <a:p>
-            <a:pPr indent="0" marL="0">
-              <a:buNone/>
-            </a:pPr>
-            <a:r>
-              <a:rPr lang="en-US" sz="1500" dirty="0">
-                <a:solidFill>
-                  <a:srgbClr val="FFFFFF"/>
-                </a:solidFill>
-                <a:latin typeface="Arial" pitchFamily="34" charset="0"/>
-                <a:ea typeface="Arial" pitchFamily="34" charset="-122"/>
-                <a:cs typeface="Arial" pitchFamily="34" charset="-120"/>
-              </a:rPr>
-              <a:t>• Eating an energizer gives +50 points and makes ghosts vulnerable for a limited time.</a:t>
-            </a:r>
-            <a:endParaRPr lang="en-US" sz="1500" dirty="0"/>
-          </a:p>
-          <a:p>
-            <a:pPr indent="0" marL="0">
-              <a:buNone/>
-            </a:pPr>
-            <a:r>
-              <a:rPr lang="en-US" sz="1500" dirty="0">
-                <a:solidFill>
-                  <a:srgbClr val="FFFFFF"/>
-                </a:solidFill>
-                <a:latin typeface="Arial" pitchFamily="34" charset="0"/>
-                <a:ea typeface="Arial" pitchFamily="34" charset="-122"/>
-                <a:cs typeface="Arial" pitchFamily="34" charset="-120"/>
-              </a:rPr>
-              <a:t>• Eating vulnerable ghosts gives increasing bonus rewards: +200 / +400 / +800 / +1600.</a:t>
-            </a:r>
-            <a:endParaRPr lang="en-US" sz="1500" dirty="0"/>
-          </a:p>
-          <a:p>
-            <a:pPr indent="0" marL="0">
-              <a:buNone/>
-            </a:pPr>
-            <a:r>
-              <a:rPr lang="en-US" sz="1500" dirty="0">
-                <a:solidFill>
-                  <a:srgbClr val="FFFFFF"/>
-                </a:solidFill>
-                <a:latin typeface="Arial" pitchFamily="34" charset="0"/>
-                <a:ea typeface="Arial" pitchFamily="34" charset="-122"/>
-                <a:cs typeface="Arial" pitchFamily="34" charset="-120"/>
-              </a:rPr>
-              <a:t>• Fruit appears at specific stages and gives bonus points when collected.</a:t>
-            </a:r>
-            <a:endParaRPr lang="en-US" sz="1500" dirty="0"/>
-          </a:p>
-        </p:txBody>
-      </p:sp>
-      <p:sp>
-        <p:nvSpPr>
-          <p:cNvPr id="40" name="Shape 32"/>
-          <p:cNvSpPr/>
-          <p:nvPr/>
-        </p:nvSpPr>
-        <p:spPr>
-          <a:xfrm>
-            <a:off x="640080" y="5943600"/>
-            <a:ext cx="10927080" cy="420624"/>
-          </a:xfrm>
-          <a:prstGeom prst="roundRect">
-            <a:avLst>
-              <a:gd name="adj" fmla="val 17391"/>
-            </a:avLst>
-          </a:prstGeom>
-          <a:solidFill>
-            <a:srgbClr val="1A2030">
-              <a:alpha val="80000"/>
-            </a:srgbClr>
-          </a:solidFill>
-          <a:ln w="12700">
-            <a:solidFill>
-              <a:srgbClr val="D9E2EC"/>
-            </a:solidFill>
-            <a:prstDash val="solid"/>
-          </a:ln>
-        </p:spPr>
-      </p:sp>
-      <p:sp>
-        <p:nvSpPr>
-          <p:cNvPr id="41" name="Text 33"/>
-          <p:cNvSpPr/>
-          <p:nvPr/>
-        </p:nvSpPr>
-        <p:spPr>
-          <a:xfrm>
-            <a:off x="896112" y="6108192"/>
-            <a:ext cx="10415016" cy="201168"/>
-          </a:xfrm>
-          <a:prstGeom prst="rect">
-            <a:avLst/>
-          </a:prstGeom>
-          <a:noFill/>
-          <a:ln/>
-        </p:spPr>
-        <p:txBody>
-          <a:bodyPr wrap="square" lIns="0" tIns="0" rIns="0" bIns="0" rtlCol="0" anchor="ctr"/>
-          <a:lstStyle/>
-          <a:p>
-            <a:pPr indent="0" marL="0">
-              <a:buNone/>
-            </a:pPr>
-            <a:r>
               <a:rPr lang="en-US" sz="1400" dirty="0">
                 <a:solidFill>
                   <a:srgbClr val="FFFFFF"/>
@@ -2413,7 +1798,7 @@
                 <a:ea typeface="Arial" pitchFamily="34" charset="-122"/>
                 <a:cs typeface="Arial" pitchFamily="34" charset="-120"/>
               </a:rPr>
-              <a:t>Core objective: score as much as possible while surviving long enough to clear the maze.</a:t>
+              <a:t>This progress update focuses on the current RL formulation, reward design, and optimization strategy.</a:t>
             </a:r>
             <a:endParaRPr lang="en-US" sz="1400" dirty="0"/>
           </a:p>
@@ -2508,7 +1893,7 @@
                 <a:ea typeface="Arial" pitchFamily="34" charset="-122"/>
                 <a:cs typeface="Arial" pitchFamily="34" charset="-120"/>
               </a:rPr>
-              <a:t>Q-Learning Update Rule</a:t>
+              <a:t>Game Rules and Scoring</a:t>
             </a:r>
             <a:endParaRPr lang="en-US" sz="2400" dirty="0"/>
           </a:p>
@@ -2531,7 +1916,7 @@
           <a:noFill/>
           <a:ln w="12700">
             <a:solidFill>
-              <a:srgbClr val="16A085">
+              <a:srgbClr val="1E88E5">
                 <a:alpha val="72000"/>
               </a:srgbClr>
             </a:solidFill>
@@ -2541,135 +1926,197 @@
       </p:sp>
       <p:sp>
         <p:nvSpPr>
-          <p:cNvPr id="5" name="Text 2"/>
-          <p:cNvSpPr/>
-          <p:nvPr/>
-        </p:nvSpPr>
-        <p:spPr>
-          <a:xfrm>
-            <a:off x="640080" y="1444752"/>
-            <a:ext cx="3383280" cy="201168"/>
-          </a:xfrm>
-          <a:prstGeom prst="rect">
-            <a:avLst/>
-          </a:prstGeom>
-          <a:noFill/>
-          <a:ln/>
-        </p:spPr>
-        <p:txBody>
-          <a:bodyPr wrap="square" lIns="0" tIns="0" rIns="0" bIns="0" rtlCol="0" anchor="ctr"/>
-          <a:lstStyle/>
-          <a:p>
-            <a:pPr indent="0" marL="0">
-              <a:buNone/>
-            </a:pPr>
-            <a:r>
-              <a:rPr lang="en-US" sz="1100" b="1" dirty="0">
-                <a:solidFill>
-                  <a:srgbClr val="D8E2EE"/>
-                </a:solidFill>
-                <a:latin typeface="Arial" pitchFamily="34" charset="0"/>
-                <a:ea typeface="Arial" pitchFamily="34" charset="-122"/>
-                <a:cs typeface="Arial" pitchFamily="34" charset="-120"/>
-              </a:rPr>
-              <a:t>Markov Decision Process (MDP)</a:t>
-            </a:r>
-            <a:endParaRPr lang="en-US" sz="1100" dirty="0"/>
-          </a:p>
-        </p:txBody>
-      </p:sp>
-      <p:sp>
-        <p:nvSpPr>
-          <p:cNvPr id="6" name="Text 3"/>
-          <p:cNvSpPr/>
-          <p:nvPr/>
-        </p:nvSpPr>
-        <p:spPr>
-          <a:xfrm>
-            <a:off x="640080" y="1664208"/>
-            <a:ext cx="10927080" cy="310896"/>
-          </a:xfrm>
-          <a:prstGeom prst="rect">
-            <a:avLst/>
-          </a:prstGeom>
-          <a:noFill/>
-          <a:ln/>
-        </p:spPr>
-        <p:txBody>
-          <a:bodyPr wrap="square" lIns="0" tIns="0" rIns="0" bIns="0" rtlCol="0" anchor="ctr"/>
-          <a:lstStyle/>
-          <a:p>
-            <a:pPr indent="0" marL="0">
-              <a:buNone/>
-            </a:pPr>
-            <a:r>
-              <a:rPr lang="en-US" sz="1700" b="1" dirty="0">
-                <a:solidFill>
-                  <a:srgbClr val="FFFFFF"/>
-                </a:solidFill>
-                <a:latin typeface="Arial" pitchFamily="34" charset="0"/>
-                <a:ea typeface="Arial" pitchFamily="34" charset="-122"/>
-                <a:cs typeface="Arial" pitchFamily="34" charset="-120"/>
-              </a:rPr>
-              <a:t>Q(s,a) ← Q(s,a) + α[r + γ max_a' Q(s',a') − Q(s,a)]</a:t>
-            </a:r>
-            <a:endParaRPr lang="en-US" sz="1700" dirty="0"/>
-          </a:p>
-        </p:txBody>
-      </p:sp>
-      <p:sp>
-        <p:nvSpPr>
-          <p:cNvPr id="7" name="Text 4"/>
-          <p:cNvSpPr/>
-          <p:nvPr/>
-        </p:nvSpPr>
-        <p:spPr>
-          <a:xfrm>
-            <a:off x="640080" y="1993392"/>
-            <a:ext cx="6583680" cy="201168"/>
-          </a:xfrm>
-          <a:prstGeom prst="rect">
-            <a:avLst/>
-          </a:prstGeom>
-          <a:noFill/>
-          <a:ln/>
-        </p:spPr>
-        <p:txBody>
-          <a:bodyPr wrap="square" lIns="0" tIns="0" rIns="0" bIns="0" rtlCol="0" anchor="ctr"/>
-          <a:lstStyle/>
-          <a:p>
-            <a:pPr indent="0" marL="0">
-              <a:buNone/>
-            </a:pPr>
-            <a:r>
-              <a:rPr lang="en-US" sz="1200" b="1" dirty="0">
-                <a:solidFill>
-                  <a:srgbClr val="D8E2EE"/>
-                </a:solidFill>
-                <a:latin typeface="Arial" pitchFamily="34" charset="0"/>
-                <a:ea typeface="Arial" pitchFamily="34" charset="-122"/>
-                <a:cs typeface="Arial" pitchFamily="34" charset="-120"/>
-              </a:rPr>
-              <a:t>How the formula updates action values from reward and future return</a:t>
-            </a:r>
-            <a:endParaRPr lang="en-US" sz="1200" dirty="0"/>
-          </a:p>
-        </p:txBody>
-      </p:sp>
-      <p:sp>
-        <p:nvSpPr>
-          <p:cNvPr id="8" name="Shape 5"/>
-          <p:cNvSpPr/>
-          <p:nvPr/>
-        </p:nvSpPr>
-        <p:spPr>
-          <a:xfrm>
-            <a:off x="640080" y="2322576"/>
-            <a:ext cx="1737360" cy="658368"/>
+          <p:cNvPr id="5" name="Shape 2"/>
+          <p:cNvSpPr/>
+          <p:nvPr/>
+        </p:nvSpPr>
+        <p:spPr>
+          <a:xfrm>
+            <a:off x="640080" y="1828800"/>
+            <a:ext cx="1783080" cy="932688"/>
           </a:xfrm>
           <a:prstGeom prst="roundRect">
             <a:avLst>
-              <a:gd name="adj" fmla="val 11111"/>
+              <a:gd name="adj" fmla="val 7843"/>
+            </a:avLst>
+          </a:prstGeom>
+          <a:solidFill>
+            <a:srgbClr val="1A2030">
+              <a:alpha val="80000"/>
+            </a:srgbClr>
+          </a:solidFill>
+          <a:ln w="12700">
+            <a:solidFill>
+              <a:srgbClr val="D93025"/>
+            </a:solidFill>
+            <a:prstDash val="solid"/>
+          </a:ln>
+        </p:spPr>
+      </p:sp>
+      <p:sp>
+        <p:nvSpPr>
+          <p:cNvPr id="6" name="Text 3"/>
+          <p:cNvSpPr/>
+          <p:nvPr/>
+        </p:nvSpPr>
+        <p:spPr>
+          <a:xfrm>
+            <a:off x="822960" y="1975104"/>
+            <a:ext cx="1417320" cy="201168"/>
+          </a:xfrm>
+          <a:prstGeom prst="rect">
+            <a:avLst/>
+          </a:prstGeom>
+          <a:noFill/>
+          <a:ln/>
+        </p:spPr>
+        <p:txBody>
+          <a:bodyPr wrap="square" lIns="0" tIns="0" rIns="0" bIns="0" rtlCol="0" anchor="ctr"/>
+          <a:lstStyle/>
+          <a:p>
+            <a:pPr indent="0" marL="0">
+              <a:buNone/>
+            </a:pPr>
+            <a:r>
+              <a:rPr lang="en-US" sz="1000" b="1" dirty="0">
+                <a:solidFill>
+                  <a:srgbClr val="D8E2EE"/>
+                </a:solidFill>
+                <a:latin typeface="Arial" pitchFamily="34" charset="0"/>
+                <a:ea typeface="Arial" pitchFamily="34" charset="-122"/>
+                <a:cs typeface="Arial" pitchFamily="34" charset="-120"/>
+              </a:rPr>
+              <a:t>LIVES</a:t>
+            </a:r>
+            <a:endParaRPr lang="en-US" sz="1000" dirty="0"/>
+          </a:p>
+        </p:txBody>
+      </p:sp>
+      <p:pic>
+        <p:nvPicPr>
+          <p:cNvPr id="7" name="Image 1" descr="/Users/fengruiding/Desktop/cs520/project/pacman/public/icon/favicon.png">    </p:cNvPr>
+          <p:cNvPicPr>
+            <a:picLocks noChangeAspect="1"/>
+          </p:cNvPicPr>
+          <p:nvPr/>
+        </p:nvPicPr>
+        <p:blipFill>
+          <a:blip r:embed="rId2"/>
+          <a:stretch>
+            <a:fillRect/>
+          </a:stretch>
+        </p:blipFill>
+        <p:spPr>
+          <a:xfrm>
+            <a:off x="1088136" y="2194560"/>
+            <a:ext cx="246888" cy="246888"/>
+          </a:xfrm>
+          <a:prstGeom prst="rect">
+            <a:avLst/>
+          </a:prstGeom>
+        </p:spPr>
+      </p:pic>
+      <p:pic>
+        <p:nvPicPr>
+          <p:cNvPr id="8" name="Image 2" descr="/Users/fengruiding/Desktop/cs520/project/pacman/public/icon/favicon.png">    </p:cNvPr>
+          <p:cNvPicPr>
+            <a:picLocks noChangeAspect="1"/>
+          </p:cNvPicPr>
+          <p:nvPr/>
+        </p:nvPicPr>
+        <p:blipFill>
+          <a:blip r:embed="rId3"/>
+          <a:stretch>
+            <a:fillRect/>
+          </a:stretch>
+        </p:blipFill>
+        <p:spPr>
+          <a:xfrm>
+            <a:off x="1408176" y="2194560"/>
+            <a:ext cx="246888" cy="246888"/>
+          </a:xfrm>
+          <a:prstGeom prst="rect">
+            <a:avLst/>
+          </a:prstGeom>
+        </p:spPr>
+      </p:pic>
+      <p:pic>
+        <p:nvPicPr>
+          <p:cNvPr id="9" name="Image 3" descr="/Users/fengruiding/Desktop/cs520/project/pacman/public/icon/favicon.png">    </p:cNvPr>
+          <p:cNvPicPr>
+            <a:picLocks noChangeAspect="1"/>
+          </p:cNvPicPr>
+          <p:nvPr/>
+        </p:nvPicPr>
+        <p:blipFill>
+          <a:blip r:embed="rId4"/>
+          <a:stretch>
+            <a:fillRect/>
+          </a:stretch>
+        </p:blipFill>
+        <p:spPr>
+          <a:xfrm>
+            <a:off x="1728216" y="2194560"/>
+            <a:ext cx="246888" cy="246888"/>
+          </a:xfrm>
+          <a:prstGeom prst="rect">
+            <a:avLst/>
+          </a:prstGeom>
+        </p:spPr>
+      </p:pic>
+      <p:sp>
+        <p:nvSpPr>
+          <p:cNvPr id="10" name="Text 4"/>
+          <p:cNvSpPr/>
+          <p:nvPr/>
+        </p:nvSpPr>
+        <p:spPr>
+          <a:xfrm>
+            <a:off x="804672" y="2496312"/>
+            <a:ext cx="1453896" cy="182880"/>
+          </a:xfrm>
+          <a:prstGeom prst="rect">
+            <a:avLst/>
+          </a:prstGeom>
+          <a:noFill/>
+          <a:ln/>
+        </p:spPr>
+        <p:txBody>
+          <a:bodyPr wrap="square" lIns="0" tIns="0" rIns="0" bIns="0" rtlCol="0" anchor="ctr"/>
+          <a:lstStyle/>
+          <a:p>
+            <a:pPr algn="ctr" indent="0" marL="0">
+              <a:buNone/>
+            </a:pPr>
+            <a:r>
+              <a:rPr lang="en-US" sz="1100" b="1" dirty="0">
+                <a:solidFill>
+                  <a:srgbClr val="FFFFFF"/>
+                </a:solidFill>
+                <a:latin typeface="Arial" pitchFamily="34" charset="0"/>
+                <a:ea typeface="Arial" pitchFamily="34" charset="-122"/>
+                <a:cs typeface="Arial" pitchFamily="34" charset="-120"/>
+              </a:rPr>
+              <a:t>3 lives</a:t>
+            </a:r>
+            <a:endParaRPr lang="en-US" sz="1100" dirty="0"/>
+          </a:p>
+        </p:txBody>
+      </p:sp>
+      <p:sp>
+        <p:nvSpPr>
+          <p:cNvPr id="11" name="Shape 5"/>
+          <p:cNvSpPr/>
+          <p:nvPr/>
+        </p:nvSpPr>
+        <p:spPr>
+          <a:xfrm>
+            <a:off x="2606040" y="1828800"/>
+            <a:ext cx="1783080" cy="932688"/>
+          </a:xfrm>
+          <a:prstGeom prst="roundRect">
+            <a:avLst>
+              <a:gd name="adj" fmla="val 7843"/>
             </a:avLst>
           </a:prstGeom>
           <a:solidFill>
@@ -2687,14 +2134,14 @@
       </p:sp>
       <p:sp>
         <p:nvSpPr>
-          <p:cNvPr id="9" name="Text 6"/>
-          <p:cNvSpPr/>
-          <p:nvPr/>
-        </p:nvSpPr>
-        <p:spPr>
-          <a:xfrm>
-            <a:off x="777240" y="2432304"/>
-            <a:ext cx="1463040" cy="182880"/>
+          <p:cNvPr id="12" name="Text 6"/>
+          <p:cNvSpPr/>
+          <p:nvPr/>
+        </p:nvSpPr>
+        <p:spPr>
+          <a:xfrm>
+            <a:off x="2788920" y="1975104"/>
+            <a:ext cx="1417320" cy="182880"/>
           </a:xfrm>
           <a:prstGeom prst="rect">
             <a:avLst/>
@@ -2706,77 +2153,373 @@
           <a:bodyPr wrap="square" lIns="0" tIns="0" rIns="0" bIns="0" rtlCol="0" anchor="ctr"/>
           <a:lstStyle/>
           <a:p>
+            <a:pPr indent="0" marL="0">
+              <a:buNone/>
+            </a:pPr>
+            <a:r>
+              <a:rPr lang="en-US" sz="1000" b="1" dirty="0">
+                <a:solidFill>
+                  <a:srgbClr val="D8E2EE"/>
+                </a:solidFill>
+                <a:latin typeface="Arial" pitchFamily="34" charset="0"/>
+                <a:ea typeface="Arial" pitchFamily="34" charset="-122"/>
+                <a:cs typeface="Arial" pitchFamily="34" charset="-120"/>
+              </a:rPr>
+              <a:t>PELLET</a:t>
+            </a:r>
+            <a:endParaRPr lang="en-US" sz="1000" dirty="0"/>
+          </a:p>
+        </p:txBody>
+      </p:sp>
+      <p:sp>
+        <p:nvSpPr>
+          <p:cNvPr id="13" name="Shape 7"/>
+          <p:cNvSpPr/>
+          <p:nvPr/>
+        </p:nvSpPr>
+        <p:spPr>
+          <a:xfrm>
+            <a:off x="2962656" y="2258568"/>
+            <a:ext cx="64008" cy="64008"/>
+          </a:xfrm>
+          <a:prstGeom prst="ellipse">
+            <a:avLst/>
+          </a:prstGeom>
+          <a:solidFill>
+            <a:srgbClr val="F7C5C0"/>
+          </a:solidFill>
+          <a:ln w="12700">
+            <a:solidFill>
+              <a:srgbClr val="F7C5C0">
+                <a:alpha val="0"/>
+              </a:srgbClr>
+            </a:solidFill>
+            <a:prstDash val="solid"/>
+          </a:ln>
+        </p:spPr>
+      </p:sp>
+      <p:sp>
+        <p:nvSpPr>
+          <p:cNvPr id="14" name="Shape 8"/>
+          <p:cNvSpPr/>
+          <p:nvPr/>
+        </p:nvSpPr>
+        <p:spPr>
+          <a:xfrm>
+            <a:off x="3163824" y="2258568"/>
+            <a:ext cx="64008" cy="64008"/>
+          </a:xfrm>
+          <a:prstGeom prst="ellipse">
+            <a:avLst/>
+          </a:prstGeom>
+          <a:solidFill>
+            <a:srgbClr val="F7C5C0"/>
+          </a:solidFill>
+          <a:ln w="12700">
+            <a:solidFill>
+              <a:srgbClr val="F7C5C0">
+                <a:alpha val="0"/>
+              </a:srgbClr>
+            </a:solidFill>
+            <a:prstDash val="solid"/>
+          </a:ln>
+        </p:spPr>
+      </p:sp>
+      <p:sp>
+        <p:nvSpPr>
+          <p:cNvPr id="15" name="Shape 9"/>
+          <p:cNvSpPr/>
+          <p:nvPr/>
+        </p:nvSpPr>
+        <p:spPr>
+          <a:xfrm>
+            <a:off x="3364992" y="2258568"/>
+            <a:ext cx="64008" cy="64008"/>
+          </a:xfrm>
+          <a:prstGeom prst="ellipse">
+            <a:avLst/>
+          </a:prstGeom>
+          <a:solidFill>
+            <a:srgbClr val="F7C5C0"/>
+          </a:solidFill>
+          <a:ln w="12700">
+            <a:solidFill>
+              <a:srgbClr val="F7C5C0">
+                <a:alpha val="0"/>
+              </a:srgbClr>
+            </a:solidFill>
+            <a:prstDash val="solid"/>
+          </a:ln>
+        </p:spPr>
+      </p:sp>
+      <p:sp>
+        <p:nvSpPr>
+          <p:cNvPr id="16" name="Shape 10"/>
+          <p:cNvSpPr/>
+          <p:nvPr/>
+        </p:nvSpPr>
+        <p:spPr>
+          <a:xfrm>
+            <a:off x="3566160" y="2258568"/>
+            <a:ext cx="64008" cy="64008"/>
+          </a:xfrm>
+          <a:prstGeom prst="ellipse">
+            <a:avLst/>
+          </a:prstGeom>
+          <a:solidFill>
+            <a:srgbClr val="F7C5C0"/>
+          </a:solidFill>
+          <a:ln w="12700">
+            <a:solidFill>
+              <a:srgbClr val="F7C5C0">
+                <a:alpha val="0"/>
+              </a:srgbClr>
+            </a:solidFill>
+            <a:prstDash val="solid"/>
+          </a:ln>
+        </p:spPr>
+      </p:sp>
+      <p:sp>
+        <p:nvSpPr>
+          <p:cNvPr id="17" name="Shape 11"/>
+          <p:cNvSpPr/>
+          <p:nvPr/>
+        </p:nvSpPr>
+        <p:spPr>
+          <a:xfrm>
+            <a:off x="3767328" y="2258568"/>
+            <a:ext cx="64008" cy="64008"/>
+          </a:xfrm>
+          <a:prstGeom prst="ellipse">
+            <a:avLst/>
+          </a:prstGeom>
+          <a:solidFill>
+            <a:srgbClr val="F7C5C0"/>
+          </a:solidFill>
+          <a:ln w="12700">
+            <a:solidFill>
+              <a:srgbClr val="F7C5C0">
+                <a:alpha val="0"/>
+              </a:srgbClr>
+            </a:solidFill>
+            <a:prstDash val="solid"/>
+          </a:ln>
+        </p:spPr>
+      </p:sp>
+      <p:sp>
+        <p:nvSpPr>
+          <p:cNvPr id="18" name="Shape 12"/>
+          <p:cNvSpPr/>
+          <p:nvPr/>
+        </p:nvSpPr>
+        <p:spPr>
+          <a:xfrm>
+            <a:off x="3968496" y="2258568"/>
+            <a:ext cx="64008" cy="64008"/>
+          </a:xfrm>
+          <a:prstGeom prst="ellipse">
+            <a:avLst/>
+          </a:prstGeom>
+          <a:solidFill>
+            <a:srgbClr val="F7C5C0"/>
+          </a:solidFill>
+          <a:ln w="12700">
+            <a:solidFill>
+              <a:srgbClr val="F7C5C0">
+                <a:alpha val="0"/>
+              </a:srgbClr>
+            </a:solidFill>
+            <a:prstDash val="solid"/>
+          </a:ln>
+        </p:spPr>
+      </p:sp>
+      <p:sp>
+        <p:nvSpPr>
+          <p:cNvPr id="19" name="Text 13"/>
+          <p:cNvSpPr/>
+          <p:nvPr/>
+        </p:nvSpPr>
+        <p:spPr>
+          <a:xfrm>
+            <a:off x="2770632" y="2459736"/>
+            <a:ext cx="1453896" cy="182880"/>
+          </a:xfrm>
+          <a:prstGeom prst="rect">
+            <a:avLst/>
+          </a:prstGeom>
+          <a:noFill/>
+          <a:ln/>
+        </p:spPr>
+        <p:txBody>
+          <a:bodyPr wrap="square" lIns="0" tIns="0" rIns="0" bIns="0" rtlCol="0" anchor="ctr"/>
+          <a:lstStyle/>
+          <a:p>
             <a:pPr algn="ctr" indent="0" marL="0">
               <a:buNone/>
             </a:pPr>
             <a:r>
-              <a:rPr lang="en-US" sz="900" b="1" dirty="0">
-                <a:solidFill>
-                  <a:srgbClr val="D8E2EE"/>
-                </a:solidFill>
-                <a:latin typeface="Arial" pitchFamily="34" charset="0"/>
-                <a:ea typeface="Arial" pitchFamily="34" charset="-122"/>
-                <a:cs typeface="Arial" pitchFamily="34" charset="-120"/>
-              </a:rPr>
-              <a:t>PELLET/E.</a:t>
-            </a:r>
-            <a:endParaRPr lang="en-US" sz="900" dirty="0"/>
-          </a:p>
-        </p:txBody>
-      </p:sp>
-      <p:sp>
-        <p:nvSpPr>
-          <p:cNvPr id="10" name="Text 7"/>
-          <p:cNvSpPr/>
-          <p:nvPr/>
-        </p:nvSpPr>
-        <p:spPr>
-          <a:xfrm>
-            <a:off x="777240" y="2670048"/>
-            <a:ext cx="1463040" cy="219456"/>
-          </a:xfrm>
-          <a:prstGeom prst="rect">
-            <a:avLst/>
-          </a:prstGeom>
-          <a:noFill/>
-          <a:ln/>
-        </p:spPr>
-        <p:txBody>
-          <a:bodyPr wrap="square" lIns="0" tIns="0" rIns="0" bIns="0" rtlCol="0" anchor="ctr"/>
-          <a:lstStyle/>
-          <a:p>
-            <a:pPr algn="ctr" indent="0" marL="0">
-              <a:buNone/>
-            </a:pPr>
-            <a:r>
-              <a:rPr lang="en-US" sz="1300" b="1" dirty="0">
-                <a:solidFill>
-                  <a:srgbClr val="FFFFFF"/>
-                </a:solidFill>
-                <a:latin typeface="Arial" pitchFamily="34" charset="0"/>
-                <a:ea typeface="Arial" pitchFamily="34" charset="-122"/>
-                <a:cs typeface="Arial" pitchFamily="34" charset="-120"/>
-              </a:rPr>
-              <a:t>+10/+50</a:t>
-            </a:r>
-            <a:endParaRPr lang="en-US" sz="1300" dirty="0"/>
-          </a:p>
-        </p:txBody>
-      </p:sp>
-      <p:sp>
-        <p:nvSpPr>
-          <p:cNvPr id="11" name="Shape 8"/>
-          <p:cNvSpPr/>
-          <p:nvPr/>
-        </p:nvSpPr>
-        <p:spPr>
-          <a:xfrm>
-            <a:off x="2478024" y="2322576"/>
-            <a:ext cx="1737360" cy="658368"/>
+              <a:rPr lang="en-US" sz="2100" b="1" dirty="0">
+                <a:solidFill>
+                  <a:srgbClr val="FFFFFF"/>
+                </a:solidFill>
+                <a:latin typeface="Arial" pitchFamily="34" charset="0"/>
+                <a:ea typeface="Arial" pitchFamily="34" charset="-122"/>
+                <a:cs typeface="Arial" pitchFamily="34" charset="-120"/>
+              </a:rPr>
+              <a:t>＋10</a:t>
+            </a:r>
+            <a:endParaRPr lang="en-US" sz="2100" dirty="0"/>
+          </a:p>
+        </p:txBody>
+      </p:sp>
+      <p:sp>
+        <p:nvSpPr>
+          <p:cNvPr id="20" name="Shape 14"/>
+          <p:cNvSpPr/>
+          <p:nvPr/>
+        </p:nvSpPr>
+        <p:spPr>
+          <a:xfrm>
+            <a:off x="4572000" y="1828800"/>
+            <a:ext cx="1965960" cy="932688"/>
           </a:xfrm>
           <a:prstGeom prst="roundRect">
             <a:avLst>
-              <a:gd name="adj" fmla="val 11111"/>
+              <a:gd name="adj" fmla="val 7843"/>
+            </a:avLst>
+          </a:prstGeom>
+          <a:solidFill>
+            <a:srgbClr val="1A2030">
+              <a:alpha val="80000"/>
+            </a:srgbClr>
+          </a:solidFill>
+          <a:ln w="12700">
+            <a:solidFill>
+              <a:srgbClr val="16A085"/>
+            </a:solidFill>
+            <a:prstDash val="solid"/>
+          </a:ln>
+        </p:spPr>
+      </p:sp>
+      <p:sp>
+        <p:nvSpPr>
+          <p:cNvPr id="21" name="Text 15"/>
+          <p:cNvSpPr/>
+          <p:nvPr/>
+        </p:nvSpPr>
+        <p:spPr>
+          <a:xfrm>
+            <a:off x="4754880" y="1975104"/>
+            <a:ext cx="1600200" cy="182880"/>
+          </a:xfrm>
+          <a:prstGeom prst="rect">
+            <a:avLst/>
+          </a:prstGeom>
+          <a:noFill/>
+          <a:ln/>
+        </p:spPr>
+        <p:txBody>
+          <a:bodyPr wrap="square" lIns="0" tIns="0" rIns="0" bIns="0" rtlCol="0" anchor="ctr"/>
+          <a:lstStyle/>
+          <a:p>
+            <a:pPr indent="0" marL="0">
+              <a:buNone/>
+            </a:pPr>
+            <a:r>
+              <a:rPr lang="en-US" sz="1000" b="1" dirty="0">
+                <a:solidFill>
+                  <a:srgbClr val="D8E2EE"/>
+                </a:solidFill>
+                <a:latin typeface="Arial" pitchFamily="34" charset="0"/>
+                <a:ea typeface="Arial" pitchFamily="34" charset="-122"/>
+                <a:cs typeface="Arial" pitchFamily="34" charset="-120"/>
+              </a:rPr>
+              <a:t>ENERGIZER</a:t>
+            </a:r>
+            <a:endParaRPr lang="en-US" sz="1000" dirty="0"/>
+          </a:p>
+        </p:txBody>
+      </p:sp>
+      <p:sp>
+        <p:nvSpPr>
+          <p:cNvPr id="22" name="Shape 16"/>
+          <p:cNvSpPr/>
+          <p:nvPr/>
+        </p:nvSpPr>
+        <p:spPr>
+          <a:xfrm>
+            <a:off x="5454396" y="2185416"/>
+            <a:ext cx="201168" cy="201168"/>
+          </a:xfrm>
+          <a:prstGeom prst="ellipse">
+            <a:avLst/>
+          </a:prstGeom>
+          <a:solidFill>
+            <a:srgbClr val="F7C5C0"/>
+          </a:solidFill>
+          <a:ln w="12700">
+            <a:solidFill>
+              <a:srgbClr val="F7C5C0">
+                <a:alpha val="0"/>
+              </a:srgbClr>
+            </a:solidFill>
+            <a:prstDash val="solid"/>
+          </a:ln>
+        </p:spPr>
+      </p:sp>
+      <p:sp>
+        <p:nvSpPr>
+          <p:cNvPr id="23" name="Text 17"/>
+          <p:cNvSpPr/>
+          <p:nvPr/>
+        </p:nvSpPr>
+        <p:spPr>
+          <a:xfrm>
+            <a:off x="4736592" y="2459736"/>
+            <a:ext cx="1636776" cy="182880"/>
+          </a:xfrm>
+          <a:prstGeom prst="rect">
+            <a:avLst/>
+          </a:prstGeom>
+          <a:noFill/>
+          <a:ln/>
+        </p:spPr>
+        <p:txBody>
+          <a:bodyPr wrap="square" lIns="0" tIns="0" rIns="0" bIns="0" rtlCol="0" anchor="ctr"/>
+          <a:lstStyle/>
+          <a:p>
+            <a:pPr algn="ctr" indent="0" marL="0">
+              <a:buNone/>
+            </a:pPr>
+            <a:r>
+              <a:rPr lang="en-US" sz="2100" b="1" dirty="0">
+                <a:solidFill>
+                  <a:srgbClr val="FFFFFF"/>
+                </a:solidFill>
+                <a:latin typeface="Arial" pitchFamily="34" charset="0"/>
+                <a:ea typeface="Arial" pitchFamily="34" charset="-122"/>
+                <a:cs typeface="Arial" pitchFamily="34" charset="-120"/>
+              </a:rPr>
+              <a:t>＋50</a:t>
+            </a:r>
+            <a:endParaRPr lang="en-US" sz="2100" dirty="0"/>
+          </a:p>
+        </p:txBody>
+      </p:sp>
+      <p:sp>
+        <p:nvSpPr>
+          <p:cNvPr id="24" name="Shape 18"/>
+          <p:cNvSpPr/>
+          <p:nvPr/>
+        </p:nvSpPr>
+        <p:spPr>
+          <a:xfrm>
+            <a:off x="6720840" y="1828800"/>
+            <a:ext cx="2423160" cy="932688"/>
+          </a:xfrm>
+          <a:prstGeom prst="roundRect">
+            <a:avLst>
+              <a:gd name="adj" fmla="val 7843"/>
             </a:avLst>
           </a:prstGeom>
           <a:solidFill>
@@ -2794,14 +2537,14 @@
       </p:sp>
       <p:sp>
         <p:nvSpPr>
-          <p:cNvPr id="12" name="Text 9"/>
-          <p:cNvSpPr/>
-          <p:nvPr/>
-        </p:nvSpPr>
-        <p:spPr>
-          <a:xfrm>
-            <a:off x="2615184" y="2432304"/>
-            <a:ext cx="1463040" cy="182880"/>
+          <p:cNvPr id="25" name="Text 19"/>
+          <p:cNvSpPr/>
+          <p:nvPr/>
+        </p:nvSpPr>
+        <p:spPr>
+          <a:xfrm>
+            <a:off x="6903720" y="1975104"/>
+            <a:ext cx="2057400" cy="182880"/>
           </a:xfrm>
           <a:prstGeom prst="rect">
             <a:avLst/>
@@ -2813,77 +2556,415 @@
           <a:bodyPr wrap="square" lIns="0" tIns="0" rIns="0" bIns="0" rtlCol="0" anchor="ctr"/>
           <a:lstStyle/>
           <a:p>
+            <a:pPr indent="0" marL="0">
+              <a:buNone/>
+            </a:pPr>
+            <a:r>
+              <a:rPr lang="en-US" sz="1000" b="1" dirty="0">
+                <a:solidFill>
+                  <a:srgbClr val="D8E2EE"/>
+                </a:solidFill>
+                <a:latin typeface="Arial" pitchFamily="34" charset="0"/>
+                <a:ea typeface="Arial" pitchFamily="34" charset="-122"/>
+                <a:cs typeface="Arial" pitchFamily="34" charset="-120"/>
+              </a:rPr>
+              <a:t>GHOST BONUS</a:t>
+            </a:r>
+            <a:endParaRPr lang="en-US" sz="1000" dirty="0"/>
+          </a:p>
+        </p:txBody>
+      </p:sp>
+      <p:pic>
+        <p:nvPicPr>
+          <p:cNvPr id="26" name="Image 4" descr="/Users/fengruiding/Desktop/cs520/project/ppt_3pages/images/ui_ghost_blue.png">    </p:cNvPr>
+          <p:cNvPicPr>
+            <a:picLocks noChangeAspect="1"/>
+          </p:cNvPicPr>
+          <p:nvPr/>
+        </p:nvPicPr>
+        <p:blipFill>
+          <a:blip r:embed="rId5"/>
+          <a:stretch>
+            <a:fillRect/>
+          </a:stretch>
+        </p:blipFill>
+        <p:spPr>
+          <a:xfrm>
+            <a:off x="7804404" y="2185416"/>
+            <a:ext cx="256032" cy="256032"/>
+          </a:xfrm>
+          <a:prstGeom prst="rect">
+            <a:avLst/>
+          </a:prstGeom>
+        </p:spPr>
+      </p:pic>
+      <p:sp>
+        <p:nvSpPr>
+          <p:cNvPr id="27" name="Text 20"/>
+          <p:cNvSpPr/>
+          <p:nvPr/>
+        </p:nvSpPr>
+        <p:spPr>
+          <a:xfrm>
+            <a:off x="6867144" y="2478024"/>
+            <a:ext cx="2130552" cy="146304"/>
+          </a:xfrm>
+          <a:prstGeom prst="rect">
+            <a:avLst/>
+          </a:prstGeom>
+          <a:noFill/>
+          <a:ln/>
+        </p:spPr>
+        <p:txBody>
+          <a:bodyPr wrap="square" lIns="0" tIns="0" rIns="0" bIns="0" rtlCol="0" anchor="ctr"/>
+          <a:lstStyle/>
+          <a:p>
             <a:pPr algn="ctr" indent="0" marL="0">
               <a:buNone/>
             </a:pPr>
             <a:r>
-              <a:rPr lang="en-US" sz="900" b="1" dirty="0">
-                <a:solidFill>
-                  <a:srgbClr val="D8E2EE"/>
-                </a:solidFill>
-                <a:latin typeface="Arial" pitchFamily="34" charset="0"/>
-                <a:ea typeface="Arial" pitchFamily="34" charset="-122"/>
-                <a:cs typeface="Arial" pitchFamily="34" charset="-120"/>
-              </a:rPr>
-              <a:t>FRUIT/GHOST</a:t>
-            </a:r>
-            <a:endParaRPr lang="en-US" sz="900" dirty="0"/>
-          </a:p>
-        </p:txBody>
-      </p:sp>
-      <p:sp>
-        <p:nvSpPr>
-          <p:cNvPr id="13" name="Text 10"/>
-          <p:cNvSpPr/>
-          <p:nvPr/>
-        </p:nvSpPr>
-        <p:spPr>
-          <a:xfrm>
-            <a:off x="2615184" y="2670048"/>
-            <a:ext cx="1463040" cy="219456"/>
-          </a:xfrm>
-          <a:prstGeom prst="rect">
-            <a:avLst/>
-          </a:prstGeom>
-          <a:noFill/>
-          <a:ln/>
-        </p:spPr>
-        <p:txBody>
-          <a:bodyPr wrap="square" lIns="0" tIns="0" rIns="0" bIns="0" rtlCol="0" anchor="ctr"/>
-          <a:lstStyle/>
-          <a:p>
-            <a:pPr algn="ctr" indent="0" marL="0">
-              <a:buNone/>
-            </a:pPr>
-            <a:r>
-              <a:rPr lang="en-US" sz="1100" b="1" dirty="0">
-                <a:solidFill>
-                  <a:srgbClr val="FFFFFF"/>
-                </a:solidFill>
-                <a:latin typeface="Arial" pitchFamily="34" charset="0"/>
-                <a:ea typeface="Arial" pitchFamily="34" charset="-122"/>
-                <a:cs typeface="Arial" pitchFamily="34" charset="-120"/>
-              </a:rPr>
-              <a:t>Bns/+200~1600</a:t>
-            </a:r>
-            <a:endParaRPr lang="en-US" sz="1100" dirty="0"/>
-          </a:p>
-        </p:txBody>
-      </p:sp>
-      <p:sp>
-        <p:nvSpPr>
-          <p:cNvPr id="14" name="Shape 11"/>
-          <p:cNvSpPr/>
-          <p:nvPr/>
-        </p:nvSpPr>
-        <p:spPr>
-          <a:xfrm>
-            <a:off x="4315968" y="2322576"/>
-            <a:ext cx="1737360" cy="658368"/>
+              <a:rPr lang="en-US" sz="1000" b="1" dirty="0">
+                <a:solidFill>
+                  <a:srgbClr val="FFFFFF"/>
+                </a:solidFill>
+                <a:latin typeface="Arial" pitchFamily="34" charset="0"/>
+                <a:ea typeface="Arial" pitchFamily="34" charset="-122"/>
+                <a:cs typeface="Arial" pitchFamily="34" charset="-120"/>
+              </a:rPr>
+              <a:t>+200 / +400 / +800 / +1600</a:t>
+            </a:r>
+            <a:endParaRPr lang="en-US" sz="1000" dirty="0"/>
+          </a:p>
+        </p:txBody>
+      </p:sp>
+      <p:sp>
+        <p:nvSpPr>
+          <p:cNvPr id="28" name="Shape 21"/>
+          <p:cNvSpPr/>
+          <p:nvPr/>
+        </p:nvSpPr>
+        <p:spPr>
+          <a:xfrm>
+            <a:off x="9326880" y="1828800"/>
+            <a:ext cx="2240280" cy="932688"/>
           </a:xfrm>
           <a:prstGeom prst="roundRect">
             <a:avLst>
-              <a:gd name="adj" fmla="val 11111"/>
+              <a:gd name="adj" fmla="val 7843"/>
+            </a:avLst>
+          </a:prstGeom>
+          <a:solidFill>
+            <a:srgbClr val="1A2030">
+              <a:alpha val="80000"/>
+            </a:srgbClr>
+          </a:solidFill>
+          <a:ln w="12700">
+            <a:solidFill>
+              <a:srgbClr val="D9E2EC"/>
+            </a:solidFill>
+            <a:prstDash val="solid"/>
+          </a:ln>
+        </p:spPr>
+      </p:sp>
+      <p:sp>
+        <p:nvSpPr>
+          <p:cNvPr id="29" name="Text 22"/>
+          <p:cNvSpPr/>
+          <p:nvPr/>
+        </p:nvSpPr>
+        <p:spPr>
+          <a:xfrm>
+            <a:off x="9509760" y="1975104"/>
+            <a:ext cx="1874520" cy="182880"/>
+          </a:xfrm>
+          <a:prstGeom prst="rect">
+            <a:avLst/>
+          </a:prstGeom>
+          <a:noFill/>
+          <a:ln/>
+        </p:spPr>
+        <p:txBody>
+          <a:bodyPr wrap="square" lIns="0" tIns="0" rIns="0" bIns="0" rtlCol="0" anchor="ctr"/>
+          <a:lstStyle/>
+          <a:p>
+            <a:pPr indent="0" marL="0">
+              <a:buNone/>
+            </a:pPr>
+            <a:r>
+              <a:rPr lang="en-US" sz="1000" b="1" dirty="0">
+                <a:solidFill>
+                  <a:srgbClr val="D8E2EE"/>
+                </a:solidFill>
+                <a:latin typeface="Arial" pitchFamily="34" charset="0"/>
+                <a:ea typeface="Arial" pitchFamily="34" charset="-122"/>
+                <a:cs typeface="Arial" pitchFamily="34" charset="-120"/>
+              </a:rPr>
+              <a:t>FRUIT</a:t>
+            </a:r>
+            <a:endParaRPr lang="en-US" sz="1000" dirty="0"/>
+          </a:p>
+        </p:txBody>
+      </p:sp>
+      <p:pic>
+        <p:nvPicPr>
+          <p:cNvPr id="30" name="Image 5" descr="/Users/fengruiding/Desktop/cs520/project/ppt_3pages/images/ui_fruit_cherries.png">    </p:cNvPr>
+          <p:cNvPicPr>
+            <a:picLocks noChangeAspect="1"/>
+          </p:cNvPicPr>
+          <p:nvPr/>
+        </p:nvPicPr>
+        <p:blipFill>
+          <a:blip r:embed="rId6"/>
+          <a:stretch>
+            <a:fillRect/>
+          </a:stretch>
+        </p:blipFill>
+        <p:spPr>
+          <a:xfrm>
+            <a:off x="10254996" y="2157984"/>
+            <a:ext cx="347472" cy="283464"/>
+          </a:xfrm>
+          <a:prstGeom prst="rect">
+            <a:avLst/>
+          </a:prstGeom>
+        </p:spPr>
+      </p:pic>
+      <p:sp>
+        <p:nvSpPr>
+          <p:cNvPr id="31" name="Text 23"/>
+          <p:cNvSpPr/>
+          <p:nvPr/>
+        </p:nvSpPr>
+        <p:spPr>
+          <a:xfrm>
+            <a:off x="9491472" y="2487168"/>
+            <a:ext cx="1911096" cy="182880"/>
+          </a:xfrm>
+          <a:prstGeom prst="rect">
+            <a:avLst/>
+          </a:prstGeom>
+          <a:noFill/>
+          <a:ln/>
+        </p:spPr>
+        <p:txBody>
+          <a:bodyPr wrap="square" lIns="0" tIns="0" rIns="0" bIns="0" rtlCol="0" anchor="ctr"/>
+          <a:lstStyle/>
+          <a:p>
+            <a:pPr algn="ctr" indent="0" marL="0">
+              <a:buNone/>
+            </a:pPr>
+            <a:r>
+              <a:rPr lang="en-US" sz="1600" b="1" dirty="0">
+                <a:solidFill>
+                  <a:srgbClr val="FFFFFF"/>
+                </a:solidFill>
+                <a:latin typeface="Arial" pitchFamily="34" charset="0"/>
+                <a:ea typeface="Arial" pitchFamily="34" charset="-122"/>
+                <a:cs typeface="Arial" pitchFamily="34" charset="-120"/>
+              </a:rPr>
+              <a:t>BONUS</a:t>
+            </a:r>
+            <a:endParaRPr lang="en-US" sz="1600" dirty="0"/>
+          </a:p>
+        </p:txBody>
+      </p:sp>
+      <p:sp>
+        <p:nvSpPr>
+          <p:cNvPr id="32" name="Shape 24"/>
+          <p:cNvSpPr/>
+          <p:nvPr/>
+        </p:nvSpPr>
+        <p:spPr>
+          <a:xfrm>
+            <a:off x="640080" y="2944368"/>
+            <a:ext cx="5440680" cy="2834640"/>
+          </a:xfrm>
+          <a:prstGeom prst="roundRect">
+            <a:avLst>
+              <a:gd name="adj" fmla="val 2581"/>
+            </a:avLst>
+          </a:prstGeom>
+          <a:solidFill>
+            <a:srgbClr val="1A2030">
+              <a:alpha val="80000"/>
+            </a:srgbClr>
+          </a:solidFill>
+          <a:ln w="12700">
+            <a:solidFill>
+              <a:srgbClr val="1E88E5"/>
+            </a:solidFill>
+            <a:prstDash val="solid"/>
+          </a:ln>
+        </p:spPr>
+      </p:sp>
+      <p:sp>
+        <p:nvSpPr>
+          <p:cNvPr id="33" name="Text 25"/>
+          <p:cNvSpPr/>
+          <p:nvPr/>
+        </p:nvSpPr>
+        <p:spPr>
+          <a:xfrm>
+            <a:off x="868680" y="3145536"/>
+            <a:ext cx="4983480" cy="274320"/>
+          </a:xfrm>
+          <a:prstGeom prst="rect">
+            <a:avLst/>
+          </a:prstGeom>
+          <a:noFill/>
+          <a:ln/>
+        </p:spPr>
+        <p:txBody>
+          <a:bodyPr wrap="square" lIns="0" tIns="0" rIns="0" bIns="0" rtlCol="0" anchor="ctr"/>
+          <a:lstStyle/>
+          <a:p>
+            <a:pPr indent="0" marL="0">
+              <a:buNone/>
+            </a:pPr>
+            <a:r>
+              <a:rPr lang="en-US" sz="1800" b="1" dirty="0">
+                <a:solidFill>
+                  <a:srgbClr val="FFFFFF"/>
+                </a:solidFill>
+                <a:latin typeface="Arial" pitchFamily="34" charset="0"/>
+                <a:ea typeface="Arial" pitchFamily="34" charset="-122"/>
+                <a:cs typeface="Arial" pitchFamily="34" charset="-120"/>
+              </a:rPr>
+              <a:t>Rules</a:t>
+            </a:r>
+            <a:endParaRPr lang="en-US" sz="1800" dirty="0"/>
+          </a:p>
+        </p:txBody>
+      </p:sp>
+      <p:sp>
+        <p:nvSpPr>
+          <p:cNvPr id="34" name="Shape 26"/>
+          <p:cNvSpPr/>
+          <p:nvPr/>
+        </p:nvSpPr>
+        <p:spPr>
+          <a:xfrm>
+            <a:off x="868680" y="3511296"/>
+            <a:ext cx="4983480" cy="0"/>
+          </a:xfrm>
+          <a:prstGeom prst="line">
+            <a:avLst/>
+          </a:prstGeom>
+          <a:noFill/>
+          <a:ln w="12700">
+            <a:solidFill>
+              <a:srgbClr val="1E88E5">
+                <a:alpha val="82000"/>
+              </a:srgbClr>
+            </a:solidFill>
+            <a:prstDash val="solid"/>
+          </a:ln>
+        </p:spPr>
+      </p:sp>
+      <p:sp>
+        <p:nvSpPr>
+          <p:cNvPr id="35" name="Text 27"/>
+          <p:cNvSpPr/>
+          <p:nvPr/>
+        </p:nvSpPr>
+        <p:spPr>
+          <a:xfrm>
+            <a:off x="868680" y="3694176"/>
+            <a:ext cx="4983480" cy="1901952"/>
+          </a:xfrm>
+          <a:prstGeom prst="rect">
+            <a:avLst/>
+          </a:prstGeom>
+          <a:noFill/>
+          <a:ln/>
+        </p:spPr>
+        <p:txBody>
+          <a:bodyPr wrap="square" lIns="0" tIns="0" rIns="0" bIns="0" rtlCol="0" anchor="t"/>
+          <a:lstStyle/>
+          <a:p>
+            <a:pPr indent="0" marL="0">
+              <a:buNone/>
+            </a:pPr>
+            <a:r>
+              <a:rPr lang="en-US" sz="1600" dirty="0">
+                <a:solidFill>
+                  <a:srgbClr val="FFFFFF"/>
+                </a:solidFill>
+                <a:latin typeface="Arial" pitchFamily="34" charset="0"/>
+                <a:ea typeface="Arial" pitchFamily="34" charset="-122"/>
+                <a:cs typeface="Arial" pitchFamily="34" charset="-120"/>
+              </a:rPr>
+              <a:t>• The player controls Pac-Man and clears the maze by eating all pellets and energizers.</a:t>
+            </a:r>
+            <a:endParaRPr lang="en-US" sz="1600" dirty="0"/>
+          </a:p>
+          <a:p>
+            <a:pPr indent="0" marL="0">
+              <a:buNone/>
+            </a:pPr>
+            <a:r>
+              <a:rPr lang="en-US" sz="1600" dirty="0">
+                <a:solidFill>
+                  <a:srgbClr val="FFFFFF"/>
+                </a:solidFill>
+                <a:latin typeface="Arial" pitchFamily="34" charset="0"/>
+                <a:ea typeface="Arial" pitchFamily="34" charset="-122"/>
+                <a:cs typeface="Arial" pitchFamily="34" charset="-120"/>
+              </a:rPr>
+              <a:t>• Pac-Man starts the game with 3 lives.</a:t>
+            </a:r>
+            <a:endParaRPr lang="en-US" sz="1600" dirty="0"/>
+          </a:p>
+          <a:p>
+            <a:pPr indent="0" marL="0">
+              <a:buNone/>
+            </a:pPr>
+            <a:r>
+              <a:rPr lang="en-US" sz="1600" dirty="0">
+                <a:solidFill>
+                  <a:srgbClr val="FFFFFF"/>
+                </a:solidFill>
+                <a:latin typeface="Arial" pitchFamily="34" charset="0"/>
+                <a:ea typeface="Arial" pitchFamily="34" charset="-122"/>
+                <a:cs typeface="Arial" pitchFamily="34" charset="-120"/>
+              </a:rPr>
+              <a:t>• Colliding with a normal ghost costs 1 life.</a:t>
+            </a:r>
+            <a:endParaRPr lang="en-US" sz="1600" dirty="0"/>
+          </a:p>
+          <a:p>
+            <a:pPr indent="0" marL="0">
+              <a:buNone/>
+            </a:pPr>
+            <a:r>
+              <a:rPr lang="en-US" sz="1600" dirty="0">
+                <a:solidFill>
+                  <a:srgbClr val="FFFFFF"/>
+                </a:solidFill>
+                <a:latin typeface="Arial" pitchFamily="34" charset="0"/>
+                <a:ea typeface="Arial" pitchFamily="34" charset="-122"/>
+                <a:cs typeface="Arial" pitchFamily="34" charset="-120"/>
+              </a:rPr>
+              <a:t>• The game ends when all 3 lives are lost.</a:t>
+            </a:r>
+            <a:endParaRPr lang="en-US" sz="1600" dirty="0"/>
+          </a:p>
+        </p:txBody>
+      </p:sp>
+      <p:sp>
+        <p:nvSpPr>
+          <p:cNvPr id="36" name="Shape 28"/>
+          <p:cNvSpPr/>
+          <p:nvPr/>
+        </p:nvSpPr>
+        <p:spPr>
+          <a:xfrm>
+            <a:off x="6291072" y="2944368"/>
+            <a:ext cx="5276088" cy="2834640"/>
+          </a:xfrm>
+          <a:prstGeom prst="roundRect">
+            <a:avLst>
+              <a:gd name="adj" fmla="val 2581"/>
             </a:avLst>
           </a:prstGeom>
           <a:solidFill>
@@ -2901,13 +2982,501 @@
       </p:sp>
       <p:sp>
         <p:nvSpPr>
-          <p:cNvPr id="15" name="Text 12"/>
-          <p:cNvSpPr/>
-          <p:nvPr/>
-        </p:nvSpPr>
-        <p:spPr>
-          <a:xfrm>
-            <a:off x="4453128" y="2432304"/>
+          <p:cNvPr id="37" name="Text 29"/>
+          <p:cNvSpPr/>
+          <p:nvPr/>
+        </p:nvSpPr>
+        <p:spPr>
+          <a:xfrm>
+            <a:off x="6519672" y="3145536"/>
+            <a:ext cx="4818888" cy="274320"/>
+          </a:xfrm>
+          <a:prstGeom prst="rect">
+            <a:avLst/>
+          </a:prstGeom>
+          <a:noFill/>
+          <a:ln/>
+        </p:spPr>
+        <p:txBody>
+          <a:bodyPr wrap="square" lIns="0" tIns="0" rIns="0" bIns="0" rtlCol="0" anchor="ctr"/>
+          <a:lstStyle/>
+          <a:p>
+            <a:pPr indent="0" marL="0">
+              <a:buNone/>
+            </a:pPr>
+            <a:r>
+              <a:rPr lang="en-US" sz="1800" b="1" dirty="0">
+                <a:solidFill>
+                  <a:srgbClr val="FFFFFF"/>
+                </a:solidFill>
+                <a:latin typeface="Arial" pitchFamily="34" charset="0"/>
+                <a:ea typeface="Arial" pitchFamily="34" charset="-122"/>
+                <a:cs typeface="Arial" pitchFamily="34" charset="-120"/>
+              </a:rPr>
+              <a:t>Scoring</a:t>
+            </a:r>
+            <a:endParaRPr lang="en-US" sz="1800" dirty="0"/>
+          </a:p>
+        </p:txBody>
+      </p:sp>
+      <p:sp>
+        <p:nvSpPr>
+          <p:cNvPr id="38" name="Shape 30"/>
+          <p:cNvSpPr/>
+          <p:nvPr/>
+        </p:nvSpPr>
+        <p:spPr>
+          <a:xfrm>
+            <a:off x="6519672" y="3511296"/>
+            <a:ext cx="4818888" cy="0"/>
+          </a:xfrm>
+          <a:prstGeom prst="line">
+            <a:avLst/>
+          </a:prstGeom>
+          <a:noFill/>
+          <a:ln w="12700">
+            <a:solidFill>
+              <a:srgbClr val="16A085">
+                <a:alpha val="82000"/>
+              </a:srgbClr>
+            </a:solidFill>
+            <a:prstDash val="solid"/>
+          </a:ln>
+        </p:spPr>
+      </p:sp>
+      <p:sp>
+        <p:nvSpPr>
+          <p:cNvPr id="39" name="Text 31"/>
+          <p:cNvSpPr/>
+          <p:nvPr/>
+        </p:nvSpPr>
+        <p:spPr>
+          <a:xfrm>
+            <a:off x="6519672" y="3694176"/>
+            <a:ext cx="4818888" cy="1901952"/>
+          </a:xfrm>
+          <a:prstGeom prst="rect">
+            <a:avLst/>
+          </a:prstGeom>
+          <a:noFill/>
+          <a:ln/>
+        </p:spPr>
+        <p:txBody>
+          <a:bodyPr wrap="square" lIns="0" tIns="0" rIns="0" bIns="0" rtlCol="0" anchor="t"/>
+          <a:lstStyle/>
+          <a:p>
+            <a:pPr indent="0" marL="0">
+              <a:buNone/>
+            </a:pPr>
+            <a:r>
+              <a:rPr lang="en-US" sz="1500" dirty="0">
+                <a:solidFill>
+                  <a:srgbClr val="FFFFFF"/>
+                </a:solidFill>
+                <a:latin typeface="Arial" pitchFamily="34" charset="0"/>
+                <a:ea typeface="Arial" pitchFamily="34" charset="-122"/>
+                <a:cs typeface="Arial" pitchFamily="34" charset="-120"/>
+              </a:rPr>
+              <a:t>• Eating a regular pellet gives +10 points.</a:t>
+            </a:r>
+            <a:endParaRPr lang="en-US" sz="1500" dirty="0"/>
+          </a:p>
+          <a:p>
+            <a:pPr indent="0" marL="0">
+              <a:buNone/>
+            </a:pPr>
+            <a:r>
+              <a:rPr lang="en-US" sz="1500" dirty="0">
+                <a:solidFill>
+                  <a:srgbClr val="FFFFFF"/>
+                </a:solidFill>
+                <a:latin typeface="Arial" pitchFamily="34" charset="0"/>
+                <a:ea typeface="Arial" pitchFamily="34" charset="-122"/>
+                <a:cs typeface="Arial" pitchFamily="34" charset="-120"/>
+              </a:rPr>
+              <a:t>• Eating an energizer gives +50 points and makes ghosts vulnerable for a limited time.</a:t>
+            </a:r>
+            <a:endParaRPr lang="en-US" sz="1500" dirty="0"/>
+          </a:p>
+          <a:p>
+            <a:pPr indent="0" marL="0">
+              <a:buNone/>
+            </a:pPr>
+            <a:r>
+              <a:rPr lang="en-US" sz="1500" dirty="0">
+                <a:solidFill>
+                  <a:srgbClr val="FFFFFF"/>
+                </a:solidFill>
+                <a:latin typeface="Arial" pitchFamily="34" charset="0"/>
+                <a:ea typeface="Arial" pitchFamily="34" charset="-122"/>
+                <a:cs typeface="Arial" pitchFamily="34" charset="-120"/>
+              </a:rPr>
+              <a:t>• Eating vulnerable ghosts gives increasing bonus rewards: +200 / +400 / +800 / +1600.</a:t>
+            </a:r>
+            <a:endParaRPr lang="en-US" sz="1500" dirty="0"/>
+          </a:p>
+          <a:p>
+            <a:pPr indent="0" marL="0">
+              <a:buNone/>
+            </a:pPr>
+            <a:r>
+              <a:rPr lang="en-US" sz="1500" dirty="0">
+                <a:solidFill>
+                  <a:srgbClr val="FFFFFF"/>
+                </a:solidFill>
+                <a:latin typeface="Arial" pitchFamily="34" charset="0"/>
+                <a:ea typeface="Arial" pitchFamily="34" charset="-122"/>
+                <a:cs typeface="Arial" pitchFamily="34" charset="-120"/>
+              </a:rPr>
+              <a:t>• Fruit appears at specific stages and gives bonus points when collected.</a:t>
+            </a:r>
+            <a:endParaRPr lang="en-US" sz="1500" dirty="0"/>
+          </a:p>
+        </p:txBody>
+      </p:sp>
+      <p:sp>
+        <p:nvSpPr>
+          <p:cNvPr id="40" name="Shape 32"/>
+          <p:cNvSpPr/>
+          <p:nvPr/>
+        </p:nvSpPr>
+        <p:spPr>
+          <a:xfrm>
+            <a:off x="640080" y="5943600"/>
+            <a:ext cx="10927080" cy="420624"/>
+          </a:xfrm>
+          <a:prstGeom prst="roundRect">
+            <a:avLst>
+              <a:gd name="adj" fmla="val 17391"/>
+            </a:avLst>
+          </a:prstGeom>
+          <a:solidFill>
+            <a:srgbClr val="1A2030">
+              <a:alpha val="80000"/>
+            </a:srgbClr>
+          </a:solidFill>
+          <a:ln w="12700">
+            <a:solidFill>
+              <a:srgbClr val="D9E2EC"/>
+            </a:solidFill>
+            <a:prstDash val="solid"/>
+          </a:ln>
+        </p:spPr>
+      </p:sp>
+      <p:sp>
+        <p:nvSpPr>
+          <p:cNvPr id="41" name="Text 33"/>
+          <p:cNvSpPr/>
+          <p:nvPr/>
+        </p:nvSpPr>
+        <p:spPr>
+          <a:xfrm>
+            <a:off x="896112" y="6108192"/>
+            <a:ext cx="10415016" cy="201168"/>
+          </a:xfrm>
+          <a:prstGeom prst="rect">
+            <a:avLst/>
+          </a:prstGeom>
+          <a:noFill/>
+          <a:ln/>
+        </p:spPr>
+        <p:txBody>
+          <a:bodyPr wrap="square" lIns="0" tIns="0" rIns="0" bIns="0" rtlCol="0" anchor="ctr"/>
+          <a:lstStyle/>
+          <a:p>
+            <a:pPr indent="0" marL="0">
+              <a:buNone/>
+            </a:pPr>
+            <a:r>
+              <a:rPr lang="en-US" sz="1400" dirty="0">
+                <a:solidFill>
+                  <a:srgbClr val="FFFFFF"/>
+                </a:solidFill>
+                <a:latin typeface="Arial" pitchFamily="34" charset="0"/>
+                <a:ea typeface="Arial" pitchFamily="34" charset="-122"/>
+                <a:cs typeface="Arial" pitchFamily="34" charset="-120"/>
+              </a:rPr>
+              <a:t>Core objective: score as much as possible while surviving long enough to clear the maze.</a:t>
+            </a:r>
+            <a:endParaRPr lang="en-US" sz="1400" dirty="0"/>
+          </a:p>
+        </p:txBody>
+      </p:sp>
+    </p:spTree>
+  </p:cSld>
+  <p:clrMapOvr>
+    <a:masterClrMapping/>
+  </p:clrMapOvr>
+</p:sld>
+</file>
+
+<file path=ppt/slides/slide3.xml><?xml version="1.0" encoding="utf-8"?>
+<p:sld xmlns:a="http://schemas.openxmlformats.org/drawingml/2006/main" xmlns:r="http://schemas.openxmlformats.org/officeDocument/2006/relationships" xmlns:p="http://schemas.openxmlformats.org/presentationml/2006/main">
+  <p:cSld name="Slide 3">
+    <p:bg>
+      <p:bgPr>
+        <a:solidFill>
+          <a:srgbClr val="FFFFFF"/>
+        </a:solidFill>
+      </p:bgPr>
+    </p:bg>
+    <p:spTree>
+      <p:nvGrpSpPr>
+        <p:cNvPr id="1" name=""/>
+        <p:cNvGrpSpPr/>
+        <p:nvPr/>
+      </p:nvGrpSpPr>
+      <p:grpSpPr>
+        <a:xfrm>
+          <a:off x="0" y="0"/>
+          <a:ext cx="0" cy="0"/>
+          <a:chOff x="0" y="0"/>
+          <a:chExt cx="0" cy="0"/>
+        </a:xfrm>
+      </p:grpSpPr>
+      <p:pic>
+        <p:nvPicPr>
+          <p:cNvPr id="2" name="Image 0" descr="/Users/fengruiding/Desktop/cs520/project/ppt_3pages/images/pacman_neon_bg.png">    </p:cNvPr>
+          <p:cNvPicPr>
+            <a:picLocks noChangeAspect="1"/>
+          </p:cNvPicPr>
+          <p:nvPr/>
+        </p:nvPicPr>
+        <p:blipFill>
+          <a:blip r:embed="rId1"/>
+          <a:stretch>
+            <a:fillRect/>
+          </a:stretch>
+        </p:blipFill>
+        <p:spPr>
+          <a:xfrm>
+            <a:off x="0" y="0"/>
+            <a:ext cx="12191695" cy="6858000"/>
+          </a:xfrm>
+          <a:prstGeom prst="rect">
+            <a:avLst/>
+          </a:prstGeom>
+        </p:spPr>
+      </p:pic>
+      <p:sp>
+        <p:nvSpPr>
+          <p:cNvPr id="3" name="Text 0"/>
+          <p:cNvSpPr/>
+          <p:nvPr/>
+        </p:nvSpPr>
+        <p:spPr>
+          <a:xfrm>
+            <a:off x="640080" y="493776"/>
+            <a:ext cx="8595360" cy="640080"/>
+          </a:xfrm>
+          <a:prstGeom prst="rect">
+            <a:avLst/>
+          </a:prstGeom>
+          <a:noFill/>
+          <a:ln/>
+        </p:spPr>
+        <p:txBody>
+          <a:bodyPr wrap="square" lIns="0" tIns="0" rIns="0" bIns="0" rtlCol="0" anchor="ctr"/>
+          <a:lstStyle/>
+          <a:p>
+            <a:pPr indent="0" marL="0">
+              <a:buNone/>
+            </a:pPr>
+            <a:r>
+              <a:rPr lang="en-US" sz="2400" b="1" dirty="0">
+                <a:solidFill>
+                  <a:srgbClr val="FFFFFF"/>
+                </a:solidFill>
+                <a:latin typeface="Arial" pitchFamily="34" charset="0"/>
+                <a:ea typeface="Arial" pitchFamily="34" charset="-122"/>
+                <a:cs typeface="Arial" pitchFamily="34" charset="-120"/>
+              </a:rPr>
+              <a:t>Q-Learning Update Rule (RL)</a:t>
+            </a:r>
+            <a:endParaRPr lang="en-US" sz="2400" dirty="0"/>
+          </a:p>
+        </p:txBody>
+      </p:sp>
+      <p:sp>
+        <p:nvSpPr>
+          <p:cNvPr id="4" name="Shape 1"/>
+          <p:cNvSpPr/>
+          <p:nvPr/>
+        </p:nvSpPr>
+        <p:spPr>
+          <a:xfrm>
+            <a:off x="640080" y="1170432"/>
+            <a:ext cx="10881360" cy="0"/>
+          </a:xfrm>
+          <a:prstGeom prst="line">
+            <a:avLst/>
+          </a:prstGeom>
+          <a:noFill/>
+          <a:ln w="12700">
+            <a:solidFill>
+              <a:srgbClr val="16A085">
+                <a:alpha val="72000"/>
+              </a:srgbClr>
+            </a:solidFill>
+            <a:prstDash val="solid"/>
+          </a:ln>
+        </p:spPr>
+      </p:sp>
+      <p:sp>
+        <p:nvSpPr>
+          <p:cNvPr id="5" name="Text 2"/>
+          <p:cNvSpPr/>
+          <p:nvPr/>
+        </p:nvSpPr>
+        <p:spPr>
+          <a:xfrm>
+            <a:off x="640080" y="1444752"/>
+            <a:ext cx="3383280" cy="201168"/>
+          </a:xfrm>
+          <a:prstGeom prst="rect">
+            <a:avLst/>
+          </a:prstGeom>
+          <a:noFill/>
+          <a:ln/>
+        </p:spPr>
+        <p:txBody>
+          <a:bodyPr wrap="square" lIns="0" tIns="0" rIns="0" bIns="0" rtlCol="0" anchor="ctr"/>
+          <a:lstStyle/>
+          <a:p>
+            <a:pPr indent="0" marL="0">
+              <a:buNone/>
+            </a:pPr>
+            <a:r>
+              <a:rPr lang="en-US" sz="1100" b="1" dirty="0">
+                <a:solidFill>
+                  <a:srgbClr val="D8E2EE"/>
+                </a:solidFill>
+                <a:latin typeface="Arial" pitchFamily="34" charset="0"/>
+                <a:ea typeface="Arial" pitchFamily="34" charset="-122"/>
+                <a:cs typeface="Arial" pitchFamily="34" charset="-120"/>
+              </a:rPr>
+              <a:t>Markov Decision Process (MDP)</a:t>
+            </a:r>
+            <a:endParaRPr lang="en-US" sz="1100" dirty="0"/>
+          </a:p>
+        </p:txBody>
+      </p:sp>
+      <p:sp>
+        <p:nvSpPr>
+          <p:cNvPr id="6" name="Text 3"/>
+          <p:cNvSpPr/>
+          <p:nvPr/>
+        </p:nvSpPr>
+        <p:spPr>
+          <a:xfrm>
+            <a:off x="640080" y="1664208"/>
+            <a:ext cx="10927080" cy="310896"/>
+          </a:xfrm>
+          <a:prstGeom prst="rect">
+            <a:avLst/>
+          </a:prstGeom>
+          <a:noFill/>
+          <a:ln/>
+        </p:spPr>
+        <p:txBody>
+          <a:bodyPr wrap="square" lIns="0" tIns="0" rIns="0" bIns="0" rtlCol="0" anchor="ctr"/>
+          <a:lstStyle/>
+          <a:p>
+            <a:pPr indent="0" marL="0">
+              <a:buNone/>
+            </a:pPr>
+            <a:r>
+              <a:rPr lang="en-US" sz="1700" b="1" dirty="0">
+                <a:solidFill>
+                  <a:srgbClr val="FFFFFF"/>
+                </a:solidFill>
+                <a:latin typeface="Arial" pitchFamily="34" charset="0"/>
+                <a:ea typeface="Arial" pitchFamily="34" charset="-122"/>
+                <a:cs typeface="Arial" pitchFamily="34" charset="-120"/>
+              </a:rPr>
+              <a:t>Q(s,a) ← Q(s,a) + α[r + γ max_a' Q(s',a') − Q(s,a)]</a:t>
+            </a:r>
+            <a:endParaRPr lang="en-US" sz="1700" dirty="0"/>
+          </a:p>
+        </p:txBody>
+      </p:sp>
+      <p:sp>
+        <p:nvSpPr>
+          <p:cNvPr id="7" name="Text 4"/>
+          <p:cNvSpPr/>
+          <p:nvPr/>
+        </p:nvSpPr>
+        <p:spPr>
+          <a:xfrm>
+            <a:off x="640080" y="1993392"/>
+            <a:ext cx="6583680" cy="201168"/>
+          </a:xfrm>
+          <a:prstGeom prst="rect">
+            <a:avLst/>
+          </a:prstGeom>
+          <a:noFill/>
+          <a:ln/>
+        </p:spPr>
+        <p:txBody>
+          <a:bodyPr wrap="square" lIns="0" tIns="0" rIns="0" bIns="0" rtlCol="0" anchor="ctr"/>
+          <a:lstStyle/>
+          <a:p>
+            <a:pPr indent="0" marL="0">
+              <a:buNone/>
+            </a:pPr>
+            <a:r>
+              <a:rPr lang="en-US" sz="1200" b="1" dirty="0">
+                <a:solidFill>
+                  <a:srgbClr val="D8E2EE"/>
+                </a:solidFill>
+                <a:latin typeface="Arial" pitchFamily="34" charset="0"/>
+                <a:ea typeface="Arial" pitchFamily="34" charset="-122"/>
+                <a:cs typeface="Arial" pitchFamily="34" charset="-120"/>
+              </a:rPr>
+              <a:t>How the formula updates action values from reward and future return</a:t>
+            </a:r>
+            <a:endParaRPr lang="en-US" sz="1200" dirty="0"/>
+          </a:p>
+        </p:txBody>
+      </p:sp>
+      <p:sp>
+        <p:nvSpPr>
+          <p:cNvPr id="8" name="Shape 5"/>
+          <p:cNvSpPr/>
+          <p:nvPr/>
+        </p:nvSpPr>
+        <p:spPr>
+          <a:xfrm>
+            <a:off x="640080" y="2322576"/>
+            <a:ext cx="1737360" cy="658368"/>
+          </a:xfrm>
+          <a:prstGeom prst="roundRect">
+            <a:avLst>
+              <a:gd name="adj" fmla="val 11111"/>
+            </a:avLst>
+          </a:prstGeom>
+          <a:solidFill>
+            <a:srgbClr val="1A2030">
+              <a:alpha val="80000"/>
+            </a:srgbClr>
+          </a:solidFill>
+          <a:ln w="12700">
+            <a:solidFill>
+              <a:srgbClr val="1E88E5"/>
+            </a:solidFill>
+            <a:prstDash val="solid"/>
+          </a:ln>
+        </p:spPr>
+      </p:sp>
+      <p:sp>
+        <p:nvSpPr>
+          <p:cNvPr id="9" name="Text 6"/>
+          <p:cNvSpPr/>
+          <p:nvPr/>
+        </p:nvSpPr>
+        <p:spPr>
+          <a:xfrm>
+            <a:off x="777240" y="2432304"/>
             <a:ext cx="1463040" cy="182880"/>
           </a:xfrm>
           <a:prstGeom prst="rect">
@@ -2932,7 +3501,7 @@
                 <a:ea typeface="Arial" pitchFamily="34" charset="-122"/>
                 <a:cs typeface="Arial" pitchFamily="34" charset="-120"/>
               </a:rPr>
-              <a:t>ESCAPE/CHASE</a:t>
+              <a:t>PELLET/E.</a:t>
             </a:r>
             <a:endParaRPr lang="en-US" sz="900" dirty="0"/>
           </a:p>
@@ -2940,13 +3509,13 @@
       </p:sp>
       <p:sp>
         <p:nvSpPr>
-          <p:cNvPr id="16" name="Text 13"/>
-          <p:cNvSpPr/>
-          <p:nvPr/>
-        </p:nvSpPr>
-        <p:spPr>
-          <a:xfrm>
-            <a:off x="4453128" y="2670048"/>
+          <p:cNvPr id="10" name="Text 7"/>
+          <p:cNvSpPr/>
+          <p:nvPr/>
+        </p:nvSpPr>
+        <p:spPr>
+          <a:xfrm>
+            <a:off x="777240" y="2670048"/>
             <a:ext cx="1463040" cy="219456"/>
           </a:xfrm>
           <a:prstGeom prst="rect">
@@ -2971,7 +3540,7 @@
                 <a:ea typeface="Arial" pitchFamily="34" charset="-122"/>
                 <a:cs typeface="Arial" pitchFamily="34" charset="-120"/>
               </a:rPr>
-              <a:t>+1.5/+3</a:t>
+              <a:t>+10/+50</a:t>
             </a:r>
             <a:endParaRPr lang="en-US" sz="1300" dirty="0"/>
           </a:p>
@@ -2979,13 +3548,120 @@
       </p:sp>
       <p:sp>
         <p:nvSpPr>
-          <p:cNvPr id="17" name="Shape 14"/>
-          <p:cNvSpPr/>
-          <p:nvPr/>
-        </p:nvSpPr>
-        <p:spPr>
-          <a:xfrm>
-            <a:off x="6153912" y="2322576"/>
+          <p:cNvPr id="11" name="Shape 8"/>
+          <p:cNvSpPr/>
+          <p:nvPr/>
+        </p:nvSpPr>
+        <p:spPr>
+          <a:xfrm>
+            <a:off x="2478024" y="2322576"/>
+            <a:ext cx="1737360" cy="658368"/>
+          </a:xfrm>
+          <a:prstGeom prst="roundRect">
+            <a:avLst>
+              <a:gd name="adj" fmla="val 11111"/>
+            </a:avLst>
+          </a:prstGeom>
+          <a:solidFill>
+            <a:srgbClr val="1A2030">
+              <a:alpha val="80000"/>
+            </a:srgbClr>
+          </a:solidFill>
+          <a:ln w="12700">
+            <a:solidFill>
+              <a:srgbClr val="F4B400"/>
+            </a:solidFill>
+            <a:prstDash val="solid"/>
+          </a:ln>
+        </p:spPr>
+      </p:sp>
+      <p:sp>
+        <p:nvSpPr>
+          <p:cNvPr id="12" name="Text 9"/>
+          <p:cNvSpPr/>
+          <p:nvPr/>
+        </p:nvSpPr>
+        <p:spPr>
+          <a:xfrm>
+            <a:off x="2615184" y="2432304"/>
+            <a:ext cx="1463040" cy="182880"/>
+          </a:xfrm>
+          <a:prstGeom prst="rect">
+            <a:avLst/>
+          </a:prstGeom>
+          <a:noFill/>
+          <a:ln/>
+        </p:spPr>
+        <p:txBody>
+          <a:bodyPr wrap="square" lIns="0" tIns="0" rIns="0" bIns="0" rtlCol="0" anchor="ctr"/>
+          <a:lstStyle/>
+          <a:p>
+            <a:pPr algn="ctr" indent="0" marL="0">
+              <a:buNone/>
+            </a:pPr>
+            <a:r>
+              <a:rPr lang="en-US" sz="900" b="1" dirty="0">
+                <a:solidFill>
+                  <a:srgbClr val="D8E2EE"/>
+                </a:solidFill>
+                <a:latin typeface="Arial" pitchFamily="34" charset="0"/>
+                <a:ea typeface="Arial" pitchFamily="34" charset="-122"/>
+                <a:cs typeface="Arial" pitchFamily="34" charset="-120"/>
+              </a:rPr>
+              <a:t>FRUIT/GHOST</a:t>
+            </a:r>
+            <a:endParaRPr lang="en-US" sz="900" dirty="0"/>
+          </a:p>
+        </p:txBody>
+      </p:sp>
+      <p:sp>
+        <p:nvSpPr>
+          <p:cNvPr id="13" name="Text 10"/>
+          <p:cNvSpPr/>
+          <p:nvPr/>
+        </p:nvSpPr>
+        <p:spPr>
+          <a:xfrm>
+            <a:off x="2615184" y="2670048"/>
+            <a:ext cx="1463040" cy="219456"/>
+          </a:xfrm>
+          <a:prstGeom prst="rect">
+            <a:avLst/>
+          </a:prstGeom>
+          <a:noFill/>
+          <a:ln/>
+        </p:spPr>
+        <p:txBody>
+          <a:bodyPr wrap="square" lIns="0" tIns="0" rIns="0" bIns="0" rtlCol="0" anchor="ctr"/>
+          <a:lstStyle/>
+          <a:p>
+            <a:pPr algn="ctr" indent="0" marL="0">
+              <a:buNone/>
+            </a:pPr>
+            <a:r>
+              <a:rPr lang="en-US" sz="1100" b="1" dirty="0">
+                <a:solidFill>
+                  <a:srgbClr val="FFFFFF"/>
+                </a:solidFill>
+                <a:latin typeface="Arial" pitchFamily="34" charset="0"/>
+                <a:ea typeface="Arial" pitchFamily="34" charset="-122"/>
+                <a:cs typeface="Arial" pitchFamily="34" charset="-120"/>
+              </a:rPr>
+              <a:t>Bns/+200~1600</a:t>
+            </a:r>
+            <a:endParaRPr lang="en-US" sz="1100" dirty="0"/>
+          </a:p>
+        </p:txBody>
+      </p:sp>
+      <p:sp>
+        <p:nvSpPr>
+          <p:cNvPr id="14" name="Shape 11"/>
+          <p:cNvSpPr/>
+          <p:nvPr/>
+        </p:nvSpPr>
+        <p:spPr>
+          <a:xfrm>
+            <a:off x="4315968" y="2322576"/>
             <a:ext cx="1737360" cy="658368"/>
           </a:xfrm>
           <a:prstGeom prst="roundRect">
@@ -3008,6 +3684,113 @@
       </p:sp>
       <p:sp>
         <p:nvSpPr>
+          <p:cNvPr id="15" name="Text 12"/>
+          <p:cNvSpPr/>
+          <p:nvPr/>
+        </p:nvSpPr>
+        <p:spPr>
+          <a:xfrm>
+            <a:off x="4453128" y="2432304"/>
+            <a:ext cx="1463040" cy="182880"/>
+          </a:xfrm>
+          <a:prstGeom prst="rect">
+            <a:avLst/>
+          </a:prstGeom>
+          <a:noFill/>
+          <a:ln/>
+        </p:spPr>
+        <p:txBody>
+          <a:bodyPr wrap="square" lIns="0" tIns="0" rIns="0" bIns="0" rtlCol="0" anchor="ctr"/>
+          <a:lstStyle/>
+          <a:p>
+            <a:pPr algn="ctr" indent="0" marL="0">
+              <a:buNone/>
+            </a:pPr>
+            <a:r>
+              <a:rPr lang="en-US" sz="900" b="1" dirty="0">
+                <a:solidFill>
+                  <a:srgbClr val="D8E2EE"/>
+                </a:solidFill>
+                <a:latin typeface="Arial" pitchFamily="34" charset="0"/>
+                <a:ea typeface="Arial" pitchFamily="34" charset="-122"/>
+                <a:cs typeface="Arial" pitchFamily="34" charset="-120"/>
+              </a:rPr>
+              <a:t>ESCAPE/CHASE</a:t>
+            </a:r>
+            <a:endParaRPr lang="en-US" sz="900" dirty="0"/>
+          </a:p>
+        </p:txBody>
+      </p:sp>
+      <p:sp>
+        <p:nvSpPr>
+          <p:cNvPr id="16" name="Text 13"/>
+          <p:cNvSpPr/>
+          <p:nvPr/>
+        </p:nvSpPr>
+        <p:spPr>
+          <a:xfrm>
+            <a:off x="4453128" y="2670048"/>
+            <a:ext cx="1463040" cy="219456"/>
+          </a:xfrm>
+          <a:prstGeom prst="rect">
+            <a:avLst/>
+          </a:prstGeom>
+          <a:noFill/>
+          <a:ln/>
+        </p:spPr>
+        <p:txBody>
+          <a:bodyPr wrap="square" lIns="0" tIns="0" rIns="0" bIns="0" rtlCol="0" anchor="ctr"/>
+          <a:lstStyle/>
+          <a:p>
+            <a:pPr algn="ctr" indent="0" marL="0">
+              <a:buNone/>
+            </a:pPr>
+            <a:r>
+              <a:rPr lang="en-US" sz="1300" b="1" dirty="0">
+                <a:solidFill>
+                  <a:srgbClr val="FFFFFF"/>
+                </a:solidFill>
+                <a:latin typeface="Arial" pitchFamily="34" charset="0"/>
+                <a:ea typeface="Arial" pitchFamily="34" charset="-122"/>
+                <a:cs typeface="Arial" pitchFamily="34" charset="-120"/>
+              </a:rPr>
+              <a:t>+1.5/+3</a:t>
+            </a:r>
+            <a:endParaRPr lang="en-US" sz="1300" dirty="0"/>
+          </a:p>
+        </p:txBody>
+      </p:sp>
+      <p:sp>
+        <p:nvSpPr>
+          <p:cNvPr id="17" name="Shape 14"/>
+          <p:cNvSpPr/>
+          <p:nvPr/>
+        </p:nvSpPr>
+        <p:spPr>
+          <a:xfrm>
+            <a:off x="6153912" y="2322576"/>
+            <a:ext cx="1737360" cy="658368"/>
+          </a:xfrm>
+          <a:prstGeom prst="roundRect">
+            <a:avLst>
+              <a:gd name="adj" fmla="val 11111"/>
+            </a:avLst>
+          </a:prstGeom>
+          <a:solidFill>
+            <a:srgbClr val="1A2030">
+              <a:alpha val="80000"/>
+            </a:srgbClr>
+          </a:solidFill>
+          <a:ln w="12700">
+            <a:solidFill>
+              <a:srgbClr val="16A085"/>
+            </a:solidFill>
+            <a:prstDash val="solid"/>
+          </a:ln>
+        </p:spPr>
+      </p:sp>
+      <p:sp>
+        <p:nvSpPr>
           <p:cNvPr id="18" name="Text 15"/>
           <p:cNvSpPr/>
           <p:nvPr/>
@@ -3855,9 +4638,9 @@
 </p:sld>
 </file>
 
-<file path=ppt/slides/slide3.xml><?xml version="1.0" encoding="utf-8"?>
+<file path=ppt/slides/slide4.xml><?xml version="1.0" encoding="utf-8"?>
 <p:sld xmlns:a="http://schemas.openxmlformats.org/drawingml/2006/main" xmlns:r="http://schemas.openxmlformats.org/officeDocument/2006/relationships" xmlns:p="http://schemas.openxmlformats.org/presentationml/2006/main">
-  <p:cSld name="Slide 3">
+  <p:cSld name="Slide 4">
     <p:bg>
       <p:bgPr>
         <a:solidFill>

</xml_diff>